<commit_message>
docs(team): cue deck without the cover or timing labels
</commit_message>
<xml_diff>
--- a/team/CUE_DECK_4min10_to_6min.pptx
+++ b/team/CUE_DECK_4min10_to_6min.pptx
@@ -12,7 +12,6 @@
     <p:sldId id="260" r:id="rId11"/>
     <p:sldId id="261" r:id="rId12"/>
     <p:sldId id="262" r:id="rId13"/>
-    <p:sldId id="263" r:id="rId14"/>
   </p:sldIdLst>
   <p:sldSz cx="12191695" cy="6858000" type="screen4x3"/>
   <p:notesSz cx="6858000" cy="9144000"/>
@@ -3104,13 +3103,13 @@
         <p:spPr>
           <a:xfrm>
             <a:off x="0" y="0"/>
-            <a:ext cx="12191695" cy="6858000"/>
+            <a:ext cx="12191695" cy="201168"/>
           </a:xfrm>
           <a:prstGeom prst="rect">
             <a:avLst/>
           </a:prstGeom>
           <a:solidFill>
-            <a:srgbClr val="3F4A26"/>
+            <a:srgbClr val="6F8140"/>
           </a:solidFill>
           <a:ln>
             <a:noFill/>
@@ -3146,8 +3145,8 @@
         </p:nvSpPr>
         <p:spPr>
           <a:xfrm>
-            <a:off x="822960" y="1371600"/>
-            <a:ext cx="10515600" cy="548640"/>
+            <a:off x="548640" y="502920"/>
+            <a:ext cx="11155680" cy="822960"/>
           </a:xfrm>
           <a:prstGeom prst="rect">
             <a:avLst/>
@@ -3162,27 +3161,72 @@
           <a:p>
             <a:pPr algn="l"/>
             <a:r>
-              <a:rPr sz="1600" b="1">
-                <a:solidFill>
-                  <a:srgbClr val="C9D4A9"/>
-                </a:solidFill>
-                <a:latin typeface="Arial"/>
-              </a:rPr>
-              <a:t>SKILLRADAR MY  ·  SDC 2026  ·  DOMAIN 1</a:t>
-            </a:r>
-          </a:p>
-        </p:txBody>
-      </p:sp>
-      <p:sp>
-        <p:nvSpPr>
-          <p:cNvPr id="4" name="TextBox 3"/>
+              <a:rPr sz="3200" b="1">
+                <a:solidFill>
+                  <a:srgbClr val="3F4A26"/>
+                </a:solidFill>
+                <a:latin typeface="Arial"/>
+              </a:rPr>
+              <a:t>Where the data comes from</a:t>
+            </a:r>
+          </a:p>
+        </p:txBody>
+      </p:sp>
+      <p:sp>
+        <p:nvSpPr>
+          <p:cNvPr id="4" name="Rectangle 3"/>
+          <p:cNvSpPr/>
+          <p:nvPr/>
+        </p:nvSpPr>
+        <p:spPr>
+          <a:xfrm>
+            <a:off x="548640" y="1600200"/>
+            <a:ext cx="5029200" cy="2971800"/>
+          </a:xfrm>
+          <a:prstGeom prst="rect">
+            <a:avLst/>
+          </a:prstGeom>
+          <a:solidFill>
+            <a:srgbClr val="F2F5E9"/>
+          </a:solidFill>
+          <a:ln>
+            <a:solidFill>
+              <a:srgbClr val="D8DFCA"/>
+            </a:solidFill>
+          </a:ln>
+        </p:spPr>
+        <p:style>
+          <a:lnRef idx="1">
+            <a:schemeClr val="accent1"/>
+          </a:lnRef>
+          <a:fillRef idx="3">
+            <a:schemeClr val="accent1"/>
+          </a:fillRef>
+          <a:effectRef idx="2">
+            <a:schemeClr val="accent1"/>
+          </a:effectRef>
+          <a:fontRef idx="minor">
+            <a:schemeClr val="lt1"/>
+          </a:fontRef>
+        </p:style>
+        <p:txBody>
+          <a:bodyPr rtlCol="0" anchor="ctr"/>
+          <a:lstStyle/>
+          <a:p>
+            <a:pPr algn="ctr"/>
+          </a:p>
+        </p:txBody>
+      </p:sp>
+      <p:sp>
+        <p:nvSpPr>
+          <p:cNvPr id="5" name="TextBox 4"/>
           <p:cNvSpPr txBox="1"/>
           <p:nvPr/>
         </p:nvSpPr>
         <p:spPr>
           <a:xfrm>
-            <a:off x="822960" y="2011680"/>
-            <a:ext cx="10515600" cy="2011680"/>
+            <a:off x="777240" y="1755648"/>
+            <a:ext cx="4572000" cy="320040"/>
           </a:xfrm>
           <a:prstGeom prst="rect">
             <a:avLst/>
@@ -3197,28 +3241,27 @@
           <a:p>
             <a:pPr algn="l"/>
             <a:r>
-              <a:rPr sz="4600" b="1">
-                <a:solidFill>
-                  <a:srgbClr val="F2F5E9"/>
-                </a:solidFill>
-                <a:latin typeface="Arial"/>
-              </a:rPr>
-              <a:t>Demo video cue sheet
-4:10 to 6:00</a:t>
-            </a:r>
-          </a:p>
-        </p:txBody>
-      </p:sp>
-      <p:sp>
-        <p:nvSpPr>
-          <p:cNvPr id="5" name="TextBox 4"/>
+              <a:rPr sz="1100" b="1">
+                <a:solidFill>
+                  <a:srgbClr val="6B7560"/>
+                </a:solidFill>
+                <a:latin typeface="Arial"/>
+              </a:rPr>
+              <a:t>ON SCREEN</a:t>
+            </a:r>
+          </a:p>
+        </p:txBody>
+      </p:sp>
+      <p:sp>
+        <p:nvSpPr>
+          <p:cNvPr id="6" name="TextBox 5"/>
           <p:cNvSpPr txBox="1"/>
           <p:nvPr/>
         </p:nvSpPr>
         <p:spPr>
           <a:xfrm>
-            <a:off x="822960" y="4023360"/>
-            <a:ext cx="10058400" cy="1463040"/>
+            <a:off x="777240" y="2148840"/>
+            <a:ext cx="4572000" cy="2286000"/>
           </a:xfrm>
           <a:prstGeom prst="rect">
             <a:avLst/>
@@ -3231,30 +3274,95 @@
           </a:bodyPr>
           <a:lstStyle/>
           <a:p>
-            <a:pPr algn="l"/>
-            <a:r>
-              <a:rPr sz="1600" b="0">
-                <a:solidFill>
-                  <a:srgbClr val="DDE6C8"/>
-                </a:solidFill>
-                <a:latin typeface="Arial"/>
-              </a:rPr>
-              <a:t>One slide per beat. Left: what to show. Right: what to say.
-Every link opens the exact file on GitHub, so nothing has to be remembered.</a:t>
-            </a:r>
-          </a:p>
-        </p:txBody>
-      </p:sp>
-      <p:sp>
-        <p:nvSpPr>
-          <p:cNvPr id="6" name="TextBox 5"/>
+            <a:r>
+              <a:rPr sz="1600">
+                <a:solidFill>
+                  <a:srgbClr val="222A18"/>
+                </a:solidFill>
+                <a:latin typeface="Arial"/>
+              </a:rPr>
+              <a:t>· GitHub README, Data sources table</a:t>
+            </a:r>
+          </a:p>
+          <a:p>
+            <a:r>
+              <a:rPr sz="1600">
+                <a:solidFill>
+                  <a:srgbClr val="222A18"/>
+                </a:solidFill>
+                <a:latin typeface="Arial"/>
+              </a:rPr>
+              <a:t>· then data/trends/dosm_q2_2026.json</a:t>
+            </a:r>
+          </a:p>
+          <a:p>
+            <a:r>
+              <a:rPr sz="1600">
+                <a:solidFill>
+                  <a:srgbClr val="222A18"/>
+                </a:solidFill>
+                <a:latin typeface="Arial"/>
+              </a:rPr>
+              <a:t>· stop on source_url, latest_released, extraction_note</a:t>
+            </a:r>
+          </a:p>
+        </p:txBody>
+      </p:sp>
+      <p:sp>
+        <p:nvSpPr>
+          <p:cNvPr id="7" name="Rectangle 6"/>
+          <p:cNvSpPr/>
+          <p:nvPr/>
+        </p:nvSpPr>
+        <p:spPr>
+          <a:xfrm>
+            <a:off x="5897880" y="1600200"/>
+            <a:ext cx="5760720" cy="2971800"/>
+          </a:xfrm>
+          <a:prstGeom prst="rect">
+            <a:avLst/>
+          </a:prstGeom>
+          <a:solidFill>
+            <a:srgbClr val="FFFFFF"/>
+          </a:solidFill>
+          <a:ln>
+            <a:solidFill>
+              <a:srgbClr val="B7C98F"/>
+            </a:solidFill>
+          </a:ln>
+        </p:spPr>
+        <p:style>
+          <a:lnRef idx="1">
+            <a:schemeClr val="accent1"/>
+          </a:lnRef>
+          <a:fillRef idx="3">
+            <a:schemeClr val="accent1"/>
+          </a:fillRef>
+          <a:effectRef idx="2">
+            <a:schemeClr val="accent1"/>
+          </a:effectRef>
+          <a:fontRef idx="minor">
+            <a:schemeClr val="lt1"/>
+          </a:fontRef>
+        </p:style>
+        <p:txBody>
+          <a:bodyPr rtlCol="0" anchor="ctr"/>
+          <a:lstStyle/>
+          <a:p>
+            <a:pPr algn="ctr"/>
+          </a:p>
+        </p:txBody>
+      </p:sp>
+      <p:sp>
+        <p:nvSpPr>
+          <p:cNvPr id="8" name="TextBox 7"/>
           <p:cNvSpPr txBox="1"/>
           <p:nvPr/>
         </p:nvSpPr>
         <p:spPr>
           <a:xfrm>
-            <a:off x="822960" y="5760720"/>
-            <a:ext cx="10058400" cy="548640"/>
+            <a:off x="6126480" y="1755648"/>
+            <a:ext cx="5303520" cy="320040"/>
           </a:xfrm>
           <a:prstGeom prst="rect">
             <a:avLst/>
@@ -3269,13 +3377,230 @@
           <a:p>
             <a:pPr algn="l"/>
             <a:r>
-              <a:rPr sz="1400" b="1">
-                <a:solidFill>
-                  <a:srgbClr val="C9D4A9"/>
-                </a:solidFill>
-                <a:latin typeface="Arial"/>
-              </a:rPr>
-              <a:t>github.com/douyinlin/sdc2026-lumina-nusantara</a:t>
+              <a:rPr sz="1100" b="1">
+                <a:solidFill>
+                  <a:srgbClr val="5B7FA6"/>
+                </a:solidFill>
+                <a:latin typeface="Arial"/>
+              </a:rPr>
+              <a:t>SAY THIS</a:t>
+            </a:r>
+          </a:p>
+        </p:txBody>
+      </p:sp>
+      <p:sp>
+        <p:nvSpPr>
+          <p:cNvPr id="9" name="TextBox 8"/>
+          <p:cNvSpPr txBox="1"/>
+          <p:nvPr/>
+        </p:nvSpPr>
+        <p:spPr>
+          <a:xfrm>
+            <a:off x="6126480" y="2148840"/>
+            <a:ext cx="5303520" cy="2286000"/>
+          </a:xfrm>
+          <a:prstGeom prst="rect">
+            <a:avLst/>
+          </a:prstGeom>
+          <a:noFill/>
+        </p:spPr>
+        <p:txBody>
+          <a:bodyPr wrap="square">
+            <a:spAutoFit/>
+          </a:bodyPr>
+          <a:lstStyle/>
+          <a:p>
+            <a:r>
+              <a:rPr sz="1600" i="1">
+                <a:solidFill>
+                  <a:srgbClr val="222A18"/>
+                </a:solidFill>
+                <a:latin typeface="Arial"/>
+              </a:rPr>
+              <a:t>“Three sources, kept separate. DOSM publishes advertised vacancies by occupation - we transcribe the counts by hand and keep the link, the date and a note on what it cannot support, inside the JSON itself.”</a:t>
+            </a:r>
+          </a:p>
+        </p:txBody>
+      </p:sp>
+      <p:sp>
+        <p:nvSpPr>
+          <p:cNvPr id="10" name="TextBox 9"/>
+          <p:cNvSpPr txBox="1"/>
+          <p:nvPr/>
+        </p:nvSpPr>
+        <p:spPr>
+          <a:xfrm>
+            <a:off x="548640" y="4800600"/>
+            <a:ext cx="2743200" cy="274320"/>
+          </a:xfrm>
+          <a:prstGeom prst="rect">
+            <a:avLst/>
+          </a:prstGeom>
+          <a:noFill/>
+        </p:spPr>
+        <p:txBody>
+          <a:bodyPr wrap="square">
+            <a:spAutoFit/>
+          </a:bodyPr>
+          <a:lstStyle/>
+          <a:p>
+            <a:pPr algn="l"/>
+            <a:r>
+              <a:rPr sz="1000" b="1">
+                <a:solidFill>
+                  <a:srgbClr val="6B7560"/>
+                </a:solidFill>
+                <a:latin typeface="Arial"/>
+              </a:rPr>
+              <a:t>LINKS</a:t>
+            </a:r>
+          </a:p>
+        </p:txBody>
+      </p:sp>
+      <p:sp>
+        <p:nvSpPr>
+          <p:cNvPr id="11" name="TextBox 10"/>
+          <p:cNvSpPr txBox="1"/>
+          <p:nvPr/>
+        </p:nvSpPr>
+        <p:spPr>
+          <a:xfrm>
+            <a:off x="548640" y="5074920"/>
+            <a:ext cx="7589520" cy="1097280"/>
+          </a:xfrm>
+          <a:prstGeom prst="rect">
+            <a:avLst/>
+          </a:prstGeom>
+          <a:noFill/>
+        </p:spPr>
+        <p:txBody>
+          <a:bodyPr wrap="square">
+            <a:spAutoFit/>
+          </a:bodyPr>
+          <a:lstStyle/>
+          <a:p>
+            <a:r>
+              <a:rPr sz="1300">
+                <a:solidFill>
+                  <a:srgbClr val="5B7FA6"/>
+                </a:solidFill>
+                <a:latin typeface="Arial"/>
+                <a:hlinkClick r:id="rId2"/>
+              </a:rPr>
+              <a:t>README data sources</a:t>
+            </a:r>
+          </a:p>
+          <a:p>
+            <a:r>
+              <a:rPr sz="1300">
+                <a:solidFill>
+                  <a:srgbClr val="5B7FA6"/>
+                </a:solidFill>
+                <a:latin typeface="Arial"/>
+                <a:hlinkClick r:id="rId3"/>
+              </a:rPr>
+              <a:t>dosm_q2_2026.json</a:t>
+            </a:r>
+          </a:p>
+          <a:p>
+            <a:r>
+              <a:rPr sz="1300">
+                <a:solidFill>
+                  <a:srgbClr val="5B7FA6"/>
+                </a:solidFill>
+                <a:latin typeface="Arial"/>
+                <a:hlinkClick r:id="rId4"/>
+              </a:rPr>
+              <a:t>wef_future_jobs_2025.json</a:t>
+            </a:r>
+          </a:p>
+        </p:txBody>
+      </p:sp>
+      <p:sp>
+        <p:nvSpPr>
+          <p:cNvPr id="12" name="Rectangle 11"/>
+          <p:cNvSpPr/>
+          <p:nvPr/>
+        </p:nvSpPr>
+        <p:spPr>
+          <a:xfrm>
+            <a:off x="8366760" y="5029200"/>
+            <a:ext cx="3291840" cy="1051560"/>
+          </a:xfrm>
+          <a:prstGeom prst="rect">
+            <a:avLst/>
+          </a:prstGeom>
+          <a:solidFill>
+            <a:srgbClr val="FBF4E4"/>
+          </a:solidFill>
+          <a:ln>
+            <a:solidFill>
+              <a:srgbClr val="E6D3A8"/>
+            </a:solidFill>
+          </a:ln>
+        </p:spPr>
+        <p:style>
+          <a:lnRef idx="1">
+            <a:schemeClr val="accent1"/>
+          </a:lnRef>
+          <a:fillRef idx="3">
+            <a:schemeClr val="accent1"/>
+          </a:fillRef>
+          <a:effectRef idx="2">
+            <a:schemeClr val="accent1"/>
+          </a:effectRef>
+          <a:fontRef idx="minor">
+            <a:schemeClr val="lt1"/>
+          </a:fontRef>
+        </p:style>
+        <p:txBody>
+          <a:bodyPr rtlCol="0" anchor="ctr" wrap="square" lIns="109728"/>
+          <a:lstStyle/>
+          <a:p>
+            <a:pPr algn="ctr"/>
+            <a:r>
+              <a:rPr sz="1200">
+                <a:solidFill>
+                  <a:srgbClr val="7A5A1E"/>
+                </a:solidFill>
+                <a:latin typeface="Arial"/>
+              </a:rPr>
+              <a:t>Hold 2 seconds on extraction_note - it is the honesty proof.</a:t>
+            </a:r>
+          </a:p>
+        </p:txBody>
+      </p:sp>
+      <p:sp>
+        <p:nvSpPr>
+          <p:cNvPr id="13" name="TextBox 12"/>
+          <p:cNvSpPr txBox="1"/>
+          <p:nvPr/>
+        </p:nvSpPr>
+        <p:spPr>
+          <a:xfrm>
+            <a:off x="548640" y="6400800"/>
+            <a:ext cx="11155680" cy="274320"/>
+          </a:xfrm>
+          <a:prstGeom prst="rect">
+            <a:avLst/>
+          </a:prstGeom>
+          <a:noFill/>
+        </p:spPr>
+        <p:txBody>
+          <a:bodyPr wrap="square">
+            <a:spAutoFit/>
+          </a:bodyPr>
+          <a:lstStyle/>
+          <a:p>
+            <a:pPr algn="l"/>
+            <a:r>
+              <a:rPr sz="900" b="0">
+                <a:solidFill>
+                  <a:srgbClr val="6B7560"/>
+                </a:solidFill>
+                <a:latin typeface="Arial"/>
+              </a:rPr>
+              <a:t>SkillRadar MY · Lumina Nusantara · SDC 2026</a:t>
             </a:r>
           </a:p>
         </p:txBody>
@@ -3349,8 +3674,8 @@
         </p:nvSpPr>
         <p:spPr>
           <a:xfrm>
-            <a:off x="548640" y="411480"/>
-            <a:ext cx="11155680" cy="411480"/>
+            <a:off x="548640" y="502920"/>
+            <a:ext cx="11155680" cy="822960"/>
           </a:xfrm>
           <a:prstGeom prst="rect">
             <a:avLst/>
@@ -3365,62 +3690,27 @@
           <a:p>
             <a:pPr algn="l"/>
             <a:r>
-              <a:rPr sz="1500" b="1">
-                <a:solidFill>
-                  <a:srgbClr val="6F8140"/>
-                </a:solidFill>
-                <a:latin typeface="Arial"/>
-              </a:rPr>
-              <a:t>4:10 - 4:20</a:t>
-            </a:r>
-          </a:p>
-        </p:txBody>
-      </p:sp>
-      <p:sp>
-        <p:nvSpPr>
-          <p:cNvPr id="4" name="TextBox 3"/>
-          <p:cNvSpPr txBox="1"/>
-          <p:nvPr/>
-        </p:nvSpPr>
-        <p:spPr>
-          <a:xfrm>
-            <a:off x="548640" y="822960"/>
-            <a:ext cx="11155680" cy="822960"/>
-          </a:xfrm>
-          <a:prstGeom prst="rect">
-            <a:avLst/>
-          </a:prstGeom>
-          <a:noFill/>
-        </p:spPr>
-        <p:txBody>
-          <a:bodyPr wrap="square">
-            <a:spAutoFit/>
-          </a:bodyPr>
-          <a:lstStyle/>
-          <a:p>
-            <a:pPr algn="l"/>
-            <a:r>
-              <a:rPr sz="3000" b="1">
+              <a:rPr sz="3200" b="1">
                 <a:solidFill>
                   <a:srgbClr val="3F4A26"/>
                 </a:solidFill>
                 <a:latin typeface="Arial"/>
               </a:rPr>
-              <a:t>Where the data comes from</a:t>
-            </a:r>
-          </a:p>
-        </p:txBody>
-      </p:sp>
-      <p:sp>
-        <p:nvSpPr>
-          <p:cNvPr id="5" name="Rectangle 4"/>
+              <a:t>What the program does, what the AI does</a:t>
+            </a:r>
+          </a:p>
+        </p:txBody>
+      </p:sp>
+      <p:sp>
+        <p:nvSpPr>
+          <p:cNvPr id="4" name="Rectangle 3"/>
           <p:cNvSpPr/>
           <p:nvPr/>
         </p:nvSpPr>
         <p:spPr>
           <a:xfrm>
-            <a:off x="548640" y="1874519"/>
-            <a:ext cx="5029200" cy="2788920"/>
+            <a:off x="548640" y="1600200"/>
+            <a:ext cx="5029200" cy="2971800"/>
           </a:xfrm>
           <a:prstGeom prst="rect">
             <a:avLst/>
@@ -3458,13 +3748,13 @@
       </p:sp>
       <p:sp>
         <p:nvSpPr>
-          <p:cNvPr id="6" name="TextBox 5"/>
+          <p:cNvPr id="5" name="TextBox 4"/>
           <p:cNvSpPr txBox="1"/>
           <p:nvPr/>
         </p:nvSpPr>
         <p:spPr>
           <a:xfrm>
-            <a:off x="777240" y="2011680"/>
+            <a:off x="777240" y="1755648"/>
             <a:ext cx="4572000" cy="320040"/>
           </a:xfrm>
           <a:prstGeom prst="rect">
@@ -3493,14 +3783,14 @@
       </p:sp>
       <p:sp>
         <p:nvSpPr>
-          <p:cNvPr id="7" name="TextBox 6"/>
+          <p:cNvPr id="6" name="TextBox 5"/>
           <p:cNvSpPr txBox="1"/>
           <p:nvPr/>
         </p:nvSpPr>
         <p:spPr>
           <a:xfrm>
-            <a:off x="777240" y="2377440"/>
-            <a:ext cx="4572000" cy="2103120"/>
+            <a:off x="777240" y="2148840"/>
+            <a:ext cx="4572000" cy="2286000"/>
           </a:xfrm>
           <a:prstGeom prst="rect">
             <a:avLst/>
@@ -3514,49 +3804,38 @@
           <a:lstStyle/>
           <a:p>
             <a:r>
-              <a:rPr sz="1500">
+              <a:rPr sz="1600">
                 <a:solidFill>
                   <a:srgbClr val="222A18"/>
                 </a:solidFill>
                 <a:latin typeface="Arial"/>
               </a:rPr>
-              <a:t>· GitHub README, Data sources table</a:t>
-            </a:r>
-          </a:p>
-          <a:p>
-            <a:r>
-              <a:rPr sz="1500">
+              <a:t>· App results page - point at the score</a:t>
+            </a:r>
+          </a:p>
+          <a:p>
+            <a:r>
+              <a:rPr sz="1600">
                 <a:solidFill>
                   <a:srgbClr val="222A18"/>
                 </a:solidFill>
                 <a:latin typeface="Arial"/>
               </a:rPr>
-              <a:t>· then data/trends/dosm_q2_2026.json</a:t>
-            </a:r>
-          </a:p>
-          <a:p>
-            <a:r>
-              <a:rPr sz="1500">
-                <a:solidFill>
-                  <a:srgbClr val="222A18"/>
-                </a:solidFill>
-                <a:latin typeface="Arial"/>
-              </a:rPr>
-              <a:t>· stop on source_url, latest_released, extraction_note</a:t>
-            </a:r>
-          </a:p>
-        </p:txBody>
-      </p:sp>
-      <p:sp>
-        <p:nvSpPr>
-          <p:cNvPr id="8" name="Rectangle 7"/>
+              <a:t>· then src/utils.py - the scoring function</a:t>
+            </a:r>
+          </a:p>
+        </p:txBody>
+      </p:sp>
+      <p:sp>
+        <p:nvSpPr>
+          <p:cNvPr id="7" name="Rectangle 6"/>
           <p:cNvSpPr/>
           <p:nvPr/>
         </p:nvSpPr>
         <p:spPr>
           <a:xfrm>
-            <a:off x="5897880" y="1874519"/>
-            <a:ext cx="5760720" cy="2788920"/>
+            <a:off x="5897880" y="1600200"/>
+            <a:ext cx="5760720" cy="2971800"/>
           </a:xfrm>
           <a:prstGeom prst="rect">
             <a:avLst/>
@@ -3594,13 +3873,13 @@
       </p:sp>
       <p:sp>
         <p:nvSpPr>
-          <p:cNvPr id="9" name="TextBox 8"/>
+          <p:cNvPr id="8" name="TextBox 7"/>
           <p:cNvSpPr txBox="1"/>
           <p:nvPr/>
         </p:nvSpPr>
         <p:spPr>
           <a:xfrm>
-            <a:off x="6126480" y="2011680"/>
+            <a:off x="6126480" y="1755648"/>
             <a:ext cx="5303520" cy="320040"/>
           </a:xfrm>
           <a:prstGeom prst="rect">
@@ -3629,14 +3908,14 @@
       </p:sp>
       <p:sp>
         <p:nvSpPr>
-          <p:cNvPr id="10" name="TextBox 9"/>
+          <p:cNvPr id="9" name="TextBox 8"/>
           <p:cNvSpPr txBox="1"/>
           <p:nvPr/>
         </p:nvSpPr>
         <p:spPr>
           <a:xfrm>
-            <a:off x="6126480" y="2377440"/>
-            <a:ext cx="5303520" cy="2148840"/>
+            <a:off x="6126480" y="2148840"/>
+            <a:ext cx="5303520" cy="2286000"/>
           </a:xfrm>
           <a:prstGeom prst="rect">
             <a:avLst/>
@@ -3650,26 +3929,26 @@
           <a:lstStyle/>
           <a:p>
             <a:r>
-              <a:rPr sz="1500" i="1">
+              <a:rPr sz="1600" i="1">
                 <a:solidFill>
                   <a:srgbClr val="222A18"/>
                 </a:solidFill>
                 <a:latin typeface="Arial"/>
               </a:rPr>
-              <a:t>“Three sources, kept separate. DOSM publishes advertised vacancies by occupation - we transcribe the counts by hand and keep the link, the date and a note on what it cannot support, inside the JSON itself.”</a:t>
-            </a:r>
-          </a:p>
-        </p:txBody>
-      </p:sp>
-      <p:sp>
-        <p:nvSpPr>
-          <p:cNvPr id="11" name="TextBox 10"/>
+              <a:t>“The running application has no model. Parsing is keyword matching, scoring is five weighted rules in this file, and the pathway is a lookup over a curated catalogue. Same profile, same answer, every time - and every point is explainable.”</a:t>
+            </a:r>
+          </a:p>
+        </p:txBody>
+      </p:sp>
+      <p:sp>
+        <p:nvSpPr>
+          <p:cNvPr id="10" name="TextBox 9"/>
           <p:cNvSpPr txBox="1"/>
           <p:nvPr/>
         </p:nvSpPr>
         <p:spPr>
           <a:xfrm>
-            <a:off x="548640" y="4846320"/>
+            <a:off x="548640" y="4800600"/>
             <a:ext cx="2743200" cy="274320"/>
           </a:xfrm>
           <a:prstGeom prst="rect">
@@ -3698,13 +3977,13 @@
       </p:sp>
       <p:sp>
         <p:nvSpPr>
-          <p:cNvPr id="12" name="TextBox 11"/>
+          <p:cNvPr id="11" name="TextBox 10"/>
           <p:cNvSpPr txBox="1"/>
           <p:nvPr/>
         </p:nvSpPr>
         <p:spPr>
           <a:xfrm>
-            <a:off x="548640" y="5120640"/>
+            <a:off x="548640" y="5074920"/>
             <a:ext cx="7589520" cy="1097280"/>
           </a:xfrm>
           <a:prstGeom prst="rect">
@@ -3719,52 +3998,52 @@
           <a:lstStyle/>
           <a:p>
             <a:r>
-              <a:rPr sz="1200">
+              <a:rPr sz="1300">
                 <a:solidFill>
                   <a:srgbClr val="5B7FA6"/>
                 </a:solidFill>
                 <a:latin typeface="Arial"/>
                 <a:hlinkClick r:id="rId2"/>
               </a:rPr>
-              <a:t>README data sources</a:t>
-            </a:r>
-          </a:p>
-          <a:p>
-            <a:r>
-              <a:rPr sz="1200">
+              <a:t>src/utils.py (scoring)</a:t>
+            </a:r>
+          </a:p>
+          <a:p>
+            <a:r>
+              <a:rPr sz="1300">
                 <a:solidFill>
                   <a:srgbClr val="5B7FA6"/>
                 </a:solidFill>
                 <a:latin typeface="Arial"/>
                 <a:hlinkClick r:id="rId3"/>
               </a:rPr>
-              <a:t>dosm_q2_2026.json</a:t>
-            </a:r>
-          </a:p>
-          <a:p>
-            <a:r>
-              <a:rPr sz="1200">
+              <a:t>src/cv.py (parsing)</a:t>
+            </a:r>
+          </a:p>
+          <a:p>
+            <a:r>
+              <a:rPr sz="1300">
                 <a:solidFill>
                   <a:srgbClr val="5B7FA6"/>
                 </a:solidFill>
                 <a:latin typeface="Arial"/>
                 <a:hlinkClick r:id="rId4"/>
               </a:rPr>
-              <a:t>wef_future_jobs_2025.json</a:t>
-            </a:r>
-          </a:p>
-        </p:txBody>
-      </p:sp>
-      <p:sp>
-        <p:nvSpPr>
-          <p:cNvPr id="13" name="Rectangle 12"/>
+              <a:t>src/trends.py</a:t>
+            </a:r>
+          </a:p>
+        </p:txBody>
+      </p:sp>
+      <p:sp>
+        <p:nvSpPr>
+          <p:cNvPr id="12" name="Rectangle 11"/>
           <p:cNvSpPr/>
           <p:nvPr/>
         </p:nvSpPr>
         <p:spPr>
           <a:xfrm>
-            <a:off x="8366760" y="5074920"/>
-            <a:ext cx="3291840" cy="1005840"/>
+            <a:off x="8366760" y="5029200"/>
+            <a:ext cx="3291840" cy="1051560"/>
           </a:xfrm>
           <a:prstGeom prst="rect">
             <a:avLst/>
@@ -3798,20 +4077,20 @@
           <a:p>
             <a:pPr algn="ctr"/>
             <a:r>
-              <a:rPr sz="1100">
+              <a:rPr sz="1200">
                 <a:solidFill>
                   <a:srgbClr val="7A5A1E"/>
                 </a:solidFill>
                 <a:latin typeface="Arial"/>
               </a:rPr>
-              <a:t>Hold 2 seconds on extraction_note - it is the honesty proof.</a:t>
-            </a:r>
-          </a:p>
-        </p:txBody>
-      </p:sp>
-      <p:sp>
-        <p:nvSpPr>
-          <p:cNvPr id="14" name="TextBox 13"/>
+              <a:t>Never say AI scores the user. AI is not on the request path.</a:t>
+            </a:r>
+          </a:p>
+        </p:txBody>
+      </p:sp>
+      <p:sp>
+        <p:nvSpPr>
+          <p:cNvPr id="13" name="TextBox 12"/>
           <p:cNvSpPr txBox="1"/>
           <p:nvPr/>
         </p:nvSpPr>
@@ -3913,8 +4192,8 @@
         </p:nvSpPr>
         <p:spPr>
           <a:xfrm>
-            <a:off x="548640" y="411480"/>
-            <a:ext cx="11155680" cy="411480"/>
+            <a:off x="548640" y="502920"/>
+            <a:ext cx="11155680" cy="822960"/>
           </a:xfrm>
           <a:prstGeom prst="rect">
             <a:avLst/>
@@ -3929,62 +4208,27 @@
           <a:p>
             <a:pPr algn="l"/>
             <a:r>
-              <a:rPr sz="1500" b="1">
-                <a:solidFill>
-                  <a:srgbClr val="6F8140"/>
-                </a:solidFill>
-                <a:latin typeface="Arial"/>
-              </a:rPr>
-              <a:t>4:20 - 4:35</a:t>
-            </a:r>
-          </a:p>
-        </p:txBody>
-      </p:sp>
-      <p:sp>
-        <p:nvSpPr>
-          <p:cNvPr id="4" name="TextBox 3"/>
-          <p:cNvSpPr txBox="1"/>
-          <p:nvPr/>
-        </p:nvSpPr>
-        <p:spPr>
-          <a:xfrm>
-            <a:off x="548640" y="822960"/>
-            <a:ext cx="11155680" cy="822960"/>
-          </a:xfrm>
-          <a:prstGeom prst="rect">
-            <a:avLst/>
-          </a:prstGeom>
-          <a:noFill/>
-        </p:spPr>
-        <p:txBody>
-          <a:bodyPr wrap="square">
-            <a:spAutoFit/>
-          </a:bodyPr>
-          <a:lstStyle/>
-          <a:p>
-            <a:pPr algn="l"/>
-            <a:r>
-              <a:rPr sz="3000" b="1">
+              <a:rPr sz="3200" b="1">
                 <a:solidFill>
                   <a:srgbClr val="3F4A26"/>
                 </a:solidFill>
                 <a:latin typeface="Arial"/>
               </a:rPr>
-              <a:t>What the program does, what the AI does</a:t>
-            </a:r>
-          </a:p>
-        </p:txBody>
-      </p:sp>
-      <p:sp>
-        <p:nvSpPr>
-          <p:cNvPr id="5" name="Rectangle 4"/>
+              <a:t>Where AI actually helped</a:t>
+            </a:r>
+          </a:p>
+        </p:txBody>
+      </p:sp>
+      <p:sp>
+        <p:nvSpPr>
+          <p:cNvPr id="4" name="Rectangle 3"/>
           <p:cNvSpPr/>
           <p:nvPr/>
         </p:nvSpPr>
         <p:spPr>
           <a:xfrm>
-            <a:off x="548640" y="1874519"/>
-            <a:ext cx="5029200" cy="2788920"/>
+            <a:off x="548640" y="1600200"/>
+            <a:ext cx="5029200" cy="2971800"/>
           </a:xfrm>
           <a:prstGeom prst="rect">
             <a:avLst/>
@@ -4022,13 +4266,13 @@
       </p:sp>
       <p:sp>
         <p:nvSpPr>
-          <p:cNvPr id="6" name="TextBox 5"/>
+          <p:cNvPr id="5" name="TextBox 4"/>
           <p:cNvSpPr txBox="1"/>
           <p:nvPr/>
         </p:nvSpPr>
         <p:spPr>
           <a:xfrm>
-            <a:off x="777240" y="2011680"/>
+            <a:off x="777240" y="1755648"/>
             <a:ext cx="4572000" cy="320040"/>
           </a:xfrm>
           <a:prstGeom prst="rect">
@@ -4057,14 +4301,14 @@
       </p:sp>
       <p:sp>
         <p:nvSpPr>
-          <p:cNvPr id="7" name="TextBox 6"/>
+          <p:cNvPr id="6" name="TextBox 5"/>
           <p:cNvSpPr txBox="1"/>
           <p:nvPr/>
         </p:nvSpPr>
         <p:spPr>
           <a:xfrm>
-            <a:off x="777240" y="2377440"/>
-            <a:ext cx="4572000" cy="2103120"/>
+            <a:off x="777240" y="2148840"/>
+            <a:ext cx="4572000" cy="2286000"/>
           </a:xfrm>
           <a:prstGeom prst="rect">
             <a:avLst/>
@@ -4078,38 +4322,49 @@
           <a:lstStyle/>
           <a:p>
             <a:r>
-              <a:rPr sz="1500">
+              <a:rPr sz="1600">
                 <a:solidFill>
                   <a:srgbClr val="222A18"/>
                 </a:solidFill>
                 <a:latin typeface="Arial"/>
               </a:rPr>
-              <a:t>· App results page - point at the score</a:t>
-            </a:r>
-          </a:p>
-          <a:p>
-            <a:r>
-              <a:rPr sz="1500">
+              <a:t>· Terminal, already cd'd into the repo</a:t>
+            </a:r>
+          </a:p>
+          <a:p>
+            <a:r>
+              <a:rPr sz="1600">
                 <a:solidFill>
                   <a:srgbClr val="222A18"/>
                 </a:solidFill>
                 <a:latin typeface="Arial"/>
               </a:rPr>
-              <a:t>· then src/utils.py - the scoring function</a:t>
-            </a:r>
-          </a:p>
-        </p:txBody>
-      </p:sp>
-      <p:sp>
-        <p:nvSpPr>
-          <p:cNvPr id="8" name="Rectangle 7"/>
+              <a:t>· python -m unittest discover -s tests -p "test_*.py"</a:t>
+            </a:r>
+          </a:p>
+          <a:p>
+            <a:r>
+              <a:rPr sz="1600">
+                <a:solidFill>
+                  <a:srgbClr val="222A18"/>
+                </a:solidFill>
+                <a:latin typeface="Arial"/>
+              </a:rPr>
+              <a:t>· let it finish: 54 tests, OK</a:t>
+            </a:r>
+          </a:p>
+        </p:txBody>
+      </p:sp>
+      <p:sp>
+        <p:nvSpPr>
+          <p:cNvPr id="7" name="Rectangle 6"/>
           <p:cNvSpPr/>
           <p:nvPr/>
         </p:nvSpPr>
         <p:spPr>
           <a:xfrm>
-            <a:off x="5897880" y="1874519"/>
-            <a:ext cx="5760720" cy="2788920"/>
+            <a:off x="5897880" y="1600200"/>
+            <a:ext cx="5760720" cy="2971800"/>
           </a:xfrm>
           <a:prstGeom prst="rect">
             <a:avLst/>
@@ -4147,13 +4402,13 @@
       </p:sp>
       <p:sp>
         <p:nvSpPr>
-          <p:cNvPr id="9" name="TextBox 8"/>
+          <p:cNvPr id="8" name="TextBox 7"/>
           <p:cNvSpPr txBox="1"/>
           <p:nvPr/>
         </p:nvSpPr>
         <p:spPr>
           <a:xfrm>
-            <a:off x="6126480" y="2011680"/>
+            <a:off x="6126480" y="1755648"/>
             <a:ext cx="5303520" cy="320040"/>
           </a:xfrm>
           <a:prstGeom prst="rect">
@@ -4182,14 +4437,14 @@
       </p:sp>
       <p:sp>
         <p:nvSpPr>
-          <p:cNvPr id="10" name="TextBox 9"/>
+          <p:cNvPr id="9" name="TextBox 8"/>
           <p:cNvSpPr txBox="1"/>
           <p:nvPr/>
         </p:nvSpPr>
         <p:spPr>
           <a:xfrm>
-            <a:off x="6126480" y="2377440"/>
-            <a:ext cx="5303520" cy="2148840"/>
+            <a:off x="6126480" y="2148840"/>
+            <a:ext cx="5303520" cy="2286000"/>
           </a:xfrm>
           <a:prstGeom prst="rect">
             <a:avLst/>
@@ -4203,26 +4458,26 @@
           <a:lstStyle/>
           <a:p>
             <a:r>
-              <a:rPr sz="1500" i="1">
+              <a:rPr sz="1600" i="1">
                 <a:solidFill>
                   <a:srgbClr val="222A18"/>
                 </a:solidFill>
                 <a:latin typeface="Arial"/>
               </a:rPr>
-              <a:t>“The running application has no model. Parsing is keyword matching, scoring is five weighted rules in this file, and the pathway is a lookup over a curated catalogue. Same profile, same answer, every time - and every point is explainable.”</a:t>
-            </a:r>
-          </a:p>
-        </p:txBody>
-      </p:sp>
-      <p:sp>
-        <p:nvSpPr>
-          <p:cNvPr id="11" name="TextBox 10"/>
+              <a:t>“AI tools were used to write this code - DeepSeek, Copilot, Codex. Every change was read, run and tested before it was kept: that run is 54 automated tests, all passing.”</a:t>
+            </a:r>
+          </a:p>
+        </p:txBody>
+      </p:sp>
+      <p:sp>
+        <p:nvSpPr>
+          <p:cNvPr id="10" name="TextBox 9"/>
           <p:cNvSpPr txBox="1"/>
           <p:nvPr/>
         </p:nvSpPr>
         <p:spPr>
           <a:xfrm>
-            <a:off x="548640" y="4846320"/>
+            <a:off x="548640" y="4800600"/>
             <a:ext cx="2743200" cy="274320"/>
           </a:xfrm>
           <a:prstGeom prst="rect">
@@ -4251,13 +4506,13 @@
       </p:sp>
       <p:sp>
         <p:nvSpPr>
-          <p:cNvPr id="12" name="TextBox 11"/>
+          <p:cNvPr id="11" name="TextBox 10"/>
           <p:cNvSpPr txBox="1"/>
           <p:nvPr/>
         </p:nvSpPr>
         <p:spPr>
           <a:xfrm>
-            <a:off x="548640" y="5120640"/>
+            <a:off x="548640" y="5074920"/>
             <a:ext cx="7589520" cy="1097280"/>
           </a:xfrm>
           <a:prstGeom prst="rect">
@@ -4272,52 +4527,40 @@
           <a:lstStyle/>
           <a:p>
             <a:r>
-              <a:rPr sz="1200">
+              <a:rPr sz="1300">
                 <a:solidFill>
                   <a:srgbClr val="5B7FA6"/>
                 </a:solidFill>
                 <a:latin typeface="Arial"/>
                 <a:hlinkClick r:id="rId2"/>
               </a:rPr>
-              <a:t>src/utils.py (scoring)</a:t>
-            </a:r>
-          </a:p>
-          <a:p>
-            <a:r>
-              <a:rPr sz="1200">
+              <a:t>tests folder</a:t>
+            </a:r>
+          </a:p>
+          <a:p>
+            <a:r>
+              <a:rPr sz="1300">
                 <a:solidFill>
                   <a:srgbClr val="5B7FA6"/>
                 </a:solidFill>
                 <a:latin typeface="Arial"/>
                 <a:hlinkClick r:id="rId3"/>
               </a:rPr>
-              <a:t>src/cv.py (parsing)</a:t>
-            </a:r>
-          </a:p>
-          <a:p>
-            <a:r>
-              <a:rPr sz="1200">
-                <a:solidFill>
-                  <a:srgbClr val="5B7FA6"/>
-                </a:solidFill>
-                <a:latin typeface="Arial"/>
-                <a:hlinkClick r:id="rId4"/>
-              </a:rPr>
-              <a:t>src/trends.py</a:t>
-            </a:r>
-          </a:p>
-        </p:txBody>
-      </p:sp>
-      <p:sp>
-        <p:nvSpPr>
-          <p:cNvPr id="13" name="Rectangle 12"/>
+              <a:t>Technical Declaration 4.3</a:t>
+            </a:r>
+          </a:p>
+        </p:txBody>
+      </p:sp>
+      <p:sp>
+        <p:nvSpPr>
+          <p:cNvPr id="12" name="Rectangle 11"/>
           <p:cNvSpPr/>
           <p:nvPr/>
         </p:nvSpPr>
         <p:spPr>
           <a:xfrm>
-            <a:off x="8366760" y="5074920"/>
-            <a:ext cx="3291840" cy="1005840"/>
+            <a:off x="8366760" y="5029200"/>
+            <a:ext cx="3291840" cy="1051560"/>
           </a:xfrm>
           <a:prstGeom prst="rect">
             <a:avLst/>
@@ -4351,20 +4594,20 @@
           <a:p>
             <a:pPr algn="ctr"/>
             <a:r>
-              <a:rPr sz="1100">
+              <a:rPr sz="1200">
                 <a:solidFill>
                   <a:srgbClr val="7A5A1E"/>
                 </a:solidFill>
                 <a:latin typeface="Arial"/>
               </a:rPr>
-              <a:t>Never say AI scores the user. AI is not on the request path.</a:t>
-            </a:r>
-          </a:p>
-        </p:txBody>
-      </p:sp>
-      <p:sp>
-        <p:nvSpPr>
-          <p:cNvPr id="14" name="TextBox 13"/>
+              <a:t>Clear the terminal first (cls). No personal paths on screen.</a:t>
+            </a:r>
+          </a:p>
+        </p:txBody>
+      </p:sp>
+      <p:sp>
+        <p:nvSpPr>
+          <p:cNvPr id="13" name="TextBox 12"/>
           <p:cNvSpPr txBox="1"/>
           <p:nvPr/>
         </p:nvSpPr>
@@ -4466,8 +4709,8 @@
         </p:nvSpPr>
         <p:spPr>
           <a:xfrm>
-            <a:off x="548640" y="411480"/>
-            <a:ext cx="11155680" cy="411480"/>
+            <a:off x="548640" y="502920"/>
+            <a:ext cx="11155680" cy="822960"/>
           </a:xfrm>
           <a:prstGeom prst="rect">
             <a:avLst/>
@@ -4482,62 +4725,27 @@
           <a:p>
             <a:pPr algn="l"/>
             <a:r>
-              <a:rPr sz="1500" b="1">
-                <a:solidFill>
-                  <a:srgbClr val="6F8140"/>
-                </a:solidFill>
-                <a:latin typeface="Arial"/>
-              </a:rPr>
-              <a:t>4:35 - 4:50</a:t>
-            </a:r>
-          </a:p>
-        </p:txBody>
-      </p:sp>
-      <p:sp>
-        <p:nvSpPr>
-          <p:cNvPr id="4" name="TextBox 3"/>
-          <p:cNvSpPr txBox="1"/>
-          <p:nvPr/>
-        </p:nvSpPr>
-        <p:spPr>
-          <a:xfrm>
-            <a:off x="548640" y="822960"/>
-            <a:ext cx="11155680" cy="822960"/>
-          </a:xfrm>
-          <a:prstGeom prst="rect">
-            <a:avLst/>
-          </a:prstGeom>
-          <a:noFill/>
-        </p:spPr>
-        <p:txBody>
-          <a:bodyPr wrap="square">
-            <a:spAutoFit/>
-          </a:bodyPr>
-          <a:lstStyle/>
-          <a:p>
-            <a:pPr algn="l"/>
-            <a:r>
-              <a:rPr sz="3000" b="1">
+              <a:rPr sz="3200" b="1">
                 <a:solidFill>
                   <a:srgbClr val="3F4A26"/>
                 </a:solidFill>
                 <a:latin typeface="Arial"/>
               </a:rPr>
-              <a:t>Where AI actually helped</a:t>
-            </a:r>
-          </a:p>
-        </p:txBody>
-      </p:sp>
-      <p:sp>
-        <p:nvSpPr>
-          <p:cNvPr id="5" name="Rectangle 4"/>
+              <a:t>Replit and RunPod</a:t>
+            </a:r>
+          </a:p>
+        </p:txBody>
+      </p:sp>
+      <p:sp>
+        <p:nvSpPr>
+          <p:cNvPr id="4" name="Rectangle 3"/>
           <p:cNvSpPr/>
           <p:nvPr/>
         </p:nvSpPr>
         <p:spPr>
           <a:xfrm>
-            <a:off x="548640" y="1874519"/>
-            <a:ext cx="5029200" cy="2788920"/>
+            <a:off x="548640" y="1600200"/>
+            <a:ext cx="5029200" cy="2971800"/>
           </a:xfrm>
           <a:prstGeom prst="rect">
             <a:avLst/>
@@ -4575,13 +4783,13 @@
       </p:sp>
       <p:sp>
         <p:nvSpPr>
-          <p:cNvPr id="6" name="TextBox 5"/>
+          <p:cNvPr id="5" name="TextBox 4"/>
           <p:cNvSpPr txBox="1"/>
           <p:nvPr/>
         </p:nvSpPr>
         <p:spPr>
           <a:xfrm>
-            <a:off x="777240" y="2011680"/>
+            <a:off x="777240" y="1755648"/>
             <a:ext cx="4572000" cy="320040"/>
           </a:xfrm>
           <a:prstGeom prst="rect">
@@ -4610,14 +4818,14 @@
       </p:sp>
       <p:sp>
         <p:nvSpPr>
-          <p:cNvPr id="7" name="TextBox 6"/>
+          <p:cNvPr id="6" name="TextBox 5"/>
           <p:cNvSpPr txBox="1"/>
           <p:nvPr/>
         </p:nvSpPr>
         <p:spPr>
           <a:xfrm>
-            <a:off x="777240" y="2377440"/>
-            <a:ext cx="4572000" cy="2103120"/>
+            <a:off x="777240" y="2148840"/>
+            <a:ext cx="4572000" cy="2286000"/>
           </a:xfrm>
           <a:prstGeom prst="rect">
             <a:avLst/>
@@ -4631,49 +4839,38 @@
           <a:lstStyle/>
           <a:p>
             <a:r>
-              <a:rPr sz="1500">
+              <a:rPr sz="1600">
                 <a:solidFill>
                   <a:srgbClr val="222A18"/>
                 </a:solidFill>
                 <a:latin typeface="Arial"/>
               </a:rPr>
-              <a:t>· Terminal, already cd'd into the repo</a:t>
-            </a:r>
-          </a:p>
-          <a:p>
-            <a:r>
-              <a:rPr sz="1500">
+              <a:t>· PDF viewer: submission/REPLIT PROOF OF USE.pdf</a:t>
+            </a:r>
+          </a:p>
+          <a:p>
+            <a:r>
+              <a:rPr sz="1600">
                 <a:solidFill>
                   <a:srgbClr val="222A18"/>
                 </a:solidFill>
                 <a:latin typeface="Arial"/>
               </a:rPr>
-              <a:t>· python -m unittest discover -s tests -p "test_*.py"</a:t>
-            </a:r>
-          </a:p>
-          <a:p>
-            <a:r>
-              <a:rPr sz="1500">
-                <a:solidFill>
-                  <a:srgbClr val="222A18"/>
-                </a:solidFill>
-                <a:latin typeface="Arial"/>
-              </a:rPr>
-              <a:t>· let it finish: 54 tests, OK</a:t>
-            </a:r>
-          </a:p>
-        </p:txBody>
-      </p:sp>
-      <p:sp>
-        <p:nvSpPr>
-          <p:cNvPr id="8" name="Rectangle 7"/>
+              <a:t>· scroll one page</a:t>
+            </a:r>
+          </a:p>
+        </p:txBody>
+      </p:sp>
+      <p:sp>
+        <p:nvSpPr>
+          <p:cNvPr id="7" name="Rectangle 6"/>
           <p:cNvSpPr/>
           <p:nvPr/>
         </p:nvSpPr>
         <p:spPr>
           <a:xfrm>
-            <a:off x="5897880" y="1874519"/>
-            <a:ext cx="5760720" cy="2788920"/>
+            <a:off x="5897880" y="1600200"/>
+            <a:ext cx="5760720" cy="2971800"/>
           </a:xfrm>
           <a:prstGeom prst="rect">
             <a:avLst/>
@@ -4711,13 +4908,13 @@
       </p:sp>
       <p:sp>
         <p:nvSpPr>
-          <p:cNvPr id="9" name="TextBox 8"/>
+          <p:cNvPr id="8" name="TextBox 7"/>
           <p:cNvSpPr txBox="1"/>
           <p:nvPr/>
         </p:nvSpPr>
         <p:spPr>
           <a:xfrm>
-            <a:off x="6126480" y="2011680"/>
+            <a:off x="6126480" y="1755648"/>
             <a:ext cx="5303520" cy="320040"/>
           </a:xfrm>
           <a:prstGeom prst="rect">
@@ -4746,14 +4943,14 @@
       </p:sp>
       <p:sp>
         <p:nvSpPr>
-          <p:cNvPr id="10" name="TextBox 9"/>
+          <p:cNvPr id="9" name="TextBox 8"/>
           <p:cNvSpPr txBox="1"/>
           <p:nvPr/>
         </p:nvSpPr>
         <p:spPr>
           <a:xfrm>
-            <a:off x="6126480" y="2377440"/>
-            <a:ext cx="5303520" cy="2148840"/>
+            <a:off x="6126480" y="2148840"/>
+            <a:ext cx="5303520" cy="2286000"/>
           </a:xfrm>
           <a:prstGeom prst="rect">
             <a:avLst/>
@@ -4767,26 +4964,26 @@
           <a:lstStyle/>
           <a:p>
             <a:r>
-              <a:rPr sz="1500" i="1">
+              <a:rPr sz="1600" i="1">
                 <a:solidFill>
                   <a:srgbClr val="222A18"/>
                 </a:solidFill>
                 <a:latin typeface="Arial"/>
               </a:rPr>
-              <a:t>“AI tools were used to write this code - DeepSeek, Copilot, Codex. Every change was read, run and tested before it was kept: that run is 54 automated tests, all passing.”</a:t>
-            </a:r>
-          </a:p>
-        </p:txBody>
-      </p:sp>
-      <p:sp>
-        <p:nvSpPr>
-          <p:cNvPr id="11" name="TextBox 10"/>
+              <a:t>“Replit was our development workspace; the screenshots are in the submission folder. RunPod is not used - there is no GPU endpoint in this project, and the Technical Declaration says so.”</a:t>
+            </a:r>
+          </a:p>
+        </p:txBody>
+      </p:sp>
+      <p:sp>
+        <p:nvSpPr>
+          <p:cNvPr id="10" name="TextBox 9"/>
           <p:cNvSpPr txBox="1"/>
           <p:nvPr/>
         </p:nvSpPr>
         <p:spPr>
           <a:xfrm>
-            <a:off x="548640" y="4846320"/>
+            <a:off x="548640" y="4800600"/>
             <a:ext cx="2743200" cy="274320"/>
           </a:xfrm>
           <a:prstGeom prst="rect">
@@ -4815,13 +5012,13 @@
       </p:sp>
       <p:sp>
         <p:nvSpPr>
-          <p:cNvPr id="12" name="TextBox 11"/>
+          <p:cNvPr id="11" name="TextBox 10"/>
           <p:cNvSpPr txBox="1"/>
           <p:nvPr/>
         </p:nvSpPr>
         <p:spPr>
           <a:xfrm>
-            <a:off x="548640" y="5120640"/>
+            <a:off x="548640" y="5074920"/>
             <a:ext cx="7589520" cy="1097280"/>
           </a:xfrm>
           <a:prstGeom prst="rect">
@@ -4836,40 +5033,40 @@
           <a:lstStyle/>
           <a:p>
             <a:r>
-              <a:rPr sz="1200">
+              <a:rPr sz="1300">
                 <a:solidFill>
                   <a:srgbClr val="5B7FA6"/>
                 </a:solidFill>
                 <a:latin typeface="Arial"/>
                 <a:hlinkClick r:id="rId2"/>
               </a:rPr>
-              <a:t>tests folder</a:t>
-            </a:r>
-          </a:p>
-          <a:p>
-            <a:r>
-              <a:rPr sz="1200">
+              <a:t>Replit proof</a:t>
+            </a:r>
+          </a:p>
+          <a:p>
+            <a:r>
+              <a:rPr sz="1300">
                 <a:solidFill>
                   <a:srgbClr val="5B7FA6"/>
                 </a:solidFill>
                 <a:latin typeface="Arial"/>
                 <a:hlinkClick r:id="rId3"/>
               </a:rPr>
-              <a:t>Technical Declaration, section 4.3</a:t>
-            </a:r>
-          </a:p>
-        </p:txBody>
-      </p:sp>
-      <p:sp>
-        <p:nvSpPr>
-          <p:cNvPr id="13" name="Rectangle 12"/>
+              <a:t>Technical Declaration</a:t>
+            </a:r>
+          </a:p>
+        </p:txBody>
+      </p:sp>
+      <p:sp>
+        <p:nvSpPr>
+          <p:cNvPr id="12" name="Rectangle 11"/>
           <p:cNvSpPr/>
           <p:nvPr/>
         </p:nvSpPr>
         <p:spPr>
           <a:xfrm>
-            <a:off x="8366760" y="5074920"/>
-            <a:ext cx="3291840" cy="1005840"/>
+            <a:off x="8366760" y="5029200"/>
+            <a:ext cx="3291840" cy="1051560"/>
           </a:xfrm>
           <a:prstGeom prst="rect">
             <a:avLst/>
@@ -4903,20 +5100,20 @@
           <a:p>
             <a:pPr algn="ctr"/>
             <a:r>
-              <a:rPr sz="1100">
+              <a:rPr sz="1200">
                 <a:solidFill>
                   <a:srgbClr val="7A5A1E"/>
                 </a:solidFill>
                 <a:latin typeface="Arial"/>
               </a:rPr>
-              <a:t>Clear the terminal first (cls). No personal paths on screen.</a:t>
-            </a:r>
-          </a:p>
-        </p:txBody>
-      </p:sp>
-      <p:sp>
-        <p:nvSpPr>
-          <p:cNvPr id="14" name="TextBox 13"/>
+              <a:t>Say used / not used in one breath. Do not explain why RunPod is unused.</a:t>
+            </a:r>
+          </a:p>
+        </p:txBody>
+      </p:sp>
+      <p:sp>
+        <p:nvSpPr>
+          <p:cNvPr id="13" name="TextBox 12"/>
           <p:cNvSpPr txBox="1"/>
           <p:nvPr/>
         </p:nvSpPr>
@@ -5018,8 +5215,8 @@
         </p:nvSpPr>
         <p:spPr>
           <a:xfrm>
-            <a:off x="548640" y="411480"/>
-            <a:ext cx="11155680" cy="411480"/>
+            <a:off x="548640" y="502920"/>
+            <a:ext cx="11155680" cy="822960"/>
           </a:xfrm>
           <a:prstGeom prst="rect">
             <a:avLst/>
@@ -5034,62 +5231,27 @@
           <a:p>
             <a:pPr algn="l"/>
             <a:r>
-              <a:rPr sz="1500" b="1">
-                <a:solidFill>
-                  <a:srgbClr val="6F8140"/>
-                </a:solidFill>
-                <a:latin typeface="Arial"/>
-              </a:rPr>
-              <a:t>4:50 - 5:00</a:t>
-            </a:r>
-          </a:p>
-        </p:txBody>
-      </p:sp>
-      <p:sp>
-        <p:nvSpPr>
-          <p:cNvPr id="4" name="TextBox 3"/>
-          <p:cNvSpPr txBox="1"/>
-          <p:nvPr/>
-        </p:nvSpPr>
-        <p:spPr>
-          <a:xfrm>
-            <a:off x="548640" y="822960"/>
-            <a:ext cx="11155680" cy="822960"/>
-          </a:xfrm>
-          <a:prstGeom prst="rect">
-            <a:avLst/>
-          </a:prstGeom>
-          <a:noFill/>
-        </p:spPr>
-        <p:txBody>
-          <a:bodyPr wrap="square">
-            <a:spAutoFit/>
-          </a:bodyPr>
-          <a:lstStyle/>
-          <a:p>
-            <a:pPr algn="l"/>
-            <a:r>
-              <a:rPr sz="3000" b="1">
+              <a:rPr sz="3200" b="1">
                 <a:solidFill>
                   <a:srgbClr val="3F4A26"/>
                 </a:solidFill>
                 <a:latin typeface="Arial"/>
               </a:rPr>
-              <a:t>Replit and RunPod</a:t>
-            </a:r>
-          </a:p>
-        </p:txBody>
-      </p:sp>
-      <p:sp>
-        <p:nvSpPr>
-          <p:cNvPr id="5" name="Rectangle 4"/>
+              <a:t>SDG mapping</a:t>
+            </a:r>
+          </a:p>
+        </p:txBody>
+      </p:sp>
+      <p:sp>
+        <p:nvSpPr>
+          <p:cNvPr id="4" name="Rectangle 3"/>
           <p:cNvSpPr/>
           <p:nvPr/>
         </p:nvSpPr>
         <p:spPr>
           <a:xfrm>
-            <a:off x="548640" y="1874519"/>
-            <a:ext cx="5029200" cy="2788920"/>
+            <a:off x="548640" y="1600200"/>
+            <a:ext cx="5029200" cy="2971800"/>
           </a:xfrm>
           <a:prstGeom prst="rect">
             <a:avLst/>
@@ -5127,13 +5289,13 @@
       </p:sp>
       <p:sp>
         <p:nvSpPr>
-          <p:cNvPr id="6" name="TextBox 5"/>
+          <p:cNvPr id="5" name="TextBox 4"/>
           <p:cNvSpPr txBox="1"/>
           <p:nvPr/>
         </p:nvSpPr>
         <p:spPr>
           <a:xfrm>
-            <a:off x="777240" y="2011680"/>
+            <a:off x="777240" y="1755648"/>
             <a:ext cx="4572000" cy="320040"/>
           </a:xfrm>
           <a:prstGeom prst="rect">
@@ -5162,14 +5324,14 @@
       </p:sp>
       <p:sp>
         <p:nvSpPr>
-          <p:cNvPr id="7" name="TextBox 6"/>
+          <p:cNvPr id="6" name="TextBox 5"/>
           <p:cNvSpPr txBox="1"/>
           <p:nvPr/>
         </p:nvSpPr>
         <p:spPr>
           <a:xfrm>
-            <a:off x="777240" y="2377440"/>
-            <a:ext cx="4572000" cy="2103120"/>
+            <a:off x="777240" y="2148840"/>
+            <a:ext cx="4572000" cy="2286000"/>
           </a:xfrm>
           <a:prstGeom prst="rect">
             <a:avLst/>
@@ -5183,38 +5345,38 @@
           <a:lstStyle/>
           <a:p>
             <a:r>
-              <a:rPr sz="1500">
+              <a:rPr sz="1600">
                 <a:solidFill>
                   <a:srgbClr val="222A18"/>
                 </a:solidFill>
                 <a:latin typeface="Arial"/>
               </a:rPr>
-              <a:t>· PDF viewer: submission/REPLIT PROOF OF USE.pdf</a:t>
-            </a:r>
-          </a:p>
-          <a:p>
-            <a:r>
-              <a:rPr sz="1500">
+              <a:t>· App, scroll to the SDG section</a:t>
+            </a:r>
+          </a:p>
+          <a:p>
+            <a:r>
+              <a:rPr sz="1600">
                 <a:solidFill>
                   <a:srgbClr val="222A18"/>
                 </a:solidFill>
                 <a:latin typeface="Arial"/>
               </a:rPr>
-              <a:t>· scroll one page</a:t>
-            </a:r>
-          </a:p>
-        </p:txBody>
-      </p:sp>
-      <p:sp>
-        <p:nvSpPr>
-          <p:cNvPr id="8" name="Rectangle 7"/>
+              <a:t>· point at the skill-level tags, not the big icons</a:t>
+            </a:r>
+          </a:p>
+        </p:txBody>
+      </p:sp>
+      <p:sp>
+        <p:nvSpPr>
+          <p:cNvPr id="7" name="Rectangle 6"/>
           <p:cNvSpPr/>
           <p:nvPr/>
         </p:nvSpPr>
         <p:spPr>
           <a:xfrm>
-            <a:off x="5897880" y="1874519"/>
-            <a:ext cx="5760720" cy="2788920"/>
+            <a:off x="5897880" y="1600200"/>
+            <a:ext cx="5760720" cy="2971800"/>
           </a:xfrm>
           <a:prstGeom prst="rect">
             <a:avLst/>
@@ -5252,13 +5414,13 @@
       </p:sp>
       <p:sp>
         <p:nvSpPr>
-          <p:cNvPr id="9" name="TextBox 8"/>
+          <p:cNvPr id="8" name="TextBox 7"/>
           <p:cNvSpPr txBox="1"/>
           <p:nvPr/>
         </p:nvSpPr>
         <p:spPr>
           <a:xfrm>
-            <a:off x="6126480" y="2011680"/>
+            <a:off x="6126480" y="1755648"/>
             <a:ext cx="5303520" cy="320040"/>
           </a:xfrm>
           <a:prstGeom prst="rect">
@@ -5287,14 +5449,14 @@
       </p:sp>
       <p:sp>
         <p:nvSpPr>
-          <p:cNvPr id="10" name="TextBox 9"/>
+          <p:cNvPr id="9" name="TextBox 8"/>
           <p:cNvSpPr txBox="1"/>
           <p:nvPr/>
         </p:nvSpPr>
         <p:spPr>
           <a:xfrm>
-            <a:off x="6126480" y="2377440"/>
-            <a:ext cx="5303520" cy="2148840"/>
+            <a:off x="6126480" y="2148840"/>
+            <a:ext cx="5303520" cy="2286000"/>
           </a:xfrm>
           <a:prstGeom prst="rect">
             <a:avLst/>
@@ -5308,26 +5470,26 @@
           <a:lstStyle/>
           <a:p>
             <a:r>
-              <a:rPr sz="1500" i="1">
+              <a:rPr sz="1600" i="1">
                 <a:solidFill>
                   <a:srgbClr val="222A18"/>
                 </a:solidFill>
                 <a:latin typeface="Arial"/>
               </a:rPr>
-              <a:t>“Replit was our development workspace; the screenshots are in the submission folder. RunPod is not used - there is no GPU endpoint in this project, and the Technical Declaration says so.”</a:t>
-            </a:r>
-          </a:p>
-        </p:txBody>
-      </p:sp>
-      <p:sp>
-        <p:nvSpPr>
-          <p:cNvPr id="11" name="TextBox 10"/>
+              <a:t>“The track is SDG 4, sub-target 4.4 - skills for employment - with 8.5 as the second target. The mapping goes down to individual skills, and we label it as our own reading, not an official UN mapping.”</a:t>
+            </a:r>
+          </a:p>
+        </p:txBody>
+      </p:sp>
+      <p:sp>
+        <p:nvSpPr>
+          <p:cNvPr id="10" name="TextBox 9"/>
           <p:cNvSpPr txBox="1"/>
           <p:nvPr/>
         </p:nvSpPr>
         <p:spPr>
           <a:xfrm>
-            <a:off x="548640" y="4846320"/>
+            <a:off x="548640" y="4800600"/>
             <a:ext cx="2743200" cy="274320"/>
           </a:xfrm>
           <a:prstGeom prst="rect">
@@ -5356,13 +5518,13 @@
       </p:sp>
       <p:sp>
         <p:nvSpPr>
-          <p:cNvPr id="12" name="TextBox 11"/>
+          <p:cNvPr id="11" name="TextBox 10"/>
           <p:cNvSpPr txBox="1"/>
           <p:nvPr/>
         </p:nvSpPr>
         <p:spPr>
           <a:xfrm>
-            <a:off x="548640" y="5120640"/>
+            <a:off x="548640" y="5074920"/>
             <a:ext cx="7589520" cy="1097280"/>
           </a:xfrm>
           <a:prstGeom prst="rect">
@@ -5377,40 +5539,40 @@
           <a:lstStyle/>
           <a:p>
             <a:r>
-              <a:rPr sz="1200">
+              <a:rPr sz="1300">
                 <a:solidFill>
                   <a:srgbClr val="5B7FA6"/>
                 </a:solidFill>
                 <a:latin typeface="Arial"/>
                 <a:hlinkClick r:id="rId2"/>
               </a:rPr>
-              <a:t>Replit proof</a:t>
-            </a:r>
-          </a:p>
-          <a:p>
-            <a:r>
-              <a:rPr sz="1200">
+              <a:t>skills_sdg.json (54 skills)</a:t>
+            </a:r>
+          </a:p>
+          <a:p>
+            <a:r>
+              <a:rPr sz="1300">
                 <a:solidFill>
                   <a:srgbClr val="5B7FA6"/>
                 </a:solidFill>
                 <a:latin typeface="Arial"/>
                 <a:hlinkClick r:id="rId3"/>
               </a:rPr>
-              <a:t>Technical Declaration</a:t>
-            </a:r>
-          </a:p>
-        </p:txBody>
-      </p:sp>
-      <p:sp>
-        <p:nvSpPr>
-          <p:cNvPr id="13" name="Rectangle 12"/>
+              <a:t>README, SDG row</a:t>
+            </a:r>
+          </a:p>
+        </p:txBody>
+      </p:sp>
+      <p:sp>
+        <p:nvSpPr>
+          <p:cNvPr id="12" name="Rectangle 11"/>
           <p:cNvSpPr/>
           <p:nvPr/>
         </p:nvSpPr>
         <p:spPr>
           <a:xfrm>
-            <a:off x="8366760" y="5074920"/>
-            <a:ext cx="3291840" cy="1005840"/>
+            <a:off x="8366760" y="5029200"/>
+            <a:ext cx="3291840" cy="1051560"/>
           </a:xfrm>
           <a:prstGeom prst="rect">
             <a:avLst/>
@@ -5444,20 +5606,20 @@
           <a:p>
             <a:pPr algn="ctr"/>
             <a:r>
-              <a:rPr sz="1100">
+              <a:rPr sz="1200">
                 <a:solidFill>
                   <a:srgbClr val="7A5A1E"/>
                 </a:solidFill>
                 <a:latin typeface="Arial"/>
               </a:rPr>
-              <a:t>Say used / not used in one breath. Do not explain why RunPod is unused.</a:t>
-            </a:r>
-          </a:p>
-        </p:txBody>
-      </p:sp>
-      <p:sp>
-        <p:nvSpPr>
-          <p:cNvPr id="14" name="TextBox 13"/>
+              <a:t>Point at the skill chips. Icon-only is explicitly not enough.</a:t>
+            </a:r>
+          </a:p>
+        </p:txBody>
+      </p:sp>
+      <p:sp>
+        <p:nvSpPr>
+          <p:cNvPr id="13" name="TextBox 12"/>
           <p:cNvSpPr txBox="1"/>
           <p:nvPr/>
         </p:nvSpPr>
@@ -5559,8 +5721,8 @@
         </p:nvSpPr>
         <p:spPr>
           <a:xfrm>
-            <a:off x="548640" y="411480"/>
-            <a:ext cx="11155680" cy="411480"/>
+            <a:off x="548640" y="502920"/>
+            <a:ext cx="11155680" cy="822960"/>
           </a:xfrm>
           <a:prstGeom prst="rect">
             <a:avLst/>
@@ -5575,62 +5737,27 @@
           <a:p>
             <a:pPr algn="l"/>
             <a:r>
-              <a:rPr sz="1500" b="1">
-                <a:solidFill>
-                  <a:srgbClr val="6F8140"/>
-                </a:solidFill>
-                <a:latin typeface="Arial"/>
-              </a:rPr>
-              <a:t>5:00 - 5:20</a:t>
-            </a:r>
-          </a:p>
-        </p:txBody>
-      </p:sp>
-      <p:sp>
-        <p:nvSpPr>
-          <p:cNvPr id="4" name="TextBox 3"/>
-          <p:cNvSpPr txBox="1"/>
-          <p:nvPr/>
-        </p:nvSpPr>
-        <p:spPr>
-          <a:xfrm>
-            <a:off x="548640" y="822960"/>
-            <a:ext cx="11155680" cy="822960"/>
-          </a:xfrm>
-          <a:prstGeom prst="rect">
-            <a:avLst/>
-          </a:prstGeom>
-          <a:noFill/>
-        </p:spPr>
-        <p:txBody>
-          <a:bodyPr wrap="square">
-            <a:spAutoFit/>
-          </a:bodyPr>
-          <a:lstStyle/>
-          <a:p>
-            <a:pPr algn="l"/>
-            <a:r>
-              <a:rPr sz="3000" b="1">
+              <a:rPr sz="3200" b="1">
                 <a:solidFill>
                   <a:srgbClr val="3F4A26"/>
                 </a:solidFill>
                 <a:latin typeface="Arial"/>
               </a:rPr>
-              <a:t>SDG mapping</a:t>
-            </a:r>
-          </a:p>
-        </p:txBody>
-      </p:sp>
-      <p:sp>
-        <p:nvSpPr>
-          <p:cNvPr id="5" name="Rectangle 4"/>
+              <a:t>What we tested, honestly</a:t>
+            </a:r>
+          </a:p>
+        </p:txBody>
+      </p:sp>
+      <p:sp>
+        <p:nvSpPr>
+          <p:cNvPr id="4" name="Rectangle 3"/>
           <p:cNvSpPr/>
           <p:nvPr/>
         </p:nvSpPr>
         <p:spPr>
           <a:xfrm>
-            <a:off x="548640" y="1874519"/>
-            <a:ext cx="5029200" cy="2788920"/>
+            <a:off x="548640" y="1600200"/>
+            <a:ext cx="5029200" cy="2971800"/>
           </a:xfrm>
           <a:prstGeom prst="rect">
             <a:avLst/>
@@ -5668,13 +5795,13 @@
       </p:sp>
       <p:sp>
         <p:nvSpPr>
-          <p:cNvPr id="6" name="TextBox 5"/>
+          <p:cNvPr id="5" name="TextBox 4"/>
           <p:cNvSpPr txBox="1"/>
           <p:nvPr/>
         </p:nvSpPr>
         <p:spPr>
           <a:xfrm>
-            <a:off x="777240" y="2011680"/>
+            <a:off x="777240" y="1755648"/>
             <a:ext cx="4572000" cy="320040"/>
           </a:xfrm>
           <a:prstGeom prst="rect">
@@ -5703,14 +5830,14 @@
       </p:sp>
       <p:sp>
         <p:nvSpPr>
-          <p:cNvPr id="7" name="TextBox 6"/>
+          <p:cNvPr id="6" name="TextBox 5"/>
           <p:cNvSpPr txBox="1"/>
           <p:nvPr/>
         </p:nvSpPr>
         <p:spPr>
           <a:xfrm>
-            <a:off x="777240" y="2377440"/>
-            <a:ext cx="4572000" cy="2103120"/>
+            <a:off x="777240" y="2148840"/>
+            <a:ext cx="4572000" cy="2286000"/>
           </a:xfrm>
           <a:prstGeom prst="rect">
             <a:avLst/>
@@ -5724,38 +5851,38 @@
           <a:lstStyle/>
           <a:p>
             <a:r>
-              <a:rPr sz="1500">
+              <a:rPr sz="1600">
                 <a:solidFill>
                   <a:srgbClr val="222A18"/>
                 </a:solidFill>
                 <a:latin typeface="Arial"/>
               </a:rPr>
-              <a:t>· App, scroll to the SDG section</a:t>
-            </a:r>
-          </a:p>
-          <a:p>
-            <a:r>
-              <a:rPr sz="1500">
+              <a:t>· App: the source-robustness table</a:t>
+            </a:r>
+          </a:p>
+          <a:p>
+            <a:r>
+              <a:rPr sz="1600">
                 <a:solidFill>
                   <a:srgbClr val="222A18"/>
                 </a:solidFill>
                 <a:latin typeface="Arial"/>
               </a:rPr>
-              <a:t>· point at the skill-level tags, not the big icons</a:t>
-            </a:r>
-          </a:p>
-        </p:txBody>
-      </p:sp>
-      <p:sp>
-        <p:nvSpPr>
-          <p:cNvPr id="8" name="Rectangle 7"/>
+              <a:t>· or the terminal still showing the test run</a:t>
+            </a:r>
+          </a:p>
+        </p:txBody>
+      </p:sp>
+      <p:sp>
+        <p:nvSpPr>
+          <p:cNvPr id="7" name="Rectangle 6"/>
           <p:cNvSpPr/>
           <p:nvPr/>
         </p:nvSpPr>
         <p:spPr>
           <a:xfrm>
-            <a:off x="5897880" y="1874519"/>
-            <a:ext cx="5760720" cy="2788920"/>
+            <a:off x="5897880" y="1600200"/>
+            <a:ext cx="5760720" cy="2971800"/>
           </a:xfrm>
           <a:prstGeom prst="rect">
             <a:avLst/>
@@ -5793,13 +5920,13 @@
       </p:sp>
       <p:sp>
         <p:nvSpPr>
-          <p:cNvPr id="9" name="TextBox 8"/>
+          <p:cNvPr id="8" name="TextBox 7"/>
           <p:cNvSpPr txBox="1"/>
           <p:nvPr/>
         </p:nvSpPr>
         <p:spPr>
           <a:xfrm>
-            <a:off x="6126480" y="2011680"/>
+            <a:off x="6126480" y="1755648"/>
             <a:ext cx="5303520" cy="320040"/>
           </a:xfrm>
           <a:prstGeom prst="rect">
@@ -5828,14 +5955,14 @@
       </p:sp>
       <p:sp>
         <p:nvSpPr>
-          <p:cNvPr id="10" name="TextBox 9"/>
+          <p:cNvPr id="9" name="TextBox 8"/>
           <p:cNvSpPr txBox="1"/>
           <p:nvPr/>
         </p:nvSpPr>
         <p:spPr>
           <a:xfrm>
-            <a:off x="6126480" y="2377440"/>
-            <a:ext cx="5303520" cy="2148840"/>
+            <a:off x="6126480" y="2148840"/>
+            <a:ext cx="5303520" cy="2286000"/>
           </a:xfrm>
           <a:prstGeom prst="rect">
             <a:avLst/>
@@ -5849,26 +5976,26 @@
           <a:lstStyle/>
           <a:p>
             <a:r>
-              <a:rPr sz="1500" i="1">
+              <a:rPr sz="1600" i="1">
                 <a:solidFill>
                   <a:srgbClr val="222A18"/>
                 </a:solidFill>
                 <a:latin typeface="Arial"/>
               </a:rPr>
-              <a:t>“The track is SDG 4, sub-target 4.4 - skills for employment - with 8.5 as the second target. The mapping goes down to individual skills, and we label it as our own reading, not an official UN mapping.”</a:t>
-            </a:r>
-          </a:p>
-        </p:txBody>
-      </p:sp>
-      <p:sp>
-        <p:nvSpPr>
-          <p:cNvPr id="11" name="TextBox 10"/>
+              <a:t>“What we tested: 54 automated tests, every flow in three languages on synthetic profiles, and 60 course links checked as reachable. What we have not done: a user study. Phase 2 targets ten testers, a median plan under five minutes, and 70% rating a top-three role at least 4 out of 5. Targets, not results.”</a:t>
+            </a:r>
+          </a:p>
+        </p:txBody>
+      </p:sp>
+      <p:sp>
+        <p:nvSpPr>
+          <p:cNvPr id="10" name="TextBox 9"/>
           <p:cNvSpPr txBox="1"/>
           <p:nvPr/>
         </p:nvSpPr>
         <p:spPr>
           <a:xfrm>
-            <a:off x="548640" y="4846320"/>
+            <a:off x="548640" y="4800600"/>
             <a:ext cx="2743200" cy="274320"/>
           </a:xfrm>
           <a:prstGeom prst="rect">
@@ -5897,13 +6024,13 @@
       </p:sp>
       <p:sp>
         <p:nvSpPr>
-          <p:cNvPr id="12" name="TextBox 11"/>
+          <p:cNvPr id="11" name="TextBox 10"/>
           <p:cNvSpPr txBox="1"/>
           <p:nvPr/>
         </p:nvSpPr>
         <p:spPr>
           <a:xfrm>
-            <a:off x="548640" y="5120640"/>
+            <a:off x="548640" y="5074920"/>
             <a:ext cx="7589520" cy="1097280"/>
           </a:xfrm>
           <a:prstGeom prst="rect">
@@ -5918,40 +6045,40 @@
           <a:lstStyle/>
           <a:p>
             <a:r>
-              <a:rPr sz="1200">
+              <a:rPr sz="1300">
                 <a:solidFill>
                   <a:srgbClr val="5B7FA6"/>
                 </a:solidFill>
                 <a:latin typeface="Arial"/>
                 <a:hlinkClick r:id="rId2"/>
               </a:rPr>
-              <a:t>skills_sdg.json (54 skills)</a:t>
-            </a:r>
-          </a:p>
-          <a:p>
-            <a:r>
-              <a:rPr sz="1200">
+              <a:t>courses.json (60 links)</a:t>
+            </a:r>
+          </a:p>
+          <a:p>
+            <a:r>
+              <a:rPr sz="1300">
                 <a:solidFill>
                   <a:srgbClr val="5B7FA6"/>
                 </a:solidFill>
                 <a:latin typeface="Arial"/>
                 <a:hlinkClick r:id="rId3"/>
               </a:rPr>
-              <a:t>README, SDG row</a:t>
-            </a:r>
-          </a:p>
-        </p:txBody>
-      </p:sp>
-      <p:sp>
-        <p:nvSpPr>
-          <p:cNvPr id="13" name="Rectangle 12"/>
+              <a:t>sample_cv.txt (synthetic)</a:t>
+            </a:r>
+          </a:p>
+        </p:txBody>
+      </p:sp>
+      <p:sp>
+        <p:nvSpPr>
+          <p:cNvPr id="12" name="Rectangle 11"/>
           <p:cNvSpPr/>
           <p:nvPr/>
         </p:nvSpPr>
         <p:spPr>
           <a:xfrm>
-            <a:off x="8366760" y="5074920"/>
-            <a:ext cx="3291840" cy="1005840"/>
+            <a:off x="8366760" y="5029200"/>
+            <a:ext cx="3291840" cy="1051560"/>
           </a:xfrm>
           <a:prstGeom prst="rect">
             <a:avLst/>
@@ -5985,20 +6112,20 @@
           <a:p>
             <a:pPr algn="ctr"/>
             <a:r>
-              <a:rPr sz="1100">
+              <a:rPr sz="1200">
                 <a:solidFill>
                   <a:srgbClr val="7A5A1E"/>
                 </a:solidFill>
                 <a:latin typeface="Arial"/>
               </a:rPr>
-              <a:t>Point at the skill chips. Icon-only is explicitly not enough.</a:t>
-            </a:r>
-          </a:p>
-        </p:txBody>
-      </p:sp>
-      <p:sp>
-        <p:nvSpPr>
-          <p:cNvPr id="14" name="TextBox 13"/>
+              <a:t>Keep the last sentence: targets, not results.</a:t>
+            </a:r>
+          </a:p>
+        </p:txBody>
+      </p:sp>
+      <p:sp>
+        <p:nvSpPr>
+          <p:cNvPr id="13" name="TextBox 12"/>
           <p:cNvSpPr txBox="1"/>
           <p:nvPr/>
         </p:nvSpPr>
@@ -6100,8 +6227,8 @@
         </p:nvSpPr>
         <p:spPr>
           <a:xfrm>
-            <a:off x="548640" y="411480"/>
-            <a:ext cx="11155680" cy="411480"/>
+            <a:off x="548640" y="502920"/>
+            <a:ext cx="11155680" cy="822960"/>
           </a:xfrm>
           <a:prstGeom prst="rect">
             <a:avLst/>
@@ -6116,62 +6243,27 @@
           <a:p>
             <a:pPr algn="l"/>
             <a:r>
-              <a:rPr sz="1500" b="1">
-                <a:solidFill>
-                  <a:srgbClr val="6F8140"/>
-                </a:solidFill>
-                <a:latin typeface="Arial"/>
-              </a:rPr>
-              <a:t>5:20 - 5:40</a:t>
-            </a:r>
-          </a:p>
-        </p:txBody>
-      </p:sp>
-      <p:sp>
-        <p:nvSpPr>
-          <p:cNvPr id="4" name="TextBox 3"/>
-          <p:cNvSpPr txBox="1"/>
-          <p:nvPr/>
-        </p:nvSpPr>
-        <p:spPr>
-          <a:xfrm>
-            <a:off x="548640" y="822960"/>
-            <a:ext cx="11155680" cy="822960"/>
-          </a:xfrm>
-          <a:prstGeom prst="rect">
-            <a:avLst/>
-          </a:prstGeom>
-          <a:noFill/>
-        </p:spPr>
-        <p:txBody>
-          <a:bodyPr wrap="square">
-            <a:spAutoFit/>
-          </a:bodyPr>
-          <a:lstStyle/>
-          <a:p>
-            <a:pPr algn="l"/>
-            <a:r>
-              <a:rPr sz="3000" b="1">
+              <a:rPr sz="3200" b="1">
                 <a:solidFill>
                   <a:srgbClr val="3F4A26"/>
                 </a:solidFill>
                 <a:latin typeface="Arial"/>
               </a:rPr>
-              <a:t>What we tested, honestly</a:t>
-            </a:r>
-          </a:p>
-        </p:txBody>
-      </p:sp>
-      <p:sp>
-        <p:nvSpPr>
-          <p:cNvPr id="5" name="Rectangle 4"/>
+              <a:t>Limits and next steps</a:t>
+            </a:r>
+          </a:p>
+        </p:txBody>
+      </p:sp>
+      <p:sp>
+        <p:nvSpPr>
+          <p:cNvPr id="4" name="Rectangle 3"/>
           <p:cNvSpPr/>
           <p:nvPr/>
         </p:nvSpPr>
         <p:spPr>
           <a:xfrm>
-            <a:off x="548640" y="1874519"/>
-            <a:ext cx="5029200" cy="2788920"/>
+            <a:off x="548640" y="1600200"/>
+            <a:ext cx="5029200" cy="2971800"/>
           </a:xfrm>
           <a:prstGeom prst="rect">
             <a:avLst/>
@@ -6209,13 +6301,13 @@
       </p:sp>
       <p:sp>
         <p:nvSpPr>
-          <p:cNvPr id="6" name="TextBox 5"/>
+          <p:cNvPr id="5" name="TextBox 4"/>
           <p:cNvSpPr txBox="1"/>
           <p:nvPr/>
         </p:nvSpPr>
         <p:spPr>
           <a:xfrm>
-            <a:off x="777240" y="2011680"/>
+            <a:off x="777240" y="1755648"/>
             <a:ext cx="4572000" cy="320040"/>
           </a:xfrm>
           <a:prstGeom prst="rect">
@@ -6244,14 +6336,14 @@
       </p:sp>
       <p:sp>
         <p:nvSpPr>
-          <p:cNvPr id="7" name="TextBox 6"/>
+          <p:cNvPr id="6" name="TextBox 5"/>
           <p:cNvSpPr txBox="1"/>
           <p:nvPr/>
         </p:nvSpPr>
         <p:spPr>
           <a:xfrm>
-            <a:off x="777240" y="2377440"/>
-            <a:ext cx="4572000" cy="2103120"/>
+            <a:off x="777240" y="2148840"/>
+            <a:ext cx="4572000" cy="2286000"/>
           </a:xfrm>
           <a:prstGeom prst="rect">
             <a:avLst/>
@@ -6265,38 +6357,38 @@
           <a:lstStyle/>
           <a:p>
             <a:r>
-              <a:rPr sz="1500">
+              <a:rPr sz="1600">
                 <a:solidFill>
                   <a:srgbClr val="222A18"/>
                 </a:solidFill>
                 <a:latin typeface="Arial"/>
               </a:rPr>
-              <a:t>· App: the source-robustness table</a:t>
-            </a:r>
-          </a:p>
-          <a:p>
-            <a:r>
-              <a:rPr sz="1500">
+              <a:t>· README, Known limitations</a:t>
+            </a:r>
+          </a:p>
+          <a:p>
+            <a:r>
+              <a:rPr sz="1600">
                 <a:solidFill>
                   <a:srgbClr val="222A18"/>
                 </a:solidFill>
                 <a:latin typeface="Arial"/>
               </a:rPr>
-              <a:t>· or the terminal still showing the test run</a:t>
-            </a:r>
-          </a:p>
-        </p:txBody>
-      </p:sp>
-      <p:sp>
-        <p:nvSpPr>
-          <p:cNvPr id="8" name="Rectangle 7"/>
+              <a:t>· or the last slide of the deck</a:t>
+            </a:r>
+          </a:p>
+        </p:txBody>
+      </p:sp>
+      <p:sp>
+        <p:nvSpPr>
+          <p:cNvPr id="7" name="Rectangle 6"/>
           <p:cNvSpPr/>
           <p:nvPr/>
         </p:nvSpPr>
         <p:spPr>
           <a:xfrm>
-            <a:off x="5897880" y="1874519"/>
-            <a:ext cx="5760720" cy="2788920"/>
+            <a:off x="5897880" y="1600200"/>
+            <a:ext cx="5760720" cy="2971800"/>
           </a:xfrm>
           <a:prstGeom prst="rect">
             <a:avLst/>
@@ -6334,13 +6426,13 @@
       </p:sp>
       <p:sp>
         <p:nvSpPr>
-          <p:cNvPr id="9" name="TextBox 8"/>
+          <p:cNvPr id="8" name="TextBox 7"/>
           <p:cNvSpPr txBox="1"/>
           <p:nvPr/>
         </p:nvSpPr>
         <p:spPr>
           <a:xfrm>
-            <a:off x="6126480" y="2011680"/>
+            <a:off x="6126480" y="1755648"/>
             <a:ext cx="5303520" cy="320040"/>
           </a:xfrm>
           <a:prstGeom prst="rect">
@@ -6369,14 +6461,14 @@
       </p:sp>
       <p:sp>
         <p:nvSpPr>
-          <p:cNvPr id="10" name="TextBox 9"/>
+          <p:cNvPr id="9" name="TextBox 8"/>
           <p:cNvSpPr txBox="1"/>
           <p:nvPr/>
         </p:nvSpPr>
         <p:spPr>
           <a:xfrm>
-            <a:off x="6126480" y="2377440"/>
-            <a:ext cx="5303520" cy="2148840"/>
+            <a:off x="6126480" y="2148840"/>
+            <a:ext cx="5303520" cy="2286000"/>
           </a:xfrm>
           <a:prstGeom prst="rect">
             <a:avLst/>
@@ -6390,26 +6482,26 @@
           <a:lstStyle/>
           <a:p>
             <a:r>
-              <a:rPr sz="1500" i="1">
+              <a:rPr sz="1600" i="1">
                 <a:solidFill>
                   <a:srgbClr val="222A18"/>
                 </a:solidFill>
                 <a:latin typeface="Arial"/>
               </a:rPr>
-              <a:t>“What we tested: 54 automated tests, every flow in three languages on synthetic profiles, and 60 course links checked as reachable. What we have not done: a user study. Phase 2 targets ten testers, a median plan under five minutes, and 70% rating a top-three role at least 4 out of 5. Targets, not results.”</a:t>
-            </a:r>
-          </a:p>
-        </p:txBody>
-      </p:sp>
-      <p:sp>
-        <p:nvSpPr>
-          <p:cNvPr id="11" name="TextBox 10"/>
+              <a:t>“Known limits: the occupation-to-skill mapping is our heuristic, one quarter is not a trend, course fees are unverified, and the parser misses synonyms. Next: verified course metadata, semantic CV parsing, and the user pilot. Everything planned is labelled as planned.”</a:t>
+            </a:r>
+          </a:p>
+        </p:txBody>
+      </p:sp>
+      <p:sp>
+        <p:nvSpPr>
+          <p:cNvPr id="10" name="TextBox 9"/>
           <p:cNvSpPr txBox="1"/>
           <p:nvPr/>
         </p:nvSpPr>
         <p:spPr>
           <a:xfrm>
-            <a:off x="548640" y="4846320"/>
+            <a:off x="548640" y="4800600"/>
             <a:ext cx="2743200" cy="274320"/>
           </a:xfrm>
           <a:prstGeom prst="rect">
@@ -6438,13 +6530,13 @@
       </p:sp>
       <p:sp>
         <p:nvSpPr>
-          <p:cNvPr id="12" name="TextBox 11"/>
+          <p:cNvPr id="11" name="TextBox 10"/>
           <p:cNvSpPr txBox="1"/>
           <p:nvPr/>
         </p:nvSpPr>
         <p:spPr>
           <a:xfrm>
-            <a:off x="548640" y="5120640"/>
+            <a:off x="548640" y="5074920"/>
             <a:ext cx="7589520" cy="1097280"/>
           </a:xfrm>
           <a:prstGeom prst="rect">
@@ -6459,40 +6551,40 @@
           <a:lstStyle/>
           <a:p>
             <a:r>
-              <a:rPr sz="1200">
+              <a:rPr sz="1300">
                 <a:solidFill>
                   <a:srgbClr val="5B7FA6"/>
                 </a:solidFill>
                 <a:latin typeface="Arial"/>
                 <a:hlinkClick r:id="rId2"/>
               </a:rPr>
-              <a:t>courses.json (60 links)</a:t>
-            </a:r>
-          </a:p>
-          <a:p>
-            <a:r>
-              <a:rPr sz="1200">
+              <a:t>README, limitations</a:t>
+            </a:r>
+          </a:p>
+          <a:p>
+            <a:r>
+              <a:rPr sz="1300">
                 <a:solidFill>
                   <a:srgbClr val="5B7FA6"/>
                 </a:solidFill>
                 <a:latin typeface="Arial"/>
                 <a:hlinkClick r:id="rId3"/>
               </a:rPr>
-              <a:t>sample_cv.txt (synthetic)</a:t>
-            </a:r>
-          </a:p>
-        </p:txBody>
-      </p:sp>
-      <p:sp>
-        <p:nvSpPr>
-          <p:cNvPr id="13" name="Rectangle 12"/>
+              <a:t>Deck, roadmap</a:t>
+            </a:r>
+          </a:p>
+        </p:txBody>
+      </p:sp>
+      <p:sp>
+        <p:nvSpPr>
+          <p:cNvPr id="12" name="Rectangle 11"/>
           <p:cNvSpPr/>
           <p:nvPr/>
         </p:nvSpPr>
         <p:spPr>
           <a:xfrm>
-            <a:off x="8366760" y="5074920"/>
-            <a:ext cx="3291840" cy="1005840"/>
+            <a:off x="8366760" y="5029200"/>
+            <a:ext cx="3291840" cy="1051560"/>
           </a:xfrm>
           <a:prstGeom prst="rect">
             <a:avLst/>
@@ -6526,553 +6618,12 @@
           <a:p>
             <a:pPr algn="ctr"/>
             <a:r>
-              <a:rPr sz="1100">
+              <a:rPr sz="1200">
                 <a:solidFill>
                   <a:srgbClr val="7A5A1E"/>
                 </a:solidFill>
                 <a:latin typeface="Arial"/>
               </a:rPr>
-              <a:t>Keep the last sentence: targets, not results.</a:t>
-            </a:r>
-          </a:p>
-        </p:txBody>
-      </p:sp>
-      <p:sp>
-        <p:nvSpPr>
-          <p:cNvPr id="14" name="TextBox 13"/>
-          <p:cNvSpPr txBox="1"/>
-          <p:nvPr/>
-        </p:nvSpPr>
-        <p:spPr>
-          <a:xfrm>
-            <a:off x="548640" y="6400800"/>
-            <a:ext cx="11155680" cy="274320"/>
-          </a:xfrm>
-          <a:prstGeom prst="rect">
-            <a:avLst/>
-          </a:prstGeom>
-          <a:noFill/>
-        </p:spPr>
-        <p:txBody>
-          <a:bodyPr wrap="square">
-            <a:spAutoFit/>
-          </a:bodyPr>
-          <a:lstStyle/>
-          <a:p>
-            <a:pPr algn="l"/>
-            <a:r>
-              <a:rPr sz="900" b="0">
-                <a:solidFill>
-                  <a:srgbClr val="6B7560"/>
-                </a:solidFill>
-                <a:latin typeface="Arial"/>
-              </a:rPr>
-              <a:t>SkillRadar MY · Lumina Nusantara · SDC 2026</a:t>
-            </a:r>
-          </a:p>
-        </p:txBody>
-      </p:sp>
-    </p:spTree>
-  </p:cSld>
-  <p:clrMapOvr>
-    <a:masterClrMapping/>
-  </p:clrMapOvr>
-</p:sld>
-</file>
-
-<file path=ppt/slides/slide8.xml><?xml version="1.0" encoding="utf-8"?>
-<p:sld xmlns:a="http://schemas.openxmlformats.org/drawingml/2006/main" xmlns:p="http://schemas.openxmlformats.org/presentationml/2006/main" xmlns:r="http://schemas.openxmlformats.org/officeDocument/2006/relationships">
-  <p:cSld>
-    <p:spTree>
-      <p:nvGrpSpPr>
-        <p:cNvPr id="1" name=""/>
-        <p:cNvGrpSpPr/>
-        <p:nvPr/>
-      </p:nvGrpSpPr>
-      <p:grpSpPr/>
-      <p:sp>
-        <p:nvSpPr>
-          <p:cNvPr id="2" name="Rectangle 1"/>
-          <p:cNvSpPr/>
-          <p:nvPr/>
-        </p:nvSpPr>
-        <p:spPr>
-          <a:xfrm>
-            <a:off x="0" y="0"/>
-            <a:ext cx="12191695" cy="201168"/>
-          </a:xfrm>
-          <a:prstGeom prst="rect">
-            <a:avLst/>
-          </a:prstGeom>
-          <a:solidFill>
-            <a:srgbClr val="6F8140"/>
-          </a:solidFill>
-          <a:ln>
-            <a:noFill/>
-          </a:ln>
-        </p:spPr>
-        <p:style>
-          <a:lnRef idx="1">
-            <a:schemeClr val="accent1"/>
-          </a:lnRef>
-          <a:fillRef idx="3">
-            <a:schemeClr val="accent1"/>
-          </a:fillRef>
-          <a:effectRef idx="2">
-            <a:schemeClr val="accent1"/>
-          </a:effectRef>
-          <a:fontRef idx="minor">
-            <a:schemeClr val="lt1"/>
-          </a:fontRef>
-        </p:style>
-        <p:txBody>
-          <a:bodyPr rtlCol="0" anchor="ctr"/>
-          <a:lstStyle/>
-          <a:p>
-            <a:pPr algn="ctr"/>
-          </a:p>
-        </p:txBody>
-      </p:sp>
-      <p:sp>
-        <p:nvSpPr>
-          <p:cNvPr id="3" name="TextBox 2"/>
-          <p:cNvSpPr txBox="1"/>
-          <p:nvPr/>
-        </p:nvSpPr>
-        <p:spPr>
-          <a:xfrm>
-            <a:off x="548640" y="411480"/>
-            <a:ext cx="11155680" cy="411480"/>
-          </a:xfrm>
-          <a:prstGeom prst="rect">
-            <a:avLst/>
-          </a:prstGeom>
-          <a:noFill/>
-        </p:spPr>
-        <p:txBody>
-          <a:bodyPr wrap="square">
-            <a:spAutoFit/>
-          </a:bodyPr>
-          <a:lstStyle/>
-          <a:p>
-            <a:pPr algn="l"/>
-            <a:r>
-              <a:rPr sz="1500" b="1">
-                <a:solidFill>
-                  <a:srgbClr val="6F8140"/>
-                </a:solidFill>
-                <a:latin typeface="Arial"/>
-              </a:rPr>
-              <a:t>5:40 - 6:00</a:t>
-            </a:r>
-          </a:p>
-        </p:txBody>
-      </p:sp>
-      <p:sp>
-        <p:nvSpPr>
-          <p:cNvPr id="4" name="TextBox 3"/>
-          <p:cNvSpPr txBox="1"/>
-          <p:nvPr/>
-        </p:nvSpPr>
-        <p:spPr>
-          <a:xfrm>
-            <a:off x="548640" y="822960"/>
-            <a:ext cx="11155680" cy="822960"/>
-          </a:xfrm>
-          <a:prstGeom prst="rect">
-            <a:avLst/>
-          </a:prstGeom>
-          <a:noFill/>
-        </p:spPr>
-        <p:txBody>
-          <a:bodyPr wrap="square">
-            <a:spAutoFit/>
-          </a:bodyPr>
-          <a:lstStyle/>
-          <a:p>
-            <a:pPr algn="l"/>
-            <a:r>
-              <a:rPr sz="3000" b="1">
-                <a:solidFill>
-                  <a:srgbClr val="3F4A26"/>
-                </a:solidFill>
-                <a:latin typeface="Arial"/>
-              </a:rPr>
-              <a:t>Limits and next steps</a:t>
-            </a:r>
-          </a:p>
-        </p:txBody>
-      </p:sp>
-      <p:sp>
-        <p:nvSpPr>
-          <p:cNvPr id="5" name="Rectangle 4"/>
-          <p:cNvSpPr/>
-          <p:nvPr/>
-        </p:nvSpPr>
-        <p:spPr>
-          <a:xfrm>
-            <a:off x="548640" y="1874519"/>
-            <a:ext cx="5029200" cy="2788920"/>
-          </a:xfrm>
-          <a:prstGeom prst="rect">
-            <a:avLst/>
-          </a:prstGeom>
-          <a:solidFill>
-            <a:srgbClr val="F2F5E9"/>
-          </a:solidFill>
-          <a:ln>
-            <a:solidFill>
-              <a:srgbClr val="D8DFCA"/>
-            </a:solidFill>
-          </a:ln>
-        </p:spPr>
-        <p:style>
-          <a:lnRef idx="1">
-            <a:schemeClr val="accent1"/>
-          </a:lnRef>
-          <a:fillRef idx="3">
-            <a:schemeClr val="accent1"/>
-          </a:fillRef>
-          <a:effectRef idx="2">
-            <a:schemeClr val="accent1"/>
-          </a:effectRef>
-          <a:fontRef idx="minor">
-            <a:schemeClr val="lt1"/>
-          </a:fontRef>
-        </p:style>
-        <p:txBody>
-          <a:bodyPr rtlCol="0" anchor="ctr"/>
-          <a:lstStyle/>
-          <a:p>
-            <a:pPr algn="ctr"/>
-          </a:p>
-        </p:txBody>
-      </p:sp>
-      <p:sp>
-        <p:nvSpPr>
-          <p:cNvPr id="6" name="TextBox 5"/>
-          <p:cNvSpPr txBox="1"/>
-          <p:nvPr/>
-        </p:nvSpPr>
-        <p:spPr>
-          <a:xfrm>
-            <a:off x="777240" y="2011680"/>
-            <a:ext cx="4572000" cy="320040"/>
-          </a:xfrm>
-          <a:prstGeom prst="rect">
-            <a:avLst/>
-          </a:prstGeom>
-          <a:noFill/>
-        </p:spPr>
-        <p:txBody>
-          <a:bodyPr wrap="square">
-            <a:spAutoFit/>
-          </a:bodyPr>
-          <a:lstStyle/>
-          <a:p>
-            <a:pPr algn="l"/>
-            <a:r>
-              <a:rPr sz="1100" b="1">
-                <a:solidFill>
-                  <a:srgbClr val="6B7560"/>
-                </a:solidFill>
-                <a:latin typeface="Arial"/>
-              </a:rPr>
-              <a:t>ON SCREEN</a:t>
-            </a:r>
-          </a:p>
-        </p:txBody>
-      </p:sp>
-      <p:sp>
-        <p:nvSpPr>
-          <p:cNvPr id="7" name="TextBox 6"/>
-          <p:cNvSpPr txBox="1"/>
-          <p:nvPr/>
-        </p:nvSpPr>
-        <p:spPr>
-          <a:xfrm>
-            <a:off x="777240" y="2377440"/>
-            <a:ext cx="4572000" cy="2103120"/>
-          </a:xfrm>
-          <a:prstGeom prst="rect">
-            <a:avLst/>
-          </a:prstGeom>
-          <a:noFill/>
-        </p:spPr>
-        <p:txBody>
-          <a:bodyPr wrap="square">
-            <a:spAutoFit/>
-          </a:bodyPr>
-          <a:lstStyle/>
-          <a:p>
-            <a:r>
-              <a:rPr sz="1500">
-                <a:solidFill>
-                  <a:srgbClr val="222A18"/>
-                </a:solidFill>
-                <a:latin typeface="Arial"/>
-              </a:rPr>
-              <a:t>· README, Known limitations</a:t>
-            </a:r>
-          </a:p>
-          <a:p>
-            <a:r>
-              <a:rPr sz="1500">
-                <a:solidFill>
-                  <a:srgbClr val="222A18"/>
-                </a:solidFill>
-                <a:latin typeface="Arial"/>
-              </a:rPr>
-              <a:t>· or the last slide of the deck</a:t>
-            </a:r>
-          </a:p>
-        </p:txBody>
-      </p:sp>
-      <p:sp>
-        <p:nvSpPr>
-          <p:cNvPr id="8" name="Rectangle 7"/>
-          <p:cNvSpPr/>
-          <p:nvPr/>
-        </p:nvSpPr>
-        <p:spPr>
-          <a:xfrm>
-            <a:off x="5897880" y="1874519"/>
-            <a:ext cx="5760720" cy="2788920"/>
-          </a:xfrm>
-          <a:prstGeom prst="rect">
-            <a:avLst/>
-          </a:prstGeom>
-          <a:solidFill>
-            <a:srgbClr val="FFFFFF"/>
-          </a:solidFill>
-          <a:ln>
-            <a:solidFill>
-              <a:srgbClr val="B7C98F"/>
-            </a:solidFill>
-          </a:ln>
-        </p:spPr>
-        <p:style>
-          <a:lnRef idx="1">
-            <a:schemeClr val="accent1"/>
-          </a:lnRef>
-          <a:fillRef idx="3">
-            <a:schemeClr val="accent1"/>
-          </a:fillRef>
-          <a:effectRef idx="2">
-            <a:schemeClr val="accent1"/>
-          </a:effectRef>
-          <a:fontRef idx="minor">
-            <a:schemeClr val="lt1"/>
-          </a:fontRef>
-        </p:style>
-        <p:txBody>
-          <a:bodyPr rtlCol="0" anchor="ctr"/>
-          <a:lstStyle/>
-          <a:p>
-            <a:pPr algn="ctr"/>
-          </a:p>
-        </p:txBody>
-      </p:sp>
-      <p:sp>
-        <p:nvSpPr>
-          <p:cNvPr id="9" name="TextBox 8"/>
-          <p:cNvSpPr txBox="1"/>
-          <p:nvPr/>
-        </p:nvSpPr>
-        <p:spPr>
-          <a:xfrm>
-            <a:off x="6126480" y="2011680"/>
-            <a:ext cx="5303520" cy="320040"/>
-          </a:xfrm>
-          <a:prstGeom prst="rect">
-            <a:avLst/>
-          </a:prstGeom>
-          <a:noFill/>
-        </p:spPr>
-        <p:txBody>
-          <a:bodyPr wrap="square">
-            <a:spAutoFit/>
-          </a:bodyPr>
-          <a:lstStyle/>
-          <a:p>
-            <a:pPr algn="l"/>
-            <a:r>
-              <a:rPr sz="1100" b="1">
-                <a:solidFill>
-                  <a:srgbClr val="5B7FA6"/>
-                </a:solidFill>
-                <a:latin typeface="Arial"/>
-              </a:rPr>
-              <a:t>SAY THIS</a:t>
-            </a:r>
-          </a:p>
-        </p:txBody>
-      </p:sp>
-      <p:sp>
-        <p:nvSpPr>
-          <p:cNvPr id="10" name="TextBox 9"/>
-          <p:cNvSpPr txBox="1"/>
-          <p:nvPr/>
-        </p:nvSpPr>
-        <p:spPr>
-          <a:xfrm>
-            <a:off x="6126480" y="2377440"/>
-            <a:ext cx="5303520" cy="2148840"/>
-          </a:xfrm>
-          <a:prstGeom prst="rect">
-            <a:avLst/>
-          </a:prstGeom>
-          <a:noFill/>
-        </p:spPr>
-        <p:txBody>
-          <a:bodyPr wrap="square">
-            <a:spAutoFit/>
-          </a:bodyPr>
-          <a:lstStyle/>
-          <a:p>
-            <a:r>
-              <a:rPr sz="1500" i="1">
-                <a:solidFill>
-                  <a:srgbClr val="222A18"/>
-                </a:solidFill>
-                <a:latin typeface="Arial"/>
-              </a:rPr>
-              <a:t>“Known limits: the occupation-to-skill mapping is our heuristic, one quarter is not a trend, course fees are unverified, and the parser misses synonyms. Next: verified course metadata, semantic CV parsing, and the user pilot. Everything planned is labelled as planned.”</a:t>
-            </a:r>
-          </a:p>
-        </p:txBody>
-      </p:sp>
-      <p:sp>
-        <p:nvSpPr>
-          <p:cNvPr id="11" name="TextBox 10"/>
-          <p:cNvSpPr txBox="1"/>
-          <p:nvPr/>
-        </p:nvSpPr>
-        <p:spPr>
-          <a:xfrm>
-            <a:off x="548640" y="4846320"/>
-            <a:ext cx="2743200" cy="274320"/>
-          </a:xfrm>
-          <a:prstGeom prst="rect">
-            <a:avLst/>
-          </a:prstGeom>
-          <a:noFill/>
-        </p:spPr>
-        <p:txBody>
-          <a:bodyPr wrap="square">
-            <a:spAutoFit/>
-          </a:bodyPr>
-          <a:lstStyle/>
-          <a:p>
-            <a:pPr algn="l"/>
-            <a:r>
-              <a:rPr sz="1000" b="1">
-                <a:solidFill>
-                  <a:srgbClr val="6B7560"/>
-                </a:solidFill>
-                <a:latin typeface="Arial"/>
-              </a:rPr>
-              <a:t>LINKS</a:t>
-            </a:r>
-          </a:p>
-        </p:txBody>
-      </p:sp>
-      <p:sp>
-        <p:nvSpPr>
-          <p:cNvPr id="12" name="TextBox 11"/>
-          <p:cNvSpPr txBox="1"/>
-          <p:nvPr/>
-        </p:nvSpPr>
-        <p:spPr>
-          <a:xfrm>
-            <a:off x="548640" y="5120640"/>
-            <a:ext cx="7589520" cy="1097280"/>
-          </a:xfrm>
-          <a:prstGeom prst="rect">
-            <a:avLst/>
-          </a:prstGeom>
-          <a:noFill/>
-        </p:spPr>
-        <p:txBody>
-          <a:bodyPr wrap="square">
-            <a:spAutoFit/>
-          </a:bodyPr>
-          <a:lstStyle/>
-          <a:p>
-            <a:r>
-              <a:rPr sz="1200">
-                <a:solidFill>
-                  <a:srgbClr val="5B7FA6"/>
-                </a:solidFill>
-                <a:latin typeface="Arial"/>
-                <a:hlinkClick r:id="rId2"/>
-              </a:rPr>
-              <a:t>README, limitations</a:t>
-            </a:r>
-          </a:p>
-          <a:p>
-            <a:r>
-              <a:rPr sz="1200">
-                <a:solidFill>
-                  <a:srgbClr val="5B7FA6"/>
-                </a:solidFill>
-                <a:latin typeface="Arial"/>
-                <a:hlinkClick r:id="rId3"/>
-              </a:rPr>
-              <a:t>Deck, slide 9 (roadmap)</a:t>
-            </a:r>
-          </a:p>
-        </p:txBody>
-      </p:sp>
-      <p:sp>
-        <p:nvSpPr>
-          <p:cNvPr id="13" name="Rectangle 12"/>
-          <p:cNvSpPr/>
-          <p:nvPr/>
-        </p:nvSpPr>
-        <p:spPr>
-          <a:xfrm>
-            <a:off x="8366760" y="5074920"/>
-            <a:ext cx="3291840" cy="1005840"/>
-          </a:xfrm>
-          <a:prstGeom prst="rect">
-            <a:avLst/>
-          </a:prstGeom>
-          <a:solidFill>
-            <a:srgbClr val="FBF4E4"/>
-          </a:solidFill>
-          <a:ln>
-            <a:solidFill>
-              <a:srgbClr val="E6D3A8"/>
-            </a:solidFill>
-          </a:ln>
-        </p:spPr>
-        <p:style>
-          <a:lnRef idx="1">
-            <a:schemeClr val="accent1"/>
-          </a:lnRef>
-          <a:fillRef idx="3">
-            <a:schemeClr val="accent1"/>
-          </a:fillRef>
-          <a:effectRef idx="2">
-            <a:schemeClr val="accent1"/>
-          </a:effectRef>
-          <a:fontRef idx="minor">
-            <a:schemeClr val="lt1"/>
-          </a:fontRef>
-        </p:style>
-        <p:txBody>
-          <a:bodyPr rtlCol="0" anchor="ctr" wrap="square" lIns="109728"/>
-          <a:lstStyle/>
-          <a:p>
-            <a:pPr algn="ctr"/>
-            <a:r>
-              <a:rPr sz="1100">
-                <a:solidFill>
-                  <a:srgbClr val="7A5A1E"/>
-                </a:solidFill>
-                <a:latin typeface="Arial"/>
-              </a:rPr>
               <a:t>Close on the product, not on the caveats.</a:t>
             </a:r>
           </a:p>
@@ -7080,7 +6631,7 @@
       </p:sp>
       <p:sp>
         <p:nvSpPr>
-          <p:cNvPr id="14" name="TextBox 13"/>
+          <p:cNvPr id="13" name="TextBox 12"/>
           <p:cNvSpPr txBox="1"/>
           <p:nvPr/>
         </p:nvSpPr>

</xml_diff>

<commit_message>
docs(team): strip the cue deck to title plus links
</commit_message>
<xml_diff>
--- a/team/CUE_DECK_4min10_to_6min.pptx
+++ b/team/CUE_DECK_4min10_to_6min.pptx
@@ -3103,7 +3103,7 @@
         <p:spPr>
           <a:xfrm>
             <a:off x="0" y="0"/>
-            <a:ext cx="12191695" cy="201168"/>
+            <a:ext cx="12191695" cy="182880"/>
           </a:xfrm>
           <a:prstGeom prst="rect">
             <a:avLst/>
@@ -3145,8 +3145,8 @@
         </p:nvSpPr>
         <p:spPr>
           <a:xfrm>
-            <a:off x="548640" y="502920"/>
-            <a:ext cx="11155680" cy="822960"/>
+            <a:off x="640080" y="685800"/>
+            <a:ext cx="10972800" cy="1097280"/>
           </a:xfrm>
           <a:prstGeom prst="rect">
             <a:avLst/>
@@ -3159,9 +3159,8 @@
           </a:bodyPr>
           <a:lstStyle/>
           <a:p>
-            <a:pPr algn="l"/>
-            <a:r>
-              <a:rPr sz="3200" b="1">
+            <a:r>
+              <a:rPr sz="3800" b="1">
                 <a:solidFill>
                   <a:srgbClr val="3F4A26"/>
                 </a:solidFill>
@@ -3174,59 +3173,14 @@
       </p:sp>
       <p:sp>
         <p:nvSpPr>
-          <p:cNvPr id="4" name="Rectangle 3"/>
-          <p:cNvSpPr/>
-          <p:nvPr/>
-        </p:nvSpPr>
-        <p:spPr>
-          <a:xfrm>
-            <a:off x="548640" y="1600200"/>
-            <a:ext cx="5029200" cy="2971800"/>
-          </a:xfrm>
-          <a:prstGeom prst="rect">
-            <a:avLst/>
-          </a:prstGeom>
-          <a:solidFill>
-            <a:srgbClr val="F2F5E9"/>
-          </a:solidFill>
-          <a:ln>
-            <a:solidFill>
-              <a:srgbClr val="D8DFCA"/>
-            </a:solidFill>
-          </a:ln>
-        </p:spPr>
-        <p:style>
-          <a:lnRef idx="1">
-            <a:schemeClr val="accent1"/>
-          </a:lnRef>
-          <a:fillRef idx="3">
-            <a:schemeClr val="accent1"/>
-          </a:fillRef>
-          <a:effectRef idx="2">
-            <a:schemeClr val="accent1"/>
-          </a:effectRef>
-          <a:fontRef idx="minor">
-            <a:schemeClr val="lt1"/>
-          </a:fontRef>
-        </p:style>
-        <p:txBody>
-          <a:bodyPr rtlCol="0" anchor="ctr"/>
-          <a:lstStyle/>
-          <a:p>
-            <a:pPr algn="ctr"/>
-          </a:p>
-        </p:txBody>
-      </p:sp>
-      <p:sp>
-        <p:nvSpPr>
-          <p:cNvPr id="5" name="TextBox 4"/>
+          <p:cNvPr id="4" name="TextBox 3"/>
           <p:cNvSpPr txBox="1"/>
           <p:nvPr/>
         </p:nvSpPr>
         <p:spPr>
           <a:xfrm>
-            <a:off x="777240" y="1755648"/>
-            <a:ext cx="4572000" cy="320040"/>
+            <a:off x="685800" y="2148840"/>
+            <a:ext cx="10789920" cy="3291840"/>
           </a:xfrm>
           <a:prstGeom prst="rect">
             <a:avLst/>
@@ -3239,29 +3193,68 @@
           </a:bodyPr>
           <a:lstStyle/>
           <a:p>
-            <a:pPr algn="l"/>
-            <a:r>
-              <a:rPr sz="1100" b="1">
-                <a:solidFill>
-                  <a:srgbClr val="6B7560"/>
+            <a:pPr>
+              <a:spcAft>
+                <a:spcPts val="1600"/>
+              </a:spcAft>
+            </a:pPr>
+            <a:r>
+              <a:rPr sz="2200" u="sng">
+                <a:solidFill>
+                  <a:srgbClr val="2F5B8A"/>
                 </a:solidFill>
                 <a:latin typeface="Arial"/>
+                <a:hlinkClick r:id="rId2"/>
               </a:rPr>
-              <a:t>ON SCREEN</a:t>
-            </a:r>
-          </a:p>
-        </p:txBody>
-      </p:sp>
-      <p:sp>
-        <p:nvSpPr>
-          <p:cNvPr id="6" name="TextBox 5"/>
+              <a:t>README - data sources</a:t>
+            </a:r>
+          </a:p>
+          <a:p>
+            <a:pPr>
+              <a:spcAft>
+                <a:spcPts val="1600"/>
+              </a:spcAft>
+            </a:pPr>
+            <a:r>
+              <a:rPr sz="2200" u="sng">
+                <a:solidFill>
+                  <a:srgbClr val="2F5B8A"/>
+                </a:solidFill>
+                <a:latin typeface="Arial"/>
+                <a:hlinkClick r:id="rId3"/>
+              </a:rPr>
+              <a:t>dosm_q2_2026.json</a:t>
+            </a:r>
+          </a:p>
+          <a:p>
+            <a:pPr>
+              <a:spcAft>
+                <a:spcPts val="1600"/>
+              </a:spcAft>
+            </a:pPr>
+            <a:r>
+              <a:rPr sz="2200" u="sng">
+                <a:solidFill>
+                  <a:srgbClr val="2F5B8A"/>
+                </a:solidFill>
+                <a:latin typeface="Arial"/>
+                <a:hlinkClick r:id="rId4"/>
+              </a:rPr>
+              <a:t>wef_future_jobs_2025.json</a:t>
+            </a:r>
+          </a:p>
+        </p:txBody>
+      </p:sp>
+      <p:sp>
+        <p:nvSpPr>
+          <p:cNvPr id="5" name="TextBox 4"/>
           <p:cNvSpPr txBox="1"/>
           <p:nvPr/>
         </p:nvSpPr>
         <p:spPr>
           <a:xfrm>
-            <a:off x="777240" y="2148840"/>
-            <a:ext cx="4572000" cy="2286000"/>
+            <a:off x="685800" y="6355080"/>
+            <a:ext cx="10789920" cy="320040"/>
           </a:xfrm>
           <a:prstGeom prst="rect">
             <a:avLst/>
@@ -3269,332 +3262,13 @@
           <a:noFill/>
         </p:spPr>
         <p:txBody>
-          <a:bodyPr wrap="square">
+          <a:bodyPr wrap="none">
             <a:spAutoFit/>
           </a:bodyPr>
           <a:lstStyle/>
           <a:p>
             <a:r>
-              <a:rPr sz="1600">
-                <a:solidFill>
-                  <a:srgbClr val="222A18"/>
-                </a:solidFill>
-                <a:latin typeface="Arial"/>
-              </a:rPr>
-              <a:t>· GitHub README, Data sources table</a:t>
-            </a:r>
-          </a:p>
-          <a:p>
-            <a:r>
-              <a:rPr sz="1600">
-                <a:solidFill>
-                  <a:srgbClr val="222A18"/>
-                </a:solidFill>
-                <a:latin typeface="Arial"/>
-              </a:rPr>
-              <a:t>· then data/trends/dosm_q2_2026.json</a:t>
-            </a:r>
-          </a:p>
-          <a:p>
-            <a:r>
-              <a:rPr sz="1600">
-                <a:solidFill>
-                  <a:srgbClr val="222A18"/>
-                </a:solidFill>
-                <a:latin typeface="Arial"/>
-              </a:rPr>
-              <a:t>· stop on source_url, latest_released, extraction_note</a:t>
-            </a:r>
-          </a:p>
-        </p:txBody>
-      </p:sp>
-      <p:sp>
-        <p:nvSpPr>
-          <p:cNvPr id="7" name="Rectangle 6"/>
-          <p:cNvSpPr/>
-          <p:nvPr/>
-        </p:nvSpPr>
-        <p:spPr>
-          <a:xfrm>
-            <a:off x="5897880" y="1600200"/>
-            <a:ext cx="5760720" cy="2971800"/>
-          </a:xfrm>
-          <a:prstGeom prst="rect">
-            <a:avLst/>
-          </a:prstGeom>
-          <a:solidFill>
-            <a:srgbClr val="FFFFFF"/>
-          </a:solidFill>
-          <a:ln>
-            <a:solidFill>
-              <a:srgbClr val="B7C98F"/>
-            </a:solidFill>
-          </a:ln>
-        </p:spPr>
-        <p:style>
-          <a:lnRef idx="1">
-            <a:schemeClr val="accent1"/>
-          </a:lnRef>
-          <a:fillRef idx="3">
-            <a:schemeClr val="accent1"/>
-          </a:fillRef>
-          <a:effectRef idx="2">
-            <a:schemeClr val="accent1"/>
-          </a:effectRef>
-          <a:fontRef idx="minor">
-            <a:schemeClr val="lt1"/>
-          </a:fontRef>
-        </p:style>
-        <p:txBody>
-          <a:bodyPr rtlCol="0" anchor="ctr"/>
-          <a:lstStyle/>
-          <a:p>
-            <a:pPr algn="ctr"/>
-          </a:p>
-        </p:txBody>
-      </p:sp>
-      <p:sp>
-        <p:nvSpPr>
-          <p:cNvPr id="8" name="TextBox 7"/>
-          <p:cNvSpPr txBox="1"/>
-          <p:nvPr/>
-        </p:nvSpPr>
-        <p:spPr>
-          <a:xfrm>
-            <a:off x="6126480" y="1755648"/>
-            <a:ext cx="5303520" cy="320040"/>
-          </a:xfrm>
-          <a:prstGeom prst="rect">
-            <a:avLst/>
-          </a:prstGeom>
-          <a:noFill/>
-        </p:spPr>
-        <p:txBody>
-          <a:bodyPr wrap="square">
-            <a:spAutoFit/>
-          </a:bodyPr>
-          <a:lstStyle/>
-          <a:p>
-            <a:pPr algn="l"/>
-            <a:r>
-              <a:rPr sz="1100" b="1">
-                <a:solidFill>
-                  <a:srgbClr val="5B7FA6"/>
-                </a:solidFill>
-                <a:latin typeface="Arial"/>
-              </a:rPr>
-              <a:t>SAY THIS</a:t>
-            </a:r>
-          </a:p>
-        </p:txBody>
-      </p:sp>
-      <p:sp>
-        <p:nvSpPr>
-          <p:cNvPr id="9" name="TextBox 8"/>
-          <p:cNvSpPr txBox="1"/>
-          <p:nvPr/>
-        </p:nvSpPr>
-        <p:spPr>
-          <a:xfrm>
-            <a:off x="6126480" y="2148840"/>
-            <a:ext cx="5303520" cy="2286000"/>
-          </a:xfrm>
-          <a:prstGeom prst="rect">
-            <a:avLst/>
-          </a:prstGeom>
-          <a:noFill/>
-        </p:spPr>
-        <p:txBody>
-          <a:bodyPr wrap="square">
-            <a:spAutoFit/>
-          </a:bodyPr>
-          <a:lstStyle/>
-          <a:p>
-            <a:r>
-              <a:rPr sz="1600" i="1">
-                <a:solidFill>
-                  <a:srgbClr val="222A18"/>
-                </a:solidFill>
-                <a:latin typeface="Arial"/>
-              </a:rPr>
-              <a:t>“Three sources, kept separate. DOSM publishes advertised vacancies by occupation - we transcribe the counts by hand and keep the link, the date and a note on what it cannot support, inside the JSON itself.”</a:t>
-            </a:r>
-          </a:p>
-        </p:txBody>
-      </p:sp>
-      <p:sp>
-        <p:nvSpPr>
-          <p:cNvPr id="10" name="TextBox 9"/>
-          <p:cNvSpPr txBox="1"/>
-          <p:nvPr/>
-        </p:nvSpPr>
-        <p:spPr>
-          <a:xfrm>
-            <a:off x="548640" y="4800600"/>
-            <a:ext cx="2743200" cy="274320"/>
-          </a:xfrm>
-          <a:prstGeom prst="rect">
-            <a:avLst/>
-          </a:prstGeom>
-          <a:noFill/>
-        </p:spPr>
-        <p:txBody>
-          <a:bodyPr wrap="square">
-            <a:spAutoFit/>
-          </a:bodyPr>
-          <a:lstStyle/>
-          <a:p>
-            <a:pPr algn="l"/>
-            <a:r>
-              <a:rPr sz="1000" b="1">
-                <a:solidFill>
-                  <a:srgbClr val="6B7560"/>
-                </a:solidFill>
-                <a:latin typeface="Arial"/>
-              </a:rPr>
-              <a:t>LINKS</a:t>
-            </a:r>
-          </a:p>
-        </p:txBody>
-      </p:sp>
-      <p:sp>
-        <p:nvSpPr>
-          <p:cNvPr id="11" name="TextBox 10"/>
-          <p:cNvSpPr txBox="1"/>
-          <p:nvPr/>
-        </p:nvSpPr>
-        <p:spPr>
-          <a:xfrm>
-            <a:off x="548640" y="5074920"/>
-            <a:ext cx="7589520" cy="1097280"/>
-          </a:xfrm>
-          <a:prstGeom prst="rect">
-            <a:avLst/>
-          </a:prstGeom>
-          <a:noFill/>
-        </p:spPr>
-        <p:txBody>
-          <a:bodyPr wrap="square">
-            <a:spAutoFit/>
-          </a:bodyPr>
-          <a:lstStyle/>
-          <a:p>
-            <a:r>
-              <a:rPr sz="1300">
-                <a:solidFill>
-                  <a:srgbClr val="5B7FA6"/>
-                </a:solidFill>
-                <a:latin typeface="Arial"/>
-                <a:hlinkClick r:id="rId2"/>
-              </a:rPr>
-              <a:t>README data sources</a:t>
-            </a:r>
-          </a:p>
-          <a:p>
-            <a:r>
-              <a:rPr sz="1300">
-                <a:solidFill>
-                  <a:srgbClr val="5B7FA6"/>
-                </a:solidFill>
-                <a:latin typeface="Arial"/>
-                <a:hlinkClick r:id="rId3"/>
-              </a:rPr>
-              <a:t>dosm_q2_2026.json</a:t>
-            </a:r>
-          </a:p>
-          <a:p>
-            <a:r>
-              <a:rPr sz="1300">
-                <a:solidFill>
-                  <a:srgbClr val="5B7FA6"/>
-                </a:solidFill>
-                <a:latin typeface="Arial"/>
-                <a:hlinkClick r:id="rId4"/>
-              </a:rPr>
-              <a:t>wef_future_jobs_2025.json</a:t>
-            </a:r>
-          </a:p>
-        </p:txBody>
-      </p:sp>
-      <p:sp>
-        <p:nvSpPr>
-          <p:cNvPr id="12" name="Rectangle 11"/>
-          <p:cNvSpPr/>
-          <p:nvPr/>
-        </p:nvSpPr>
-        <p:spPr>
-          <a:xfrm>
-            <a:off x="8366760" y="5029200"/>
-            <a:ext cx="3291840" cy="1051560"/>
-          </a:xfrm>
-          <a:prstGeom prst="rect">
-            <a:avLst/>
-          </a:prstGeom>
-          <a:solidFill>
-            <a:srgbClr val="FBF4E4"/>
-          </a:solidFill>
-          <a:ln>
-            <a:solidFill>
-              <a:srgbClr val="E6D3A8"/>
-            </a:solidFill>
-          </a:ln>
-        </p:spPr>
-        <p:style>
-          <a:lnRef idx="1">
-            <a:schemeClr val="accent1"/>
-          </a:lnRef>
-          <a:fillRef idx="3">
-            <a:schemeClr val="accent1"/>
-          </a:fillRef>
-          <a:effectRef idx="2">
-            <a:schemeClr val="accent1"/>
-          </a:effectRef>
-          <a:fontRef idx="minor">
-            <a:schemeClr val="lt1"/>
-          </a:fontRef>
-        </p:style>
-        <p:txBody>
-          <a:bodyPr rtlCol="0" anchor="ctr" wrap="square" lIns="109728"/>
-          <a:lstStyle/>
-          <a:p>
-            <a:pPr algn="ctr"/>
-            <a:r>
-              <a:rPr sz="1200">
-                <a:solidFill>
-                  <a:srgbClr val="7A5A1E"/>
-                </a:solidFill>
-                <a:latin typeface="Arial"/>
-              </a:rPr>
-              <a:t>Hold 2 seconds on extraction_note - it is the honesty proof.</a:t>
-            </a:r>
-          </a:p>
-        </p:txBody>
-      </p:sp>
-      <p:sp>
-        <p:nvSpPr>
-          <p:cNvPr id="13" name="TextBox 12"/>
-          <p:cNvSpPr txBox="1"/>
-          <p:nvPr/>
-        </p:nvSpPr>
-        <p:spPr>
-          <a:xfrm>
-            <a:off x="548640" y="6400800"/>
-            <a:ext cx="11155680" cy="274320"/>
-          </a:xfrm>
-          <a:prstGeom prst="rect">
-            <a:avLst/>
-          </a:prstGeom>
-          <a:noFill/>
-        </p:spPr>
-        <p:txBody>
-          <a:bodyPr wrap="square">
-            <a:spAutoFit/>
-          </a:bodyPr>
-          <a:lstStyle/>
-          <a:p>
-            <a:pPr algn="l"/>
-            <a:r>
-              <a:rPr sz="900" b="0">
+              <a:rPr sz="1000">
                 <a:solidFill>
                   <a:srgbClr val="6B7560"/>
                 </a:solidFill>
@@ -3632,7 +3306,7 @@
         <p:spPr>
           <a:xfrm>
             <a:off x="0" y="0"/>
-            <a:ext cx="12191695" cy="201168"/>
+            <a:ext cx="12191695" cy="182880"/>
           </a:xfrm>
           <a:prstGeom prst="rect">
             <a:avLst/>
@@ -3674,8 +3348,8 @@
         </p:nvSpPr>
         <p:spPr>
           <a:xfrm>
-            <a:off x="548640" y="502920"/>
-            <a:ext cx="11155680" cy="822960"/>
+            <a:off x="640080" y="685800"/>
+            <a:ext cx="10972800" cy="1097280"/>
           </a:xfrm>
           <a:prstGeom prst="rect">
             <a:avLst/>
@@ -3688,9 +3362,8 @@
           </a:bodyPr>
           <a:lstStyle/>
           <a:p>
-            <a:pPr algn="l"/>
-            <a:r>
-              <a:rPr sz="3200" b="1">
+            <a:r>
+              <a:rPr sz="3800" b="1">
                 <a:solidFill>
                   <a:srgbClr val="3F4A26"/>
                 </a:solidFill>
@@ -3703,59 +3376,14 @@
       </p:sp>
       <p:sp>
         <p:nvSpPr>
-          <p:cNvPr id="4" name="Rectangle 3"/>
-          <p:cNvSpPr/>
-          <p:nvPr/>
-        </p:nvSpPr>
-        <p:spPr>
-          <a:xfrm>
-            <a:off x="548640" y="1600200"/>
-            <a:ext cx="5029200" cy="2971800"/>
-          </a:xfrm>
-          <a:prstGeom prst="rect">
-            <a:avLst/>
-          </a:prstGeom>
-          <a:solidFill>
-            <a:srgbClr val="F2F5E9"/>
-          </a:solidFill>
-          <a:ln>
-            <a:solidFill>
-              <a:srgbClr val="D8DFCA"/>
-            </a:solidFill>
-          </a:ln>
-        </p:spPr>
-        <p:style>
-          <a:lnRef idx="1">
-            <a:schemeClr val="accent1"/>
-          </a:lnRef>
-          <a:fillRef idx="3">
-            <a:schemeClr val="accent1"/>
-          </a:fillRef>
-          <a:effectRef idx="2">
-            <a:schemeClr val="accent1"/>
-          </a:effectRef>
-          <a:fontRef idx="minor">
-            <a:schemeClr val="lt1"/>
-          </a:fontRef>
-        </p:style>
-        <p:txBody>
-          <a:bodyPr rtlCol="0" anchor="ctr"/>
-          <a:lstStyle/>
-          <a:p>
-            <a:pPr algn="ctr"/>
-          </a:p>
-        </p:txBody>
-      </p:sp>
-      <p:sp>
-        <p:nvSpPr>
-          <p:cNvPr id="5" name="TextBox 4"/>
+          <p:cNvPr id="4" name="TextBox 3"/>
           <p:cNvSpPr txBox="1"/>
           <p:nvPr/>
         </p:nvSpPr>
         <p:spPr>
           <a:xfrm>
-            <a:off x="777240" y="1755648"/>
-            <a:ext cx="4572000" cy="320040"/>
+            <a:off x="685800" y="2148840"/>
+            <a:ext cx="10789920" cy="3291840"/>
           </a:xfrm>
           <a:prstGeom prst="rect">
             <a:avLst/>
@@ -3768,29 +3396,68 @@
           </a:bodyPr>
           <a:lstStyle/>
           <a:p>
-            <a:pPr algn="l"/>
-            <a:r>
-              <a:rPr sz="1100" b="1">
-                <a:solidFill>
-                  <a:srgbClr val="6B7560"/>
+            <a:pPr>
+              <a:spcAft>
+                <a:spcPts val="1600"/>
+              </a:spcAft>
+            </a:pPr>
+            <a:r>
+              <a:rPr sz="2200" u="sng">
+                <a:solidFill>
+                  <a:srgbClr val="2F5B8A"/>
                 </a:solidFill>
                 <a:latin typeface="Arial"/>
+                <a:hlinkClick r:id="rId2"/>
               </a:rPr>
-              <a:t>ON SCREEN</a:t>
-            </a:r>
-          </a:p>
-        </p:txBody>
-      </p:sp>
-      <p:sp>
-        <p:nvSpPr>
-          <p:cNvPr id="6" name="TextBox 5"/>
+              <a:t>src/utils.py - scoring</a:t>
+            </a:r>
+          </a:p>
+          <a:p>
+            <a:pPr>
+              <a:spcAft>
+                <a:spcPts val="1600"/>
+              </a:spcAft>
+            </a:pPr>
+            <a:r>
+              <a:rPr sz="2200" u="sng">
+                <a:solidFill>
+                  <a:srgbClr val="2F5B8A"/>
+                </a:solidFill>
+                <a:latin typeface="Arial"/>
+                <a:hlinkClick r:id="rId3"/>
+              </a:rPr>
+              <a:t>src/cv.py - parsing</a:t>
+            </a:r>
+          </a:p>
+          <a:p>
+            <a:pPr>
+              <a:spcAft>
+                <a:spcPts val="1600"/>
+              </a:spcAft>
+            </a:pPr>
+            <a:r>
+              <a:rPr sz="2200" u="sng">
+                <a:solidFill>
+                  <a:srgbClr val="2F5B8A"/>
+                </a:solidFill>
+                <a:latin typeface="Arial"/>
+                <a:hlinkClick r:id="rId4"/>
+              </a:rPr>
+              <a:t>src/trends.py</a:t>
+            </a:r>
+          </a:p>
+        </p:txBody>
+      </p:sp>
+      <p:sp>
+        <p:nvSpPr>
+          <p:cNvPr id="5" name="TextBox 4"/>
           <p:cNvSpPr txBox="1"/>
           <p:nvPr/>
         </p:nvSpPr>
         <p:spPr>
           <a:xfrm>
-            <a:off x="777240" y="2148840"/>
-            <a:ext cx="4572000" cy="2286000"/>
+            <a:off x="685800" y="6355080"/>
+            <a:ext cx="10789920" cy="320040"/>
           </a:xfrm>
           <a:prstGeom prst="rect">
             <a:avLst/>
@@ -3798,321 +3465,13 @@
           <a:noFill/>
         </p:spPr>
         <p:txBody>
-          <a:bodyPr wrap="square">
+          <a:bodyPr wrap="none">
             <a:spAutoFit/>
           </a:bodyPr>
           <a:lstStyle/>
           <a:p>
             <a:r>
-              <a:rPr sz="1600">
-                <a:solidFill>
-                  <a:srgbClr val="222A18"/>
-                </a:solidFill>
-                <a:latin typeface="Arial"/>
-              </a:rPr>
-              <a:t>· App results page - point at the score</a:t>
-            </a:r>
-          </a:p>
-          <a:p>
-            <a:r>
-              <a:rPr sz="1600">
-                <a:solidFill>
-                  <a:srgbClr val="222A18"/>
-                </a:solidFill>
-                <a:latin typeface="Arial"/>
-              </a:rPr>
-              <a:t>· then src/utils.py - the scoring function</a:t>
-            </a:r>
-          </a:p>
-        </p:txBody>
-      </p:sp>
-      <p:sp>
-        <p:nvSpPr>
-          <p:cNvPr id="7" name="Rectangle 6"/>
-          <p:cNvSpPr/>
-          <p:nvPr/>
-        </p:nvSpPr>
-        <p:spPr>
-          <a:xfrm>
-            <a:off x="5897880" y="1600200"/>
-            <a:ext cx="5760720" cy="2971800"/>
-          </a:xfrm>
-          <a:prstGeom prst="rect">
-            <a:avLst/>
-          </a:prstGeom>
-          <a:solidFill>
-            <a:srgbClr val="FFFFFF"/>
-          </a:solidFill>
-          <a:ln>
-            <a:solidFill>
-              <a:srgbClr val="B7C98F"/>
-            </a:solidFill>
-          </a:ln>
-        </p:spPr>
-        <p:style>
-          <a:lnRef idx="1">
-            <a:schemeClr val="accent1"/>
-          </a:lnRef>
-          <a:fillRef idx="3">
-            <a:schemeClr val="accent1"/>
-          </a:fillRef>
-          <a:effectRef idx="2">
-            <a:schemeClr val="accent1"/>
-          </a:effectRef>
-          <a:fontRef idx="minor">
-            <a:schemeClr val="lt1"/>
-          </a:fontRef>
-        </p:style>
-        <p:txBody>
-          <a:bodyPr rtlCol="0" anchor="ctr"/>
-          <a:lstStyle/>
-          <a:p>
-            <a:pPr algn="ctr"/>
-          </a:p>
-        </p:txBody>
-      </p:sp>
-      <p:sp>
-        <p:nvSpPr>
-          <p:cNvPr id="8" name="TextBox 7"/>
-          <p:cNvSpPr txBox="1"/>
-          <p:nvPr/>
-        </p:nvSpPr>
-        <p:spPr>
-          <a:xfrm>
-            <a:off x="6126480" y="1755648"/>
-            <a:ext cx="5303520" cy="320040"/>
-          </a:xfrm>
-          <a:prstGeom prst="rect">
-            <a:avLst/>
-          </a:prstGeom>
-          <a:noFill/>
-        </p:spPr>
-        <p:txBody>
-          <a:bodyPr wrap="square">
-            <a:spAutoFit/>
-          </a:bodyPr>
-          <a:lstStyle/>
-          <a:p>
-            <a:pPr algn="l"/>
-            <a:r>
-              <a:rPr sz="1100" b="1">
-                <a:solidFill>
-                  <a:srgbClr val="5B7FA6"/>
-                </a:solidFill>
-                <a:latin typeface="Arial"/>
-              </a:rPr>
-              <a:t>SAY THIS</a:t>
-            </a:r>
-          </a:p>
-        </p:txBody>
-      </p:sp>
-      <p:sp>
-        <p:nvSpPr>
-          <p:cNvPr id="9" name="TextBox 8"/>
-          <p:cNvSpPr txBox="1"/>
-          <p:nvPr/>
-        </p:nvSpPr>
-        <p:spPr>
-          <a:xfrm>
-            <a:off x="6126480" y="2148840"/>
-            <a:ext cx="5303520" cy="2286000"/>
-          </a:xfrm>
-          <a:prstGeom prst="rect">
-            <a:avLst/>
-          </a:prstGeom>
-          <a:noFill/>
-        </p:spPr>
-        <p:txBody>
-          <a:bodyPr wrap="square">
-            <a:spAutoFit/>
-          </a:bodyPr>
-          <a:lstStyle/>
-          <a:p>
-            <a:r>
-              <a:rPr sz="1600" i="1">
-                <a:solidFill>
-                  <a:srgbClr val="222A18"/>
-                </a:solidFill>
-                <a:latin typeface="Arial"/>
-              </a:rPr>
-              <a:t>“The running application has no model. Parsing is keyword matching, scoring is five weighted rules in this file, and the pathway is a lookup over a curated catalogue. Same profile, same answer, every time - and every point is explainable.”</a:t>
-            </a:r>
-          </a:p>
-        </p:txBody>
-      </p:sp>
-      <p:sp>
-        <p:nvSpPr>
-          <p:cNvPr id="10" name="TextBox 9"/>
-          <p:cNvSpPr txBox="1"/>
-          <p:nvPr/>
-        </p:nvSpPr>
-        <p:spPr>
-          <a:xfrm>
-            <a:off x="548640" y="4800600"/>
-            <a:ext cx="2743200" cy="274320"/>
-          </a:xfrm>
-          <a:prstGeom prst="rect">
-            <a:avLst/>
-          </a:prstGeom>
-          <a:noFill/>
-        </p:spPr>
-        <p:txBody>
-          <a:bodyPr wrap="square">
-            <a:spAutoFit/>
-          </a:bodyPr>
-          <a:lstStyle/>
-          <a:p>
-            <a:pPr algn="l"/>
-            <a:r>
-              <a:rPr sz="1000" b="1">
-                <a:solidFill>
-                  <a:srgbClr val="6B7560"/>
-                </a:solidFill>
-                <a:latin typeface="Arial"/>
-              </a:rPr>
-              <a:t>LINKS</a:t>
-            </a:r>
-          </a:p>
-        </p:txBody>
-      </p:sp>
-      <p:sp>
-        <p:nvSpPr>
-          <p:cNvPr id="11" name="TextBox 10"/>
-          <p:cNvSpPr txBox="1"/>
-          <p:nvPr/>
-        </p:nvSpPr>
-        <p:spPr>
-          <a:xfrm>
-            <a:off x="548640" y="5074920"/>
-            <a:ext cx="7589520" cy="1097280"/>
-          </a:xfrm>
-          <a:prstGeom prst="rect">
-            <a:avLst/>
-          </a:prstGeom>
-          <a:noFill/>
-        </p:spPr>
-        <p:txBody>
-          <a:bodyPr wrap="square">
-            <a:spAutoFit/>
-          </a:bodyPr>
-          <a:lstStyle/>
-          <a:p>
-            <a:r>
-              <a:rPr sz="1300">
-                <a:solidFill>
-                  <a:srgbClr val="5B7FA6"/>
-                </a:solidFill>
-                <a:latin typeface="Arial"/>
-                <a:hlinkClick r:id="rId2"/>
-              </a:rPr>
-              <a:t>src/utils.py (scoring)</a:t>
-            </a:r>
-          </a:p>
-          <a:p>
-            <a:r>
-              <a:rPr sz="1300">
-                <a:solidFill>
-                  <a:srgbClr val="5B7FA6"/>
-                </a:solidFill>
-                <a:latin typeface="Arial"/>
-                <a:hlinkClick r:id="rId3"/>
-              </a:rPr>
-              <a:t>src/cv.py (parsing)</a:t>
-            </a:r>
-          </a:p>
-          <a:p>
-            <a:r>
-              <a:rPr sz="1300">
-                <a:solidFill>
-                  <a:srgbClr val="5B7FA6"/>
-                </a:solidFill>
-                <a:latin typeface="Arial"/>
-                <a:hlinkClick r:id="rId4"/>
-              </a:rPr>
-              <a:t>src/trends.py</a:t>
-            </a:r>
-          </a:p>
-        </p:txBody>
-      </p:sp>
-      <p:sp>
-        <p:nvSpPr>
-          <p:cNvPr id="12" name="Rectangle 11"/>
-          <p:cNvSpPr/>
-          <p:nvPr/>
-        </p:nvSpPr>
-        <p:spPr>
-          <a:xfrm>
-            <a:off x="8366760" y="5029200"/>
-            <a:ext cx="3291840" cy="1051560"/>
-          </a:xfrm>
-          <a:prstGeom prst="rect">
-            <a:avLst/>
-          </a:prstGeom>
-          <a:solidFill>
-            <a:srgbClr val="FBF4E4"/>
-          </a:solidFill>
-          <a:ln>
-            <a:solidFill>
-              <a:srgbClr val="E6D3A8"/>
-            </a:solidFill>
-          </a:ln>
-        </p:spPr>
-        <p:style>
-          <a:lnRef idx="1">
-            <a:schemeClr val="accent1"/>
-          </a:lnRef>
-          <a:fillRef idx="3">
-            <a:schemeClr val="accent1"/>
-          </a:fillRef>
-          <a:effectRef idx="2">
-            <a:schemeClr val="accent1"/>
-          </a:effectRef>
-          <a:fontRef idx="minor">
-            <a:schemeClr val="lt1"/>
-          </a:fontRef>
-        </p:style>
-        <p:txBody>
-          <a:bodyPr rtlCol="0" anchor="ctr" wrap="square" lIns="109728"/>
-          <a:lstStyle/>
-          <a:p>
-            <a:pPr algn="ctr"/>
-            <a:r>
-              <a:rPr sz="1200">
-                <a:solidFill>
-                  <a:srgbClr val="7A5A1E"/>
-                </a:solidFill>
-                <a:latin typeface="Arial"/>
-              </a:rPr>
-              <a:t>Never say AI scores the user. AI is not on the request path.</a:t>
-            </a:r>
-          </a:p>
-        </p:txBody>
-      </p:sp>
-      <p:sp>
-        <p:nvSpPr>
-          <p:cNvPr id="13" name="TextBox 12"/>
-          <p:cNvSpPr txBox="1"/>
-          <p:nvPr/>
-        </p:nvSpPr>
-        <p:spPr>
-          <a:xfrm>
-            <a:off x="548640" y="6400800"/>
-            <a:ext cx="11155680" cy="274320"/>
-          </a:xfrm>
-          <a:prstGeom prst="rect">
-            <a:avLst/>
-          </a:prstGeom>
-          <a:noFill/>
-        </p:spPr>
-        <p:txBody>
-          <a:bodyPr wrap="square">
-            <a:spAutoFit/>
-          </a:bodyPr>
-          <a:lstStyle/>
-          <a:p>
-            <a:pPr algn="l"/>
-            <a:r>
-              <a:rPr sz="900" b="0">
+              <a:rPr sz="1000">
                 <a:solidFill>
                   <a:srgbClr val="6B7560"/>
                 </a:solidFill>
@@ -4150,7 +3509,7 @@
         <p:spPr>
           <a:xfrm>
             <a:off x="0" y="0"/>
-            <a:ext cx="12191695" cy="201168"/>
+            <a:ext cx="12191695" cy="182880"/>
           </a:xfrm>
           <a:prstGeom prst="rect">
             <a:avLst/>
@@ -4192,8 +3551,8 @@
         </p:nvSpPr>
         <p:spPr>
           <a:xfrm>
-            <a:off x="548640" y="502920"/>
-            <a:ext cx="11155680" cy="822960"/>
+            <a:off x="640080" y="685800"/>
+            <a:ext cx="10972800" cy="1097280"/>
           </a:xfrm>
           <a:prstGeom prst="rect">
             <a:avLst/>
@@ -4206,9 +3565,8 @@
           </a:bodyPr>
           <a:lstStyle/>
           <a:p>
-            <a:pPr algn="l"/>
-            <a:r>
-              <a:rPr sz="3200" b="1">
+            <a:r>
+              <a:rPr sz="3800" b="1">
                 <a:solidFill>
                   <a:srgbClr val="3F4A26"/>
                 </a:solidFill>
@@ -4221,59 +3579,14 @@
       </p:sp>
       <p:sp>
         <p:nvSpPr>
-          <p:cNvPr id="4" name="Rectangle 3"/>
-          <p:cNvSpPr/>
-          <p:nvPr/>
-        </p:nvSpPr>
-        <p:spPr>
-          <a:xfrm>
-            <a:off x="548640" y="1600200"/>
-            <a:ext cx="5029200" cy="2971800"/>
-          </a:xfrm>
-          <a:prstGeom prst="rect">
-            <a:avLst/>
-          </a:prstGeom>
-          <a:solidFill>
-            <a:srgbClr val="F2F5E9"/>
-          </a:solidFill>
-          <a:ln>
-            <a:solidFill>
-              <a:srgbClr val="D8DFCA"/>
-            </a:solidFill>
-          </a:ln>
-        </p:spPr>
-        <p:style>
-          <a:lnRef idx="1">
-            <a:schemeClr val="accent1"/>
-          </a:lnRef>
-          <a:fillRef idx="3">
-            <a:schemeClr val="accent1"/>
-          </a:fillRef>
-          <a:effectRef idx="2">
-            <a:schemeClr val="accent1"/>
-          </a:effectRef>
-          <a:fontRef idx="minor">
-            <a:schemeClr val="lt1"/>
-          </a:fontRef>
-        </p:style>
-        <p:txBody>
-          <a:bodyPr rtlCol="0" anchor="ctr"/>
-          <a:lstStyle/>
-          <a:p>
-            <a:pPr algn="ctr"/>
-          </a:p>
-        </p:txBody>
-      </p:sp>
-      <p:sp>
-        <p:nvSpPr>
-          <p:cNvPr id="5" name="TextBox 4"/>
+          <p:cNvPr id="4" name="TextBox 3"/>
           <p:cNvSpPr txBox="1"/>
           <p:nvPr/>
         </p:nvSpPr>
         <p:spPr>
           <a:xfrm>
-            <a:off x="777240" y="1755648"/>
-            <a:ext cx="4572000" cy="320040"/>
+            <a:off x="685800" y="2148840"/>
+            <a:ext cx="10789920" cy="3291840"/>
           </a:xfrm>
           <a:prstGeom prst="rect">
             <a:avLst/>
@@ -4286,29 +3599,51 @@
           </a:bodyPr>
           <a:lstStyle/>
           <a:p>
-            <a:pPr algn="l"/>
-            <a:r>
-              <a:rPr sz="1100" b="1">
-                <a:solidFill>
-                  <a:srgbClr val="6B7560"/>
+            <a:pPr>
+              <a:spcAft>
+                <a:spcPts val="1600"/>
+              </a:spcAft>
+            </a:pPr>
+            <a:r>
+              <a:rPr sz="2200" u="sng">
+                <a:solidFill>
+                  <a:srgbClr val="2F5B8A"/>
                 </a:solidFill>
                 <a:latin typeface="Arial"/>
+                <a:hlinkClick r:id="rId2"/>
               </a:rPr>
-              <a:t>ON SCREEN</a:t>
-            </a:r>
-          </a:p>
-        </p:txBody>
-      </p:sp>
-      <p:sp>
-        <p:nvSpPr>
-          <p:cNvPr id="6" name="TextBox 5"/>
+              <a:t>tests folder (54 tests)</a:t>
+            </a:r>
+          </a:p>
+          <a:p>
+            <a:pPr>
+              <a:spcAft>
+                <a:spcPts val="1600"/>
+              </a:spcAft>
+            </a:pPr>
+            <a:r>
+              <a:rPr sz="2200" u="sng">
+                <a:solidFill>
+                  <a:srgbClr val="2F5B8A"/>
+                </a:solidFill>
+                <a:latin typeface="Arial"/>
+                <a:hlinkClick r:id="rId3"/>
+              </a:rPr>
+              <a:t>Technical Declaration 4.3</a:t>
+            </a:r>
+          </a:p>
+        </p:txBody>
+      </p:sp>
+      <p:sp>
+        <p:nvSpPr>
+          <p:cNvPr id="5" name="TextBox 4"/>
           <p:cNvSpPr txBox="1"/>
           <p:nvPr/>
         </p:nvSpPr>
         <p:spPr>
           <a:xfrm>
-            <a:off x="777240" y="2148840"/>
-            <a:ext cx="4572000" cy="2286000"/>
+            <a:off x="685800" y="6355080"/>
+            <a:ext cx="10789920" cy="320040"/>
           </a:xfrm>
           <a:prstGeom prst="rect">
             <a:avLst/>
@@ -4316,320 +3651,13 @@
           <a:noFill/>
         </p:spPr>
         <p:txBody>
-          <a:bodyPr wrap="square">
+          <a:bodyPr wrap="none">
             <a:spAutoFit/>
           </a:bodyPr>
           <a:lstStyle/>
           <a:p>
             <a:r>
-              <a:rPr sz="1600">
-                <a:solidFill>
-                  <a:srgbClr val="222A18"/>
-                </a:solidFill>
-                <a:latin typeface="Arial"/>
-              </a:rPr>
-              <a:t>· Terminal, already cd'd into the repo</a:t>
-            </a:r>
-          </a:p>
-          <a:p>
-            <a:r>
-              <a:rPr sz="1600">
-                <a:solidFill>
-                  <a:srgbClr val="222A18"/>
-                </a:solidFill>
-                <a:latin typeface="Arial"/>
-              </a:rPr>
-              <a:t>· python -m unittest discover -s tests -p "test_*.py"</a:t>
-            </a:r>
-          </a:p>
-          <a:p>
-            <a:r>
-              <a:rPr sz="1600">
-                <a:solidFill>
-                  <a:srgbClr val="222A18"/>
-                </a:solidFill>
-                <a:latin typeface="Arial"/>
-              </a:rPr>
-              <a:t>· let it finish: 54 tests, OK</a:t>
-            </a:r>
-          </a:p>
-        </p:txBody>
-      </p:sp>
-      <p:sp>
-        <p:nvSpPr>
-          <p:cNvPr id="7" name="Rectangle 6"/>
-          <p:cNvSpPr/>
-          <p:nvPr/>
-        </p:nvSpPr>
-        <p:spPr>
-          <a:xfrm>
-            <a:off x="5897880" y="1600200"/>
-            <a:ext cx="5760720" cy="2971800"/>
-          </a:xfrm>
-          <a:prstGeom prst="rect">
-            <a:avLst/>
-          </a:prstGeom>
-          <a:solidFill>
-            <a:srgbClr val="FFFFFF"/>
-          </a:solidFill>
-          <a:ln>
-            <a:solidFill>
-              <a:srgbClr val="B7C98F"/>
-            </a:solidFill>
-          </a:ln>
-        </p:spPr>
-        <p:style>
-          <a:lnRef idx="1">
-            <a:schemeClr val="accent1"/>
-          </a:lnRef>
-          <a:fillRef idx="3">
-            <a:schemeClr val="accent1"/>
-          </a:fillRef>
-          <a:effectRef idx="2">
-            <a:schemeClr val="accent1"/>
-          </a:effectRef>
-          <a:fontRef idx="minor">
-            <a:schemeClr val="lt1"/>
-          </a:fontRef>
-        </p:style>
-        <p:txBody>
-          <a:bodyPr rtlCol="0" anchor="ctr"/>
-          <a:lstStyle/>
-          <a:p>
-            <a:pPr algn="ctr"/>
-          </a:p>
-        </p:txBody>
-      </p:sp>
-      <p:sp>
-        <p:nvSpPr>
-          <p:cNvPr id="8" name="TextBox 7"/>
-          <p:cNvSpPr txBox="1"/>
-          <p:nvPr/>
-        </p:nvSpPr>
-        <p:spPr>
-          <a:xfrm>
-            <a:off x="6126480" y="1755648"/>
-            <a:ext cx="5303520" cy="320040"/>
-          </a:xfrm>
-          <a:prstGeom prst="rect">
-            <a:avLst/>
-          </a:prstGeom>
-          <a:noFill/>
-        </p:spPr>
-        <p:txBody>
-          <a:bodyPr wrap="square">
-            <a:spAutoFit/>
-          </a:bodyPr>
-          <a:lstStyle/>
-          <a:p>
-            <a:pPr algn="l"/>
-            <a:r>
-              <a:rPr sz="1100" b="1">
-                <a:solidFill>
-                  <a:srgbClr val="5B7FA6"/>
-                </a:solidFill>
-                <a:latin typeface="Arial"/>
-              </a:rPr>
-              <a:t>SAY THIS</a:t>
-            </a:r>
-          </a:p>
-        </p:txBody>
-      </p:sp>
-      <p:sp>
-        <p:nvSpPr>
-          <p:cNvPr id="9" name="TextBox 8"/>
-          <p:cNvSpPr txBox="1"/>
-          <p:nvPr/>
-        </p:nvSpPr>
-        <p:spPr>
-          <a:xfrm>
-            <a:off x="6126480" y="2148840"/>
-            <a:ext cx="5303520" cy="2286000"/>
-          </a:xfrm>
-          <a:prstGeom prst="rect">
-            <a:avLst/>
-          </a:prstGeom>
-          <a:noFill/>
-        </p:spPr>
-        <p:txBody>
-          <a:bodyPr wrap="square">
-            <a:spAutoFit/>
-          </a:bodyPr>
-          <a:lstStyle/>
-          <a:p>
-            <a:r>
-              <a:rPr sz="1600" i="1">
-                <a:solidFill>
-                  <a:srgbClr val="222A18"/>
-                </a:solidFill>
-                <a:latin typeface="Arial"/>
-              </a:rPr>
-              <a:t>“AI tools were used to write this code - DeepSeek, Copilot, Codex. Every change was read, run and tested before it was kept: that run is 54 automated tests, all passing.”</a:t>
-            </a:r>
-          </a:p>
-        </p:txBody>
-      </p:sp>
-      <p:sp>
-        <p:nvSpPr>
-          <p:cNvPr id="10" name="TextBox 9"/>
-          <p:cNvSpPr txBox="1"/>
-          <p:nvPr/>
-        </p:nvSpPr>
-        <p:spPr>
-          <a:xfrm>
-            <a:off x="548640" y="4800600"/>
-            <a:ext cx="2743200" cy="274320"/>
-          </a:xfrm>
-          <a:prstGeom prst="rect">
-            <a:avLst/>
-          </a:prstGeom>
-          <a:noFill/>
-        </p:spPr>
-        <p:txBody>
-          <a:bodyPr wrap="square">
-            <a:spAutoFit/>
-          </a:bodyPr>
-          <a:lstStyle/>
-          <a:p>
-            <a:pPr algn="l"/>
-            <a:r>
-              <a:rPr sz="1000" b="1">
-                <a:solidFill>
-                  <a:srgbClr val="6B7560"/>
-                </a:solidFill>
-                <a:latin typeface="Arial"/>
-              </a:rPr>
-              <a:t>LINKS</a:t>
-            </a:r>
-          </a:p>
-        </p:txBody>
-      </p:sp>
-      <p:sp>
-        <p:nvSpPr>
-          <p:cNvPr id="11" name="TextBox 10"/>
-          <p:cNvSpPr txBox="1"/>
-          <p:nvPr/>
-        </p:nvSpPr>
-        <p:spPr>
-          <a:xfrm>
-            <a:off x="548640" y="5074920"/>
-            <a:ext cx="7589520" cy="1097280"/>
-          </a:xfrm>
-          <a:prstGeom prst="rect">
-            <a:avLst/>
-          </a:prstGeom>
-          <a:noFill/>
-        </p:spPr>
-        <p:txBody>
-          <a:bodyPr wrap="square">
-            <a:spAutoFit/>
-          </a:bodyPr>
-          <a:lstStyle/>
-          <a:p>
-            <a:r>
-              <a:rPr sz="1300">
-                <a:solidFill>
-                  <a:srgbClr val="5B7FA6"/>
-                </a:solidFill>
-                <a:latin typeface="Arial"/>
-                <a:hlinkClick r:id="rId2"/>
-              </a:rPr>
-              <a:t>tests folder</a:t>
-            </a:r>
-          </a:p>
-          <a:p>
-            <a:r>
-              <a:rPr sz="1300">
-                <a:solidFill>
-                  <a:srgbClr val="5B7FA6"/>
-                </a:solidFill>
-                <a:latin typeface="Arial"/>
-                <a:hlinkClick r:id="rId3"/>
-              </a:rPr>
-              <a:t>Technical Declaration 4.3</a:t>
-            </a:r>
-          </a:p>
-        </p:txBody>
-      </p:sp>
-      <p:sp>
-        <p:nvSpPr>
-          <p:cNvPr id="12" name="Rectangle 11"/>
-          <p:cNvSpPr/>
-          <p:nvPr/>
-        </p:nvSpPr>
-        <p:spPr>
-          <a:xfrm>
-            <a:off x="8366760" y="5029200"/>
-            <a:ext cx="3291840" cy="1051560"/>
-          </a:xfrm>
-          <a:prstGeom prst="rect">
-            <a:avLst/>
-          </a:prstGeom>
-          <a:solidFill>
-            <a:srgbClr val="FBF4E4"/>
-          </a:solidFill>
-          <a:ln>
-            <a:solidFill>
-              <a:srgbClr val="E6D3A8"/>
-            </a:solidFill>
-          </a:ln>
-        </p:spPr>
-        <p:style>
-          <a:lnRef idx="1">
-            <a:schemeClr val="accent1"/>
-          </a:lnRef>
-          <a:fillRef idx="3">
-            <a:schemeClr val="accent1"/>
-          </a:fillRef>
-          <a:effectRef idx="2">
-            <a:schemeClr val="accent1"/>
-          </a:effectRef>
-          <a:fontRef idx="minor">
-            <a:schemeClr val="lt1"/>
-          </a:fontRef>
-        </p:style>
-        <p:txBody>
-          <a:bodyPr rtlCol="0" anchor="ctr" wrap="square" lIns="109728"/>
-          <a:lstStyle/>
-          <a:p>
-            <a:pPr algn="ctr"/>
-            <a:r>
-              <a:rPr sz="1200">
-                <a:solidFill>
-                  <a:srgbClr val="7A5A1E"/>
-                </a:solidFill>
-                <a:latin typeface="Arial"/>
-              </a:rPr>
-              <a:t>Clear the terminal first (cls). No personal paths on screen.</a:t>
-            </a:r>
-          </a:p>
-        </p:txBody>
-      </p:sp>
-      <p:sp>
-        <p:nvSpPr>
-          <p:cNvPr id="13" name="TextBox 12"/>
-          <p:cNvSpPr txBox="1"/>
-          <p:nvPr/>
-        </p:nvSpPr>
-        <p:spPr>
-          <a:xfrm>
-            <a:off x="548640" y="6400800"/>
-            <a:ext cx="11155680" cy="274320"/>
-          </a:xfrm>
-          <a:prstGeom prst="rect">
-            <a:avLst/>
-          </a:prstGeom>
-          <a:noFill/>
-        </p:spPr>
-        <p:txBody>
-          <a:bodyPr wrap="square">
-            <a:spAutoFit/>
-          </a:bodyPr>
-          <a:lstStyle/>
-          <a:p>
-            <a:pPr algn="l"/>
-            <a:r>
-              <a:rPr sz="900" b="0">
+              <a:rPr sz="1000">
                 <a:solidFill>
                   <a:srgbClr val="6B7560"/>
                 </a:solidFill>
@@ -4667,7 +3695,7 @@
         <p:spPr>
           <a:xfrm>
             <a:off x="0" y="0"/>
-            <a:ext cx="12191695" cy="201168"/>
+            <a:ext cx="12191695" cy="182880"/>
           </a:xfrm>
           <a:prstGeom prst="rect">
             <a:avLst/>
@@ -4709,8 +3737,8 @@
         </p:nvSpPr>
         <p:spPr>
           <a:xfrm>
-            <a:off x="548640" y="502920"/>
-            <a:ext cx="11155680" cy="822960"/>
+            <a:off x="640080" y="685800"/>
+            <a:ext cx="10972800" cy="1097280"/>
           </a:xfrm>
           <a:prstGeom prst="rect">
             <a:avLst/>
@@ -4723,9 +3751,8 @@
           </a:bodyPr>
           <a:lstStyle/>
           <a:p>
-            <a:pPr algn="l"/>
-            <a:r>
-              <a:rPr sz="3200" b="1">
+            <a:r>
+              <a:rPr sz="3800" b="1">
                 <a:solidFill>
                   <a:srgbClr val="3F4A26"/>
                 </a:solidFill>
@@ -4738,59 +3765,14 @@
       </p:sp>
       <p:sp>
         <p:nvSpPr>
-          <p:cNvPr id="4" name="Rectangle 3"/>
-          <p:cNvSpPr/>
-          <p:nvPr/>
-        </p:nvSpPr>
-        <p:spPr>
-          <a:xfrm>
-            <a:off x="548640" y="1600200"/>
-            <a:ext cx="5029200" cy="2971800"/>
-          </a:xfrm>
-          <a:prstGeom prst="rect">
-            <a:avLst/>
-          </a:prstGeom>
-          <a:solidFill>
-            <a:srgbClr val="F2F5E9"/>
-          </a:solidFill>
-          <a:ln>
-            <a:solidFill>
-              <a:srgbClr val="D8DFCA"/>
-            </a:solidFill>
-          </a:ln>
-        </p:spPr>
-        <p:style>
-          <a:lnRef idx="1">
-            <a:schemeClr val="accent1"/>
-          </a:lnRef>
-          <a:fillRef idx="3">
-            <a:schemeClr val="accent1"/>
-          </a:fillRef>
-          <a:effectRef idx="2">
-            <a:schemeClr val="accent1"/>
-          </a:effectRef>
-          <a:fontRef idx="minor">
-            <a:schemeClr val="lt1"/>
-          </a:fontRef>
-        </p:style>
-        <p:txBody>
-          <a:bodyPr rtlCol="0" anchor="ctr"/>
-          <a:lstStyle/>
-          <a:p>
-            <a:pPr algn="ctr"/>
-          </a:p>
-        </p:txBody>
-      </p:sp>
-      <p:sp>
-        <p:nvSpPr>
-          <p:cNvPr id="5" name="TextBox 4"/>
+          <p:cNvPr id="4" name="TextBox 3"/>
           <p:cNvSpPr txBox="1"/>
           <p:nvPr/>
         </p:nvSpPr>
         <p:spPr>
           <a:xfrm>
-            <a:off x="777240" y="1755648"/>
-            <a:ext cx="4572000" cy="320040"/>
+            <a:off x="685800" y="2148840"/>
+            <a:ext cx="10789920" cy="3291840"/>
           </a:xfrm>
           <a:prstGeom prst="rect">
             <a:avLst/>
@@ -4803,29 +3785,51 @@
           </a:bodyPr>
           <a:lstStyle/>
           <a:p>
-            <a:pPr algn="l"/>
-            <a:r>
-              <a:rPr sz="1100" b="1">
-                <a:solidFill>
-                  <a:srgbClr val="6B7560"/>
+            <a:pPr>
+              <a:spcAft>
+                <a:spcPts val="1600"/>
+              </a:spcAft>
+            </a:pPr>
+            <a:r>
+              <a:rPr sz="2200" u="sng">
+                <a:solidFill>
+                  <a:srgbClr val="2F5B8A"/>
                 </a:solidFill>
                 <a:latin typeface="Arial"/>
+                <a:hlinkClick r:id="rId2"/>
               </a:rPr>
-              <a:t>ON SCREEN</a:t>
-            </a:r>
-          </a:p>
-        </p:txBody>
-      </p:sp>
-      <p:sp>
-        <p:nvSpPr>
-          <p:cNvPr id="6" name="TextBox 5"/>
+              <a:t>REPLIT PROOF OF USE.pdf</a:t>
+            </a:r>
+          </a:p>
+          <a:p>
+            <a:pPr>
+              <a:spcAft>
+                <a:spcPts val="1600"/>
+              </a:spcAft>
+            </a:pPr>
+            <a:r>
+              <a:rPr sz="2200" u="sng">
+                <a:solidFill>
+                  <a:srgbClr val="2F5B8A"/>
+                </a:solidFill>
+                <a:latin typeface="Arial"/>
+                <a:hlinkClick r:id="rId3"/>
+              </a:rPr>
+              <a:t>Technical Declaration</a:t>
+            </a:r>
+          </a:p>
+        </p:txBody>
+      </p:sp>
+      <p:sp>
+        <p:nvSpPr>
+          <p:cNvPr id="5" name="TextBox 4"/>
           <p:cNvSpPr txBox="1"/>
           <p:nvPr/>
         </p:nvSpPr>
         <p:spPr>
           <a:xfrm>
-            <a:off x="777240" y="2148840"/>
-            <a:ext cx="4572000" cy="2286000"/>
+            <a:off x="685800" y="6355080"/>
+            <a:ext cx="10789920" cy="320040"/>
           </a:xfrm>
           <a:prstGeom prst="rect">
             <a:avLst/>
@@ -4833,309 +3837,13 @@
           <a:noFill/>
         </p:spPr>
         <p:txBody>
-          <a:bodyPr wrap="square">
+          <a:bodyPr wrap="none">
             <a:spAutoFit/>
           </a:bodyPr>
           <a:lstStyle/>
           <a:p>
             <a:r>
-              <a:rPr sz="1600">
-                <a:solidFill>
-                  <a:srgbClr val="222A18"/>
-                </a:solidFill>
-                <a:latin typeface="Arial"/>
-              </a:rPr>
-              <a:t>· PDF viewer: submission/REPLIT PROOF OF USE.pdf</a:t>
-            </a:r>
-          </a:p>
-          <a:p>
-            <a:r>
-              <a:rPr sz="1600">
-                <a:solidFill>
-                  <a:srgbClr val="222A18"/>
-                </a:solidFill>
-                <a:latin typeface="Arial"/>
-              </a:rPr>
-              <a:t>· scroll one page</a:t>
-            </a:r>
-          </a:p>
-        </p:txBody>
-      </p:sp>
-      <p:sp>
-        <p:nvSpPr>
-          <p:cNvPr id="7" name="Rectangle 6"/>
-          <p:cNvSpPr/>
-          <p:nvPr/>
-        </p:nvSpPr>
-        <p:spPr>
-          <a:xfrm>
-            <a:off x="5897880" y="1600200"/>
-            <a:ext cx="5760720" cy="2971800"/>
-          </a:xfrm>
-          <a:prstGeom prst="rect">
-            <a:avLst/>
-          </a:prstGeom>
-          <a:solidFill>
-            <a:srgbClr val="FFFFFF"/>
-          </a:solidFill>
-          <a:ln>
-            <a:solidFill>
-              <a:srgbClr val="B7C98F"/>
-            </a:solidFill>
-          </a:ln>
-        </p:spPr>
-        <p:style>
-          <a:lnRef idx="1">
-            <a:schemeClr val="accent1"/>
-          </a:lnRef>
-          <a:fillRef idx="3">
-            <a:schemeClr val="accent1"/>
-          </a:fillRef>
-          <a:effectRef idx="2">
-            <a:schemeClr val="accent1"/>
-          </a:effectRef>
-          <a:fontRef idx="minor">
-            <a:schemeClr val="lt1"/>
-          </a:fontRef>
-        </p:style>
-        <p:txBody>
-          <a:bodyPr rtlCol="0" anchor="ctr"/>
-          <a:lstStyle/>
-          <a:p>
-            <a:pPr algn="ctr"/>
-          </a:p>
-        </p:txBody>
-      </p:sp>
-      <p:sp>
-        <p:nvSpPr>
-          <p:cNvPr id="8" name="TextBox 7"/>
-          <p:cNvSpPr txBox="1"/>
-          <p:nvPr/>
-        </p:nvSpPr>
-        <p:spPr>
-          <a:xfrm>
-            <a:off x="6126480" y="1755648"/>
-            <a:ext cx="5303520" cy="320040"/>
-          </a:xfrm>
-          <a:prstGeom prst="rect">
-            <a:avLst/>
-          </a:prstGeom>
-          <a:noFill/>
-        </p:spPr>
-        <p:txBody>
-          <a:bodyPr wrap="square">
-            <a:spAutoFit/>
-          </a:bodyPr>
-          <a:lstStyle/>
-          <a:p>
-            <a:pPr algn="l"/>
-            <a:r>
-              <a:rPr sz="1100" b="1">
-                <a:solidFill>
-                  <a:srgbClr val="5B7FA6"/>
-                </a:solidFill>
-                <a:latin typeface="Arial"/>
-              </a:rPr>
-              <a:t>SAY THIS</a:t>
-            </a:r>
-          </a:p>
-        </p:txBody>
-      </p:sp>
-      <p:sp>
-        <p:nvSpPr>
-          <p:cNvPr id="9" name="TextBox 8"/>
-          <p:cNvSpPr txBox="1"/>
-          <p:nvPr/>
-        </p:nvSpPr>
-        <p:spPr>
-          <a:xfrm>
-            <a:off x="6126480" y="2148840"/>
-            <a:ext cx="5303520" cy="2286000"/>
-          </a:xfrm>
-          <a:prstGeom prst="rect">
-            <a:avLst/>
-          </a:prstGeom>
-          <a:noFill/>
-        </p:spPr>
-        <p:txBody>
-          <a:bodyPr wrap="square">
-            <a:spAutoFit/>
-          </a:bodyPr>
-          <a:lstStyle/>
-          <a:p>
-            <a:r>
-              <a:rPr sz="1600" i="1">
-                <a:solidFill>
-                  <a:srgbClr val="222A18"/>
-                </a:solidFill>
-                <a:latin typeface="Arial"/>
-              </a:rPr>
-              <a:t>“Replit was our development workspace; the screenshots are in the submission folder. RunPod is not used - there is no GPU endpoint in this project, and the Technical Declaration says so.”</a:t>
-            </a:r>
-          </a:p>
-        </p:txBody>
-      </p:sp>
-      <p:sp>
-        <p:nvSpPr>
-          <p:cNvPr id="10" name="TextBox 9"/>
-          <p:cNvSpPr txBox="1"/>
-          <p:nvPr/>
-        </p:nvSpPr>
-        <p:spPr>
-          <a:xfrm>
-            <a:off x="548640" y="4800600"/>
-            <a:ext cx="2743200" cy="274320"/>
-          </a:xfrm>
-          <a:prstGeom prst="rect">
-            <a:avLst/>
-          </a:prstGeom>
-          <a:noFill/>
-        </p:spPr>
-        <p:txBody>
-          <a:bodyPr wrap="square">
-            <a:spAutoFit/>
-          </a:bodyPr>
-          <a:lstStyle/>
-          <a:p>
-            <a:pPr algn="l"/>
-            <a:r>
-              <a:rPr sz="1000" b="1">
-                <a:solidFill>
-                  <a:srgbClr val="6B7560"/>
-                </a:solidFill>
-                <a:latin typeface="Arial"/>
-              </a:rPr>
-              <a:t>LINKS</a:t>
-            </a:r>
-          </a:p>
-        </p:txBody>
-      </p:sp>
-      <p:sp>
-        <p:nvSpPr>
-          <p:cNvPr id="11" name="TextBox 10"/>
-          <p:cNvSpPr txBox="1"/>
-          <p:nvPr/>
-        </p:nvSpPr>
-        <p:spPr>
-          <a:xfrm>
-            <a:off x="548640" y="5074920"/>
-            <a:ext cx="7589520" cy="1097280"/>
-          </a:xfrm>
-          <a:prstGeom prst="rect">
-            <a:avLst/>
-          </a:prstGeom>
-          <a:noFill/>
-        </p:spPr>
-        <p:txBody>
-          <a:bodyPr wrap="square">
-            <a:spAutoFit/>
-          </a:bodyPr>
-          <a:lstStyle/>
-          <a:p>
-            <a:r>
-              <a:rPr sz="1300">
-                <a:solidFill>
-                  <a:srgbClr val="5B7FA6"/>
-                </a:solidFill>
-                <a:latin typeface="Arial"/>
-                <a:hlinkClick r:id="rId2"/>
-              </a:rPr>
-              <a:t>Replit proof</a:t>
-            </a:r>
-          </a:p>
-          <a:p>
-            <a:r>
-              <a:rPr sz="1300">
-                <a:solidFill>
-                  <a:srgbClr val="5B7FA6"/>
-                </a:solidFill>
-                <a:latin typeface="Arial"/>
-                <a:hlinkClick r:id="rId3"/>
-              </a:rPr>
-              <a:t>Technical Declaration</a:t>
-            </a:r>
-          </a:p>
-        </p:txBody>
-      </p:sp>
-      <p:sp>
-        <p:nvSpPr>
-          <p:cNvPr id="12" name="Rectangle 11"/>
-          <p:cNvSpPr/>
-          <p:nvPr/>
-        </p:nvSpPr>
-        <p:spPr>
-          <a:xfrm>
-            <a:off x="8366760" y="5029200"/>
-            <a:ext cx="3291840" cy="1051560"/>
-          </a:xfrm>
-          <a:prstGeom prst="rect">
-            <a:avLst/>
-          </a:prstGeom>
-          <a:solidFill>
-            <a:srgbClr val="FBF4E4"/>
-          </a:solidFill>
-          <a:ln>
-            <a:solidFill>
-              <a:srgbClr val="E6D3A8"/>
-            </a:solidFill>
-          </a:ln>
-        </p:spPr>
-        <p:style>
-          <a:lnRef idx="1">
-            <a:schemeClr val="accent1"/>
-          </a:lnRef>
-          <a:fillRef idx="3">
-            <a:schemeClr val="accent1"/>
-          </a:fillRef>
-          <a:effectRef idx="2">
-            <a:schemeClr val="accent1"/>
-          </a:effectRef>
-          <a:fontRef idx="minor">
-            <a:schemeClr val="lt1"/>
-          </a:fontRef>
-        </p:style>
-        <p:txBody>
-          <a:bodyPr rtlCol="0" anchor="ctr" wrap="square" lIns="109728"/>
-          <a:lstStyle/>
-          <a:p>
-            <a:pPr algn="ctr"/>
-            <a:r>
-              <a:rPr sz="1200">
-                <a:solidFill>
-                  <a:srgbClr val="7A5A1E"/>
-                </a:solidFill>
-                <a:latin typeface="Arial"/>
-              </a:rPr>
-              <a:t>Say used / not used in one breath. Do not explain why RunPod is unused.</a:t>
-            </a:r>
-          </a:p>
-        </p:txBody>
-      </p:sp>
-      <p:sp>
-        <p:nvSpPr>
-          <p:cNvPr id="13" name="TextBox 12"/>
-          <p:cNvSpPr txBox="1"/>
-          <p:nvPr/>
-        </p:nvSpPr>
-        <p:spPr>
-          <a:xfrm>
-            <a:off x="548640" y="6400800"/>
-            <a:ext cx="11155680" cy="274320"/>
-          </a:xfrm>
-          <a:prstGeom prst="rect">
-            <a:avLst/>
-          </a:prstGeom>
-          <a:noFill/>
-        </p:spPr>
-        <p:txBody>
-          <a:bodyPr wrap="square">
-            <a:spAutoFit/>
-          </a:bodyPr>
-          <a:lstStyle/>
-          <a:p>
-            <a:pPr algn="l"/>
-            <a:r>
-              <a:rPr sz="900" b="0">
+              <a:rPr sz="1000">
                 <a:solidFill>
                   <a:srgbClr val="6B7560"/>
                 </a:solidFill>
@@ -5173,7 +3881,7 @@
         <p:spPr>
           <a:xfrm>
             <a:off x="0" y="0"/>
-            <a:ext cx="12191695" cy="201168"/>
+            <a:ext cx="12191695" cy="182880"/>
           </a:xfrm>
           <a:prstGeom prst="rect">
             <a:avLst/>
@@ -5215,8 +3923,8 @@
         </p:nvSpPr>
         <p:spPr>
           <a:xfrm>
-            <a:off x="548640" y="502920"/>
-            <a:ext cx="11155680" cy="822960"/>
+            <a:off x="640080" y="685800"/>
+            <a:ext cx="10972800" cy="1097280"/>
           </a:xfrm>
           <a:prstGeom prst="rect">
             <a:avLst/>
@@ -5229,9 +3937,8 @@
           </a:bodyPr>
           <a:lstStyle/>
           <a:p>
-            <a:pPr algn="l"/>
-            <a:r>
-              <a:rPr sz="3200" b="1">
+            <a:r>
+              <a:rPr sz="3800" b="1">
                 <a:solidFill>
                   <a:srgbClr val="3F4A26"/>
                 </a:solidFill>
@@ -5244,59 +3951,14 @@
       </p:sp>
       <p:sp>
         <p:nvSpPr>
-          <p:cNvPr id="4" name="Rectangle 3"/>
-          <p:cNvSpPr/>
-          <p:nvPr/>
-        </p:nvSpPr>
-        <p:spPr>
-          <a:xfrm>
-            <a:off x="548640" y="1600200"/>
-            <a:ext cx="5029200" cy="2971800"/>
-          </a:xfrm>
-          <a:prstGeom prst="rect">
-            <a:avLst/>
-          </a:prstGeom>
-          <a:solidFill>
-            <a:srgbClr val="F2F5E9"/>
-          </a:solidFill>
-          <a:ln>
-            <a:solidFill>
-              <a:srgbClr val="D8DFCA"/>
-            </a:solidFill>
-          </a:ln>
-        </p:spPr>
-        <p:style>
-          <a:lnRef idx="1">
-            <a:schemeClr val="accent1"/>
-          </a:lnRef>
-          <a:fillRef idx="3">
-            <a:schemeClr val="accent1"/>
-          </a:fillRef>
-          <a:effectRef idx="2">
-            <a:schemeClr val="accent1"/>
-          </a:effectRef>
-          <a:fontRef idx="minor">
-            <a:schemeClr val="lt1"/>
-          </a:fontRef>
-        </p:style>
-        <p:txBody>
-          <a:bodyPr rtlCol="0" anchor="ctr"/>
-          <a:lstStyle/>
-          <a:p>
-            <a:pPr algn="ctr"/>
-          </a:p>
-        </p:txBody>
-      </p:sp>
-      <p:sp>
-        <p:nvSpPr>
-          <p:cNvPr id="5" name="TextBox 4"/>
+          <p:cNvPr id="4" name="TextBox 3"/>
           <p:cNvSpPr txBox="1"/>
           <p:nvPr/>
         </p:nvSpPr>
         <p:spPr>
           <a:xfrm>
-            <a:off x="777240" y="1755648"/>
-            <a:ext cx="4572000" cy="320040"/>
+            <a:off x="685800" y="2148840"/>
+            <a:ext cx="10789920" cy="3291840"/>
           </a:xfrm>
           <a:prstGeom prst="rect">
             <a:avLst/>
@@ -5309,29 +3971,51 @@
           </a:bodyPr>
           <a:lstStyle/>
           <a:p>
-            <a:pPr algn="l"/>
-            <a:r>
-              <a:rPr sz="1100" b="1">
-                <a:solidFill>
-                  <a:srgbClr val="6B7560"/>
+            <a:pPr>
+              <a:spcAft>
+                <a:spcPts val="1600"/>
+              </a:spcAft>
+            </a:pPr>
+            <a:r>
+              <a:rPr sz="2200" u="sng">
+                <a:solidFill>
+                  <a:srgbClr val="2F5B8A"/>
                 </a:solidFill>
                 <a:latin typeface="Arial"/>
+                <a:hlinkClick r:id="rId2"/>
               </a:rPr>
-              <a:t>ON SCREEN</a:t>
-            </a:r>
-          </a:p>
-        </p:txBody>
-      </p:sp>
-      <p:sp>
-        <p:nvSpPr>
-          <p:cNvPr id="6" name="TextBox 5"/>
+              <a:t>data/skills_sdg.json - 54 skills</a:t>
+            </a:r>
+          </a:p>
+          <a:p>
+            <a:pPr>
+              <a:spcAft>
+                <a:spcPts val="1600"/>
+              </a:spcAft>
+            </a:pPr>
+            <a:r>
+              <a:rPr sz="2200" u="sng">
+                <a:solidFill>
+                  <a:srgbClr val="2F5B8A"/>
+                </a:solidFill>
+                <a:latin typeface="Arial"/>
+                <a:hlinkClick r:id="rId3"/>
+              </a:rPr>
+              <a:t>README - SDG row</a:t>
+            </a:r>
+          </a:p>
+        </p:txBody>
+      </p:sp>
+      <p:sp>
+        <p:nvSpPr>
+          <p:cNvPr id="5" name="TextBox 4"/>
           <p:cNvSpPr txBox="1"/>
           <p:nvPr/>
         </p:nvSpPr>
         <p:spPr>
           <a:xfrm>
-            <a:off x="777240" y="2148840"/>
-            <a:ext cx="4572000" cy="2286000"/>
+            <a:off x="685800" y="6355080"/>
+            <a:ext cx="10789920" cy="320040"/>
           </a:xfrm>
           <a:prstGeom prst="rect">
             <a:avLst/>
@@ -5339,309 +4023,13 @@
           <a:noFill/>
         </p:spPr>
         <p:txBody>
-          <a:bodyPr wrap="square">
+          <a:bodyPr wrap="none">
             <a:spAutoFit/>
           </a:bodyPr>
           <a:lstStyle/>
           <a:p>
             <a:r>
-              <a:rPr sz="1600">
-                <a:solidFill>
-                  <a:srgbClr val="222A18"/>
-                </a:solidFill>
-                <a:latin typeface="Arial"/>
-              </a:rPr>
-              <a:t>· App, scroll to the SDG section</a:t>
-            </a:r>
-          </a:p>
-          <a:p>
-            <a:r>
-              <a:rPr sz="1600">
-                <a:solidFill>
-                  <a:srgbClr val="222A18"/>
-                </a:solidFill>
-                <a:latin typeface="Arial"/>
-              </a:rPr>
-              <a:t>· point at the skill-level tags, not the big icons</a:t>
-            </a:r>
-          </a:p>
-        </p:txBody>
-      </p:sp>
-      <p:sp>
-        <p:nvSpPr>
-          <p:cNvPr id="7" name="Rectangle 6"/>
-          <p:cNvSpPr/>
-          <p:nvPr/>
-        </p:nvSpPr>
-        <p:spPr>
-          <a:xfrm>
-            <a:off x="5897880" y="1600200"/>
-            <a:ext cx="5760720" cy="2971800"/>
-          </a:xfrm>
-          <a:prstGeom prst="rect">
-            <a:avLst/>
-          </a:prstGeom>
-          <a:solidFill>
-            <a:srgbClr val="FFFFFF"/>
-          </a:solidFill>
-          <a:ln>
-            <a:solidFill>
-              <a:srgbClr val="B7C98F"/>
-            </a:solidFill>
-          </a:ln>
-        </p:spPr>
-        <p:style>
-          <a:lnRef idx="1">
-            <a:schemeClr val="accent1"/>
-          </a:lnRef>
-          <a:fillRef idx="3">
-            <a:schemeClr val="accent1"/>
-          </a:fillRef>
-          <a:effectRef idx="2">
-            <a:schemeClr val="accent1"/>
-          </a:effectRef>
-          <a:fontRef idx="minor">
-            <a:schemeClr val="lt1"/>
-          </a:fontRef>
-        </p:style>
-        <p:txBody>
-          <a:bodyPr rtlCol="0" anchor="ctr"/>
-          <a:lstStyle/>
-          <a:p>
-            <a:pPr algn="ctr"/>
-          </a:p>
-        </p:txBody>
-      </p:sp>
-      <p:sp>
-        <p:nvSpPr>
-          <p:cNvPr id="8" name="TextBox 7"/>
-          <p:cNvSpPr txBox="1"/>
-          <p:nvPr/>
-        </p:nvSpPr>
-        <p:spPr>
-          <a:xfrm>
-            <a:off x="6126480" y="1755648"/>
-            <a:ext cx="5303520" cy="320040"/>
-          </a:xfrm>
-          <a:prstGeom prst="rect">
-            <a:avLst/>
-          </a:prstGeom>
-          <a:noFill/>
-        </p:spPr>
-        <p:txBody>
-          <a:bodyPr wrap="square">
-            <a:spAutoFit/>
-          </a:bodyPr>
-          <a:lstStyle/>
-          <a:p>
-            <a:pPr algn="l"/>
-            <a:r>
-              <a:rPr sz="1100" b="1">
-                <a:solidFill>
-                  <a:srgbClr val="5B7FA6"/>
-                </a:solidFill>
-                <a:latin typeface="Arial"/>
-              </a:rPr>
-              <a:t>SAY THIS</a:t>
-            </a:r>
-          </a:p>
-        </p:txBody>
-      </p:sp>
-      <p:sp>
-        <p:nvSpPr>
-          <p:cNvPr id="9" name="TextBox 8"/>
-          <p:cNvSpPr txBox="1"/>
-          <p:nvPr/>
-        </p:nvSpPr>
-        <p:spPr>
-          <a:xfrm>
-            <a:off x="6126480" y="2148840"/>
-            <a:ext cx="5303520" cy="2286000"/>
-          </a:xfrm>
-          <a:prstGeom prst="rect">
-            <a:avLst/>
-          </a:prstGeom>
-          <a:noFill/>
-        </p:spPr>
-        <p:txBody>
-          <a:bodyPr wrap="square">
-            <a:spAutoFit/>
-          </a:bodyPr>
-          <a:lstStyle/>
-          <a:p>
-            <a:r>
-              <a:rPr sz="1600" i="1">
-                <a:solidFill>
-                  <a:srgbClr val="222A18"/>
-                </a:solidFill>
-                <a:latin typeface="Arial"/>
-              </a:rPr>
-              <a:t>“The track is SDG 4, sub-target 4.4 - skills for employment - with 8.5 as the second target. The mapping goes down to individual skills, and we label it as our own reading, not an official UN mapping.”</a:t>
-            </a:r>
-          </a:p>
-        </p:txBody>
-      </p:sp>
-      <p:sp>
-        <p:nvSpPr>
-          <p:cNvPr id="10" name="TextBox 9"/>
-          <p:cNvSpPr txBox="1"/>
-          <p:nvPr/>
-        </p:nvSpPr>
-        <p:spPr>
-          <a:xfrm>
-            <a:off x="548640" y="4800600"/>
-            <a:ext cx="2743200" cy="274320"/>
-          </a:xfrm>
-          <a:prstGeom prst="rect">
-            <a:avLst/>
-          </a:prstGeom>
-          <a:noFill/>
-        </p:spPr>
-        <p:txBody>
-          <a:bodyPr wrap="square">
-            <a:spAutoFit/>
-          </a:bodyPr>
-          <a:lstStyle/>
-          <a:p>
-            <a:pPr algn="l"/>
-            <a:r>
-              <a:rPr sz="1000" b="1">
-                <a:solidFill>
-                  <a:srgbClr val="6B7560"/>
-                </a:solidFill>
-                <a:latin typeface="Arial"/>
-              </a:rPr>
-              <a:t>LINKS</a:t>
-            </a:r>
-          </a:p>
-        </p:txBody>
-      </p:sp>
-      <p:sp>
-        <p:nvSpPr>
-          <p:cNvPr id="11" name="TextBox 10"/>
-          <p:cNvSpPr txBox="1"/>
-          <p:nvPr/>
-        </p:nvSpPr>
-        <p:spPr>
-          <a:xfrm>
-            <a:off x="548640" y="5074920"/>
-            <a:ext cx="7589520" cy="1097280"/>
-          </a:xfrm>
-          <a:prstGeom prst="rect">
-            <a:avLst/>
-          </a:prstGeom>
-          <a:noFill/>
-        </p:spPr>
-        <p:txBody>
-          <a:bodyPr wrap="square">
-            <a:spAutoFit/>
-          </a:bodyPr>
-          <a:lstStyle/>
-          <a:p>
-            <a:r>
-              <a:rPr sz="1300">
-                <a:solidFill>
-                  <a:srgbClr val="5B7FA6"/>
-                </a:solidFill>
-                <a:latin typeface="Arial"/>
-                <a:hlinkClick r:id="rId2"/>
-              </a:rPr>
-              <a:t>skills_sdg.json (54 skills)</a:t>
-            </a:r>
-          </a:p>
-          <a:p>
-            <a:r>
-              <a:rPr sz="1300">
-                <a:solidFill>
-                  <a:srgbClr val="5B7FA6"/>
-                </a:solidFill>
-                <a:latin typeface="Arial"/>
-                <a:hlinkClick r:id="rId3"/>
-              </a:rPr>
-              <a:t>README, SDG row</a:t>
-            </a:r>
-          </a:p>
-        </p:txBody>
-      </p:sp>
-      <p:sp>
-        <p:nvSpPr>
-          <p:cNvPr id="12" name="Rectangle 11"/>
-          <p:cNvSpPr/>
-          <p:nvPr/>
-        </p:nvSpPr>
-        <p:spPr>
-          <a:xfrm>
-            <a:off x="8366760" y="5029200"/>
-            <a:ext cx="3291840" cy="1051560"/>
-          </a:xfrm>
-          <a:prstGeom prst="rect">
-            <a:avLst/>
-          </a:prstGeom>
-          <a:solidFill>
-            <a:srgbClr val="FBF4E4"/>
-          </a:solidFill>
-          <a:ln>
-            <a:solidFill>
-              <a:srgbClr val="E6D3A8"/>
-            </a:solidFill>
-          </a:ln>
-        </p:spPr>
-        <p:style>
-          <a:lnRef idx="1">
-            <a:schemeClr val="accent1"/>
-          </a:lnRef>
-          <a:fillRef idx="3">
-            <a:schemeClr val="accent1"/>
-          </a:fillRef>
-          <a:effectRef idx="2">
-            <a:schemeClr val="accent1"/>
-          </a:effectRef>
-          <a:fontRef idx="minor">
-            <a:schemeClr val="lt1"/>
-          </a:fontRef>
-        </p:style>
-        <p:txBody>
-          <a:bodyPr rtlCol="0" anchor="ctr" wrap="square" lIns="109728"/>
-          <a:lstStyle/>
-          <a:p>
-            <a:pPr algn="ctr"/>
-            <a:r>
-              <a:rPr sz="1200">
-                <a:solidFill>
-                  <a:srgbClr val="7A5A1E"/>
-                </a:solidFill>
-                <a:latin typeface="Arial"/>
-              </a:rPr>
-              <a:t>Point at the skill chips. Icon-only is explicitly not enough.</a:t>
-            </a:r>
-          </a:p>
-        </p:txBody>
-      </p:sp>
-      <p:sp>
-        <p:nvSpPr>
-          <p:cNvPr id="13" name="TextBox 12"/>
-          <p:cNvSpPr txBox="1"/>
-          <p:nvPr/>
-        </p:nvSpPr>
-        <p:spPr>
-          <a:xfrm>
-            <a:off x="548640" y="6400800"/>
-            <a:ext cx="11155680" cy="274320"/>
-          </a:xfrm>
-          <a:prstGeom prst="rect">
-            <a:avLst/>
-          </a:prstGeom>
-          <a:noFill/>
-        </p:spPr>
-        <p:txBody>
-          <a:bodyPr wrap="square">
-            <a:spAutoFit/>
-          </a:bodyPr>
-          <a:lstStyle/>
-          <a:p>
-            <a:pPr algn="l"/>
-            <a:r>
-              <a:rPr sz="900" b="0">
+              <a:rPr sz="1000">
                 <a:solidFill>
                   <a:srgbClr val="6B7560"/>
                 </a:solidFill>
@@ -5679,7 +4067,7 @@
         <p:spPr>
           <a:xfrm>
             <a:off x="0" y="0"/>
-            <a:ext cx="12191695" cy="201168"/>
+            <a:ext cx="12191695" cy="182880"/>
           </a:xfrm>
           <a:prstGeom prst="rect">
             <a:avLst/>
@@ -5721,8 +4109,8 @@
         </p:nvSpPr>
         <p:spPr>
           <a:xfrm>
-            <a:off x="548640" y="502920"/>
-            <a:ext cx="11155680" cy="822960"/>
+            <a:off x="640080" y="685800"/>
+            <a:ext cx="10972800" cy="1097280"/>
           </a:xfrm>
           <a:prstGeom prst="rect">
             <a:avLst/>
@@ -5735,9 +4123,8 @@
           </a:bodyPr>
           <a:lstStyle/>
           <a:p>
-            <a:pPr algn="l"/>
-            <a:r>
-              <a:rPr sz="3200" b="1">
+            <a:r>
+              <a:rPr sz="3800" b="1">
                 <a:solidFill>
                   <a:srgbClr val="3F4A26"/>
                 </a:solidFill>
@@ -5750,59 +4137,14 @@
       </p:sp>
       <p:sp>
         <p:nvSpPr>
-          <p:cNvPr id="4" name="Rectangle 3"/>
-          <p:cNvSpPr/>
-          <p:nvPr/>
-        </p:nvSpPr>
-        <p:spPr>
-          <a:xfrm>
-            <a:off x="548640" y="1600200"/>
-            <a:ext cx="5029200" cy="2971800"/>
-          </a:xfrm>
-          <a:prstGeom prst="rect">
-            <a:avLst/>
-          </a:prstGeom>
-          <a:solidFill>
-            <a:srgbClr val="F2F5E9"/>
-          </a:solidFill>
-          <a:ln>
-            <a:solidFill>
-              <a:srgbClr val="D8DFCA"/>
-            </a:solidFill>
-          </a:ln>
-        </p:spPr>
-        <p:style>
-          <a:lnRef idx="1">
-            <a:schemeClr val="accent1"/>
-          </a:lnRef>
-          <a:fillRef idx="3">
-            <a:schemeClr val="accent1"/>
-          </a:fillRef>
-          <a:effectRef idx="2">
-            <a:schemeClr val="accent1"/>
-          </a:effectRef>
-          <a:fontRef idx="minor">
-            <a:schemeClr val="lt1"/>
-          </a:fontRef>
-        </p:style>
-        <p:txBody>
-          <a:bodyPr rtlCol="0" anchor="ctr"/>
-          <a:lstStyle/>
-          <a:p>
-            <a:pPr algn="ctr"/>
-          </a:p>
-        </p:txBody>
-      </p:sp>
-      <p:sp>
-        <p:nvSpPr>
-          <p:cNvPr id="5" name="TextBox 4"/>
+          <p:cNvPr id="4" name="TextBox 3"/>
           <p:cNvSpPr txBox="1"/>
           <p:nvPr/>
         </p:nvSpPr>
         <p:spPr>
           <a:xfrm>
-            <a:off x="777240" y="1755648"/>
-            <a:ext cx="4572000" cy="320040"/>
+            <a:off x="685800" y="2148840"/>
+            <a:ext cx="10789920" cy="3291840"/>
           </a:xfrm>
           <a:prstGeom prst="rect">
             <a:avLst/>
@@ -5815,29 +4157,51 @@
           </a:bodyPr>
           <a:lstStyle/>
           <a:p>
-            <a:pPr algn="l"/>
-            <a:r>
-              <a:rPr sz="1100" b="1">
-                <a:solidFill>
-                  <a:srgbClr val="6B7560"/>
+            <a:pPr>
+              <a:spcAft>
+                <a:spcPts val="1600"/>
+              </a:spcAft>
+            </a:pPr>
+            <a:r>
+              <a:rPr sz="2200" u="sng">
+                <a:solidFill>
+                  <a:srgbClr val="2F5B8A"/>
                 </a:solidFill>
                 <a:latin typeface="Arial"/>
+                <a:hlinkClick r:id="rId2"/>
               </a:rPr>
-              <a:t>ON SCREEN</a:t>
-            </a:r>
-          </a:p>
-        </p:txBody>
-      </p:sp>
-      <p:sp>
-        <p:nvSpPr>
-          <p:cNvPr id="6" name="TextBox 5"/>
+              <a:t>data/courses.json - 60 links</a:t>
+            </a:r>
+          </a:p>
+          <a:p>
+            <a:pPr>
+              <a:spcAft>
+                <a:spcPts val="1600"/>
+              </a:spcAft>
+            </a:pPr>
+            <a:r>
+              <a:rPr sz="2200" u="sng">
+                <a:solidFill>
+                  <a:srgbClr val="2F5B8A"/>
+                </a:solidFill>
+                <a:latin typeface="Arial"/>
+                <a:hlinkClick r:id="rId3"/>
+              </a:rPr>
+              <a:t>data/sample_cv.txt - synthetic</a:t>
+            </a:r>
+          </a:p>
+        </p:txBody>
+      </p:sp>
+      <p:sp>
+        <p:nvSpPr>
+          <p:cNvPr id="5" name="TextBox 4"/>
           <p:cNvSpPr txBox="1"/>
           <p:nvPr/>
         </p:nvSpPr>
         <p:spPr>
           <a:xfrm>
-            <a:off x="777240" y="2148840"/>
-            <a:ext cx="4572000" cy="2286000"/>
+            <a:off x="685800" y="6355080"/>
+            <a:ext cx="10789920" cy="320040"/>
           </a:xfrm>
           <a:prstGeom prst="rect">
             <a:avLst/>
@@ -5845,309 +4209,13 @@
           <a:noFill/>
         </p:spPr>
         <p:txBody>
-          <a:bodyPr wrap="square">
+          <a:bodyPr wrap="none">
             <a:spAutoFit/>
           </a:bodyPr>
           <a:lstStyle/>
           <a:p>
             <a:r>
-              <a:rPr sz="1600">
-                <a:solidFill>
-                  <a:srgbClr val="222A18"/>
-                </a:solidFill>
-                <a:latin typeface="Arial"/>
-              </a:rPr>
-              <a:t>· App: the source-robustness table</a:t>
-            </a:r>
-          </a:p>
-          <a:p>
-            <a:r>
-              <a:rPr sz="1600">
-                <a:solidFill>
-                  <a:srgbClr val="222A18"/>
-                </a:solidFill>
-                <a:latin typeface="Arial"/>
-              </a:rPr>
-              <a:t>· or the terminal still showing the test run</a:t>
-            </a:r>
-          </a:p>
-        </p:txBody>
-      </p:sp>
-      <p:sp>
-        <p:nvSpPr>
-          <p:cNvPr id="7" name="Rectangle 6"/>
-          <p:cNvSpPr/>
-          <p:nvPr/>
-        </p:nvSpPr>
-        <p:spPr>
-          <a:xfrm>
-            <a:off x="5897880" y="1600200"/>
-            <a:ext cx="5760720" cy="2971800"/>
-          </a:xfrm>
-          <a:prstGeom prst="rect">
-            <a:avLst/>
-          </a:prstGeom>
-          <a:solidFill>
-            <a:srgbClr val="FFFFFF"/>
-          </a:solidFill>
-          <a:ln>
-            <a:solidFill>
-              <a:srgbClr val="B7C98F"/>
-            </a:solidFill>
-          </a:ln>
-        </p:spPr>
-        <p:style>
-          <a:lnRef idx="1">
-            <a:schemeClr val="accent1"/>
-          </a:lnRef>
-          <a:fillRef idx="3">
-            <a:schemeClr val="accent1"/>
-          </a:fillRef>
-          <a:effectRef idx="2">
-            <a:schemeClr val="accent1"/>
-          </a:effectRef>
-          <a:fontRef idx="minor">
-            <a:schemeClr val="lt1"/>
-          </a:fontRef>
-        </p:style>
-        <p:txBody>
-          <a:bodyPr rtlCol="0" anchor="ctr"/>
-          <a:lstStyle/>
-          <a:p>
-            <a:pPr algn="ctr"/>
-          </a:p>
-        </p:txBody>
-      </p:sp>
-      <p:sp>
-        <p:nvSpPr>
-          <p:cNvPr id="8" name="TextBox 7"/>
-          <p:cNvSpPr txBox="1"/>
-          <p:nvPr/>
-        </p:nvSpPr>
-        <p:spPr>
-          <a:xfrm>
-            <a:off x="6126480" y="1755648"/>
-            <a:ext cx="5303520" cy="320040"/>
-          </a:xfrm>
-          <a:prstGeom prst="rect">
-            <a:avLst/>
-          </a:prstGeom>
-          <a:noFill/>
-        </p:spPr>
-        <p:txBody>
-          <a:bodyPr wrap="square">
-            <a:spAutoFit/>
-          </a:bodyPr>
-          <a:lstStyle/>
-          <a:p>
-            <a:pPr algn="l"/>
-            <a:r>
-              <a:rPr sz="1100" b="1">
-                <a:solidFill>
-                  <a:srgbClr val="5B7FA6"/>
-                </a:solidFill>
-                <a:latin typeface="Arial"/>
-              </a:rPr>
-              <a:t>SAY THIS</a:t>
-            </a:r>
-          </a:p>
-        </p:txBody>
-      </p:sp>
-      <p:sp>
-        <p:nvSpPr>
-          <p:cNvPr id="9" name="TextBox 8"/>
-          <p:cNvSpPr txBox="1"/>
-          <p:nvPr/>
-        </p:nvSpPr>
-        <p:spPr>
-          <a:xfrm>
-            <a:off x="6126480" y="2148840"/>
-            <a:ext cx="5303520" cy="2286000"/>
-          </a:xfrm>
-          <a:prstGeom prst="rect">
-            <a:avLst/>
-          </a:prstGeom>
-          <a:noFill/>
-        </p:spPr>
-        <p:txBody>
-          <a:bodyPr wrap="square">
-            <a:spAutoFit/>
-          </a:bodyPr>
-          <a:lstStyle/>
-          <a:p>
-            <a:r>
-              <a:rPr sz="1600" i="1">
-                <a:solidFill>
-                  <a:srgbClr val="222A18"/>
-                </a:solidFill>
-                <a:latin typeface="Arial"/>
-              </a:rPr>
-              <a:t>“What we tested: 54 automated tests, every flow in three languages on synthetic profiles, and 60 course links checked as reachable. What we have not done: a user study. Phase 2 targets ten testers, a median plan under five minutes, and 70% rating a top-three role at least 4 out of 5. Targets, not results.”</a:t>
-            </a:r>
-          </a:p>
-        </p:txBody>
-      </p:sp>
-      <p:sp>
-        <p:nvSpPr>
-          <p:cNvPr id="10" name="TextBox 9"/>
-          <p:cNvSpPr txBox="1"/>
-          <p:nvPr/>
-        </p:nvSpPr>
-        <p:spPr>
-          <a:xfrm>
-            <a:off x="548640" y="4800600"/>
-            <a:ext cx="2743200" cy="274320"/>
-          </a:xfrm>
-          <a:prstGeom prst="rect">
-            <a:avLst/>
-          </a:prstGeom>
-          <a:noFill/>
-        </p:spPr>
-        <p:txBody>
-          <a:bodyPr wrap="square">
-            <a:spAutoFit/>
-          </a:bodyPr>
-          <a:lstStyle/>
-          <a:p>
-            <a:pPr algn="l"/>
-            <a:r>
-              <a:rPr sz="1000" b="1">
-                <a:solidFill>
-                  <a:srgbClr val="6B7560"/>
-                </a:solidFill>
-                <a:latin typeface="Arial"/>
-              </a:rPr>
-              <a:t>LINKS</a:t>
-            </a:r>
-          </a:p>
-        </p:txBody>
-      </p:sp>
-      <p:sp>
-        <p:nvSpPr>
-          <p:cNvPr id="11" name="TextBox 10"/>
-          <p:cNvSpPr txBox="1"/>
-          <p:nvPr/>
-        </p:nvSpPr>
-        <p:spPr>
-          <a:xfrm>
-            <a:off x="548640" y="5074920"/>
-            <a:ext cx="7589520" cy="1097280"/>
-          </a:xfrm>
-          <a:prstGeom prst="rect">
-            <a:avLst/>
-          </a:prstGeom>
-          <a:noFill/>
-        </p:spPr>
-        <p:txBody>
-          <a:bodyPr wrap="square">
-            <a:spAutoFit/>
-          </a:bodyPr>
-          <a:lstStyle/>
-          <a:p>
-            <a:r>
-              <a:rPr sz="1300">
-                <a:solidFill>
-                  <a:srgbClr val="5B7FA6"/>
-                </a:solidFill>
-                <a:latin typeface="Arial"/>
-                <a:hlinkClick r:id="rId2"/>
-              </a:rPr>
-              <a:t>courses.json (60 links)</a:t>
-            </a:r>
-          </a:p>
-          <a:p>
-            <a:r>
-              <a:rPr sz="1300">
-                <a:solidFill>
-                  <a:srgbClr val="5B7FA6"/>
-                </a:solidFill>
-                <a:latin typeface="Arial"/>
-                <a:hlinkClick r:id="rId3"/>
-              </a:rPr>
-              <a:t>sample_cv.txt (synthetic)</a:t>
-            </a:r>
-          </a:p>
-        </p:txBody>
-      </p:sp>
-      <p:sp>
-        <p:nvSpPr>
-          <p:cNvPr id="12" name="Rectangle 11"/>
-          <p:cNvSpPr/>
-          <p:nvPr/>
-        </p:nvSpPr>
-        <p:spPr>
-          <a:xfrm>
-            <a:off x="8366760" y="5029200"/>
-            <a:ext cx="3291840" cy="1051560"/>
-          </a:xfrm>
-          <a:prstGeom prst="rect">
-            <a:avLst/>
-          </a:prstGeom>
-          <a:solidFill>
-            <a:srgbClr val="FBF4E4"/>
-          </a:solidFill>
-          <a:ln>
-            <a:solidFill>
-              <a:srgbClr val="E6D3A8"/>
-            </a:solidFill>
-          </a:ln>
-        </p:spPr>
-        <p:style>
-          <a:lnRef idx="1">
-            <a:schemeClr val="accent1"/>
-          </a:lnRef>
-          <a:fillRef idx="3">
-            <a:schemeClr val="accent1"/>
-          </a:fillRef>
-          <a:effectRef idx="2">
-            <a:schemeClr val="accent1"/>
-          </a:effectRef>
-          <a:fontRef idx="minor">
-            <a:schemeClr val="lt1"/>
-          </a:fontRef>
-        </p:style>
-        <p:txBody>
-          <a:bodyPr rtlCol="0" anchor="ctr" wrap="square" lIns="109728"/>
-          <a:lstStyle/>
-          <a:p>
-            <a:pPr algn="ctr"/>
-            <a:r>
-              <a:rPr sz="1200">
-                <a:solidFill>
-                  <a:srgbClr val="7A5A1E"/>
-                </a:solidFill>
-                <a:latin typeface="Arial"/>
-              </a:rPr>
-              <a:t>Keep the last sentence: targets, not results.</a:t>
-            </a:r>
-          </a:p>
-        </p:txBody>
-      </p:sp>
-      <p:sp>
-        <p:nvSpPr>
-          <p:cNvPr id="13" name="TextBox 12"/>
-          <p:cNvSpPr txBox="1"/>
-          <p:nvPr/>
-        </p:nvSpPr>
-        <p:spPr>
-          <a:xfrm>
-            <a:off x="548640" y="6400800"/>
-            <a:ext cx="11155680" cy="274320"/>
-          </a:xfrm>
-          <a:prstGeom prst="rect">
-            <a:avLst/>
-          </a:prstGeom>
-          <a:noFill/>
-        </p:spPr>
-        <p:txBody>
-          <a:bodyPr wrap="square">
-            <a:spAutoFit/>
-          </a:bodyPr>
-          <a:lstStyle/>
-          <a:p>
-            <a:pPr algn="l"/>
-            <a:r>
-              <a:rPr sz="900" b="0">
+              <a:rPr sz="1000">
                 <a:solidFill>
                   <a:srgbClr val="6B7560"/>
                 </a:solidFill>
@@ -6185,7 +4253,7 @@
         <p:spPr>
           <a:xfrm>
             <a:off x="0" y="0"/>
-            <a:ext cx="12191695" cy="201168"/>
+            <a:ext cx="12191695" cy="182880"/>
           </a:xfrm>
           <a:prstGeom prst="rect">
             <a:avLst/>
@@ -6227,8 +4295,8 @@
         </p:nvSpPr>
         <p:spPr>
           <a:xfrm>
-            <a:off x="548640" y="502920"/>
-            <a:ext cx="11155680" cy="822960"/>
+            <a:off x="640080" y="685800"/>
+            <a:ext cx="10972800" cy="1097280"/>
           </a:xfrm>
           <a:prstGeom prst="rect">
             <a:avLst/>
@@ -6241,9 +4309,8 @@
           </a:bodyPr>
           <a:lstStyle/>
           <a:p>
-            <a:pPr algn="l"/>
-            <a:r>
-              <a:rPr sz="3200" b="1">
+            <a:r>
+              <a:rPr sz="3800" b="1">
                 <a:solidFill>
                   <a:srgbClr val="3F4A26"/>
                 </a:solidFill>
@@ -6256,59 +4323,14 @@
       </p:sp>
       <p:sp>
         <p:nvSpPr>
-          <p:cNvPr id="4" name="Rectangle 3"/>
-          <p:cNvSpPr/>
-          <p:nvPr/>
-        </p:nvSpPr>
-        <p:spPr>
-          <a:xfrm>
-            <a:off x="548640" y="1600200"/>
-            <a:ext cx="5029200" cy="2971800"/>
-          </a:xfrm>
-          <a:prstGeom prst="rect">
-            <a:avLst/>
-          </a:prstGeom>
-          <a:solidFill>
-            <a:srgbClr val="F2F5E9"/>
-          </a:solidFill>
-          <a:ln>
-            <a:solidFill>
-              <a:srgbClr val="D8DFCA"/>
-            </a:solidFill>
-          </a:ln>
-        </p:spPr>
-        <p:style>
-          <a:lnRef idx="1">
-            <a:schemeClr val="accent1"/>
-          </a:lnRef>
-          <a:fillRef idx="3">
-            <a:schemeClr val="accent1"/>
-          </a:fillRef>
-          <a:effectRef idx="2">
-            <a:schemeClr val="accent1"/>
-          </a:effectRef>
-          <a:fontRef idx="minor">
-            <a:schemeClr val="lt1"/>
-          </a:fontRef>
-        </p:style>
-        <p:txBody>
-          <a:bodyPr rtlCol="0" anchor="ctr"/>
-          <a:lstStyle/>
-          <a:p>
-            <a:pPr algn="ctr"/>
-          </a:p>
-        </p:txBody>
-      </p:sp>
-      <p:sp>
-        <p:nvSpPr>
-          <p:cNvPr id="5" name="TextBox 4"/>
+          <p:cNvPr id="4" name="TextBox 3"/>
           <p:cNvSpPr txBox="1"/>
           <p:nvPr/>
         </p:nvSpPr>
         <p:spPr>
           <a:xfrm>
-            <a:off x="777240" y="1755648"/>
-            <a:ext cx="4572000" cy="320040"/>
+            <a:off x="685800" y="2148840"/>
+            <a:ext cx="10789920" cy="3291840"/>
           </a:xfrm>
           <a:prstGeom prst="rect">
             <a:avLst/>
@@ -6321,29 +4343,51 @@
           </a:bodyPr>
           <a:lstStyle/>
           <a:p>
-            <a:pPr algn="l"/>
-            <a:r>
-              <a:rPr sz="1100" b="1">
-                <a:solidFill>
-                  <a:srgbClr val="6B7560"/>
+            <a:pPr>
+              <a:spcAft>
+                <a:spcPts val="1600"/>
+              </a:spcAft>
+            </a:pPr>
+            <a:r>
+              <a:rPr sz="2200" u="sng">
+                <a:solidFill>
+                  <a:srgbClr val="2F5B8A"/>
                 </a:solidFill>
                 <a:latin typeface="Arial"/>
+                <a:hlinkClick r:id="rId2"/>
               </a:rPr>
-              <a:t>ON SCREEN</a:t>
-            </a:r>
-          </a:p>
-        </p:txBody>
-      </p:sp>
-      <p:sp>
-        <p:nvSpPr>
-          <p:cNvPr id="6" name="TextBox 5"/>
+              <a:t>README - known limitations</a:t>
+            </a:r>
+          </a:p>
+          <a:p>
+            <a:pPr>
+              <a:spcAft>
+                <a:spcPts val="1600"/>
+              </a:spcAft>
+            </a:pPr>
+            <a:r>
+              <a:rPr sz="2200" u="sng">
+                <a:solidFill>
+                  <a:srgbClr val="2F5B8A"/>
+                </a:solidFill>
+                <a:latin typeface="Arial"/>
+                <a:hlinkClick r:id="rId3"/>
+              </a:rPr>
+              <a:t>Slide deck - roadmap</a:t>
+            </a:r>
+          </a:p>
+        </p:txBody>
+      </p:sp>
+      <p:sp>
+        <p:nvSpPr>
+          <p:cNvPr id="5" name="TextBox 4"/>
           <p:cNvSpPr txBox="1"/>
           <p:nvPr/>
         </p:nvSpPr>
         <p:spPr>
           <a:xfrm>
-            <a:off x="777240" y="2148840"/>
-            <a:ext cx="4572000" cy="2286000"/>
+            <a:off x="685800" y="6355080"/>
+            <a:ext cx="10789920" cy="320040"/>
           </a:xfrm>
           <a:prstGeom prst="rect">
             <a:avLst/>
@@ -6351,309 +4395,13 @@
           <a:noFill/>
         </p:spPr>
         <p:txBody>
-          <a:bodyPr wrap="square">
+          <a:bodyPr wrap="none">
             <a:spAutoFit/>
           </a:bodyPr>
           <a:lstStyle/>
           <a:p>
             <a:r>
-              <a:rPr sz="1600">
-                <a:solidFill>
-                  <a:srgbClr val="222A18"/>
-                </a:solidFill>
-                <a:latin typeface="Arial"/>
-              </a:rPr>
-              <a:t>· README, Known limitations</a:t>
-            </a:r>
-          </a:p>
-          <a:p>
-            <a:r>
-              <a:rPr sz="1600">
-                <a:solidFill>
-                  <a:srgbClr val="222A18"/>
-                </a:solidFill>
-                <a:latin typeface="Arial"/>
-              </a:rPr>
-              <a:t>· or the last slide of the deck</a:t>
-            </a:r>
-          </a:p>
-        </p:txBody>
-      </p:sp>
-      <p:sp>
-        <p:nvSpPr>
-          <p:cNvPr id="7" name="Rectangle 6"/>
-          <p:cNvSpPr/>
-          <p:nvPr/>
-        </p:nvSpPr>
-        <p:spPr>
-          <a:xfrm>
-            <a:off x="5897880" y="1600200"/>
-            <a:ext cx="5760720" cy="2971800"/>
-          </a:xfrm>
-          <a:prstGeom prst="rect">
-            <a:avLst/>
-          </a:prstGeom>
-          <a:solidFill>
-            <a:srgbClr val="FFFFFF"/>
-          </a:solidFill>
-          <a:ln>
-            <a:solidFill>
-              <a:srgbClr val="B7C98F"/>
-            </a:solidFill>
-          </a:ln>
-        </p:spPr>
-        <p:style>
-          <a:lnRef idx="1">
-            <a:schemeClr val="accent1"/>
-          </a:lnRef>
-          <a:fillRef idx="3">
-            <a:schemeClr val="accent1"/>
-          </a:fillRef>
-          <a:effectRef idx="2">
-            <a:schemeClr val="accent1"/>
-          </a:effectRef>
-          <a:fontRef idx="minor">
-            <a:schemeClr val="lt1"/>
-          </a:fontRef>
-        </p:style>
-        <p:txBody>
-          <a:bodyPr rtlCol="0" anchor="ctr"/>
-          <a:lstStyle/>
-          <a:p>
-            <a:pPr algn="ctr"/>
-          </a:p>
-        </p:txBody>
-      </p:sp>
-      <p:sp>
-        <p:nvSpPr>
-          <p:cNvPr id="8" name="TextBox 7"/>
-          <p:cNvSpPr txBox="1"/>
-          <p:nvPr/>
-        </p:nvSpPr>
-        <p:spPr>
-          <a:xfrm>
-            <a:off x="6126480" y="1755648"/>
-            <a:ext cx="5303520" cy="320040"/>
-          </a:xfrm>
-          <a:prstGeom prst="rect">
-            <a:avLst/>
-          </a:prstGeom>
-          <a:noFill/>
-        </p:spPr>
-        <p:txBody>
-          <a:bodyPr wrap="square">
-            <a:spAutoFit/>
-          </a:bodyPr>
-          <a:lstStyle/>
-          <a:p>
-            <a:pPr algn="l"/>
-            <a:r>
-              <a:rPr sz="1100" b="1">
-                <a:solidFill>
-                  <a:srgbClr val="5B7FA6"/>
-                </a:solidFill>
-                <a:latin typeface="Arial"/>
-              </a:rPr>
-              <a:t>SAY THIS</a:t>
-            </a:r>
-          </a:p>
-        </p:txBody>
-      </p:sp>
-      <p:sp>
-        <p:nvSpPr>
-          <p:cNvPr id="9" name="TextBox 8"/>
-          <p:cNvSpPr txBox="1"/>
-          <p:nvPr/>
-        </p:nvSpPr>
-        <p:spPr>
-          <a:xfrm>
-            <a:off x="6126480" y="2148840"/>
-            <a:ext cx="5303520" cy="2286000"/>
-          </a:xfrm>
-          <a:prstGeom prst="rect">
-            <a:avLst/>
-          </a:prstGeom>
-          <a:noFill/>
-        </p:spPr>
-        <p:txBody>
-          <a:bodyPr wrap="square">
-            <a:spAutoFit/>
-          </a:bodyPr>
-          <a:lstStyle/>
-          <a:p>
-            <a:r>
-              <a:rPr sz="1600" i="1">
-                <a:solidFill>
-                  <a:srgbClr val="222A18"/>
-                </a:solidFill>
-                <a:latin typeface="Arial"/>
-              </a:rPr>
-              <a:t>“Known limits: the occupation-to-skill mapping is our heuristic, one quarter is not a trend, course fees are unverified, and the parser misses synonyms. Next: verified course metadata, semantic CV parsing, and the user pilot. Everything planned is labelled as planned.”</a:t>
-            </a:r>
-          </a:p>
-        </p:txBody>
-      </p:sp>
-      <p:sp>
-        <p:nvSpPr>
-          <p:cNvPr id="10" name="TextBox 9"/>
-          <p:cNvSpPr txBox="1"/>
-          <p:nvPr/>
-        </p:nvSpPr>
-        <p:spPr>
-          <a:xfrm>
-            <a:off x="548640" y="4800600"/>
-            <a:ext cx="2743200" cy="274320"/>
-          </a:xfrm>
-          <a:prstGeom prst="rect">
-            <a:avLst/>
-          </a:prstGeom>
-          <a:noFill/>
-        </p:spPr>
-        <p:txBody>
-          <a:bodyPr wrap="square">
-            <a:spAutoFit/>
-          </a:bodyPr>
-          <a:lstStyle/>
-          <a:p>
-            <a:pPr algn="l"/>
-            <a:r>
-              <a:rPr sz="1000" b="1">
-                <a:solidFill>
-                  <a:srgbClr val="6B7560"/>
-                </a:solidFill>
-                <a:latin typeface="Arial"/>
-              </a:rPr>
-              <a:t>LINKS</a:t>
-            </a:r>
-          </a:p>
-        </p:txBody>
-      </p:sp>
-      <p:sp>
-        <p:nvSpPr>
-          <p:cNvPr id="11" name="TextBox 10"/>
-          <p:cNvSpPr txBox="1"/>
-          <p:nvPr/>
-        </p:nvSpPr>
-        <p:spPr>
-          <a:xfrm>
-            <a:off x="548640" y="5074920"/>
-            <a:ext cx="7589520" cy="1097280"/>
-          </a:xfrm>
-          <a:prstGeom prst="rect">
-            <a:avLst/>
-          </a:prstGeom>
-          <a:noFill/>
-        </p:spPr>
-        <p:txBody>
-          <a:bodyPr wrap="square">
-            <a:spAutoFit/>
-          </a:bodyPr>
-          <a:lstStyle/>
-          <a:p>
-            <a:r>
-              <a:rPr sz="1300">
-                <a:solidFill>
-                  <a:srgbClr val="5B7FA6"/>
-                </a:solidFill>
-                <a:latin typeface="Arial"/>
-                <a:hlinkClick r:id="rId2"/>
-              </a:rPr>
-              <a:t>README, limitations</a:t>
-            </a:r>
-          </a:p>
-          <a:p>
-            <a:r>
-              <a:rPr sz="1300">
-                <a:solidFill>
-                  <a:srgbClr val="5B7FA6"/>
-                </a:solidFill>
-                <a:latin typeface="Arial"/>
-                <a:hlinkClick r:id="rId3"/>
-              </a:rPr>
-              <a:t>Deck, roadmap</a:t>
-            </a:r>
-          </a:p>
-        </p:txBody>
-      </p:sp>
-      <p:sp>
-        <p:nvSpPr>
-          <p:cNvPr id="12" name="Rectangle 11"/>
-          <p:cNvSpPr/>
-          <p:nvPr/>
-        </p:nvSpPr>
-        <p:spPr>
-          <a:xfrm>
-            <a:off x="8366760" y="5029200"/>
-            <a:ext cx="3291840" cy="1051560"/>
-          </a:xfrm>
-          <a:prstGeom prst="rect">
-            <a:avLst/>
-          </a:prstGeom>
-          <a:solidFill>
-            <a:srgbClr val="FBF4E4"/>
-          </a:solidFill>
-          <a:ln>
-            <a:solidFill>
-              <a:srgbClr val="E6D3A8"/>
-            </a:solidFill>
-          </a:ln>
-        </p:spPr>
-        <p:style>
-          <a:lnRef idx="1">
-            <a:schemeClr val="accent1"/>
-          </a:lnRef>
-          <a:fillRef idx="3">
-            <a:schemeClr val="accent1"/>
-          </a:fillRef>
-          <a:effectRef idx="2">
-            <a:schemeClr val="accent1"/>
-          </a:effectRef>
-          <a:fontRef idx="minor">
-            <a:schemeClr val="lt1"/>
-          </a:fontRef>
-        </p:style>
-        <p:txBody>
-          <a:bodyPr rtlCol="0" anchor="ctr" wrap="square" lIns="109728"/>
-          <a:lstStyle/>
-          <a:p>
-            <a:pPr algn="ctr"/>
-            <a:r>
-              <a:rPr sz="1200">
-                <a:solidFill>
-                  <a:srgbClr val="7A5A1E"/>
-                </a:solidFill>
-                <a:latin typeface="Arial"/>
-              </a:rPr>
-              <a:t>Close on the product, not on the caveats.</a:t>
-            </a:r>
-          </a:p>
-        </p:txBody>
-      </p:sp>
-      <p:sp>
-        <p:nvSpPr>
-          <p:cNvPr id="13" name="TextBox 12"/>
-          <p:cNvSpPr txBox="1"/>
-          <p:nvPr/>
-        </p:nvSpPr>
-        <p:spPr>
-          <a:xfrm>
-            <a:off x="548640" y="6400800"/>
-            <a:ext cx="11155680" cy="274320"/>
-          </a:xfrm>
-          <a:prstGeom prst="rect">
-            <a:avLst/>
-          </a:prstGeom>
-          <a:noFill/>
-        </p:spPr>
-        <p:txBody>
-          <a:bodyPr wrap="square">
-            <a:spAutoFit/>
-          </a:bodyPr>
-          <a:lstStyle/>
-          <a:p>
-            <a:pPr algn="l"/>
-            <a:r>
-              <a:rPr sz="900" b="0">
+              <a:rPr sz="1000">
                 <a:solidFill>
                   <a:srgbClr val="6B7560"/>
                 </a:solidFill>

</xml_diff>

<commit_message>
docs: add readable data, tech and validation pages and point the cue deck at them
</commit_message>
<xml_diff>
--- a/team/CUE_DECK_4min10_to_6min.pptx
+++ b/team/CUE_DECK_4min10_to_6min.pptx
@@ -3179,8 +3179,8 @@
         </p:nvSpPr>
         <p:spPr>
           <a:xfrm>
-            <a:off x="685800" y="2148840"/>
-            <a:ext cx="10789920" cy="3291840"/>
+            <a:off x="685800" y="2240280"/>
+            <a:ext cx="10789920" cy="2926080"/>
           </a:xfrm>
           <a:prstGeom prst="rect">
             <a:avLst/>
@@ -3195,52 +3195,35 @@
           <a:p>
             <a:pPr>
               <a:spcAft>
-                <a:spcPts val="1600"/>
+                <a:spcPts val="1800"/>
               </a:spcAft>
             </a:pPr>
             <a:r>
-              <a:rPr sz="2200" u="sng">
+              <a:rPr sz="2400" u="sng">
                 <a:solidFill>
                   <a:srgbClr val="2F5B8A"/>
                 </a:solidFill>
                 <a:latin typeface="Arial"/>
                 <a:hlinkClick r:id="rId2"/>
               </a:rPr>
-              <a:t>README - data sources</a:t>
+              <a:t>Data sources explained</a:t>
             </a:r>
           </a:p>
           <a:p>
             <a:pPr>
               <a:spcAft>
-                <a:spcPts val="1600"/>
+                <a:spcPts val="1800"/>
               </a:spcAft>
             </a:pPr>
             <a:r>
-              <a:rPr sz="2200" u="sng">
+              <a:rPr sz="2400" u="sng">
                 <a:solidFill>
                   <a:srgbClr val="2F5B8A"/>
                 </a:solidFill>
                 <a:latin typeface="Arial"/>
                 <a:hlinkClick r:id="rId3"/>
               </a:rPr>
-              <a:t>dosm_q2_2026.json</a:t>
-            </a:r>
-          </a:p>
-          <a:p>
-            <a:pPr>
-              <a:spcAft>
-                <a:spcPts val="1600"/>
-              </a:spcAft>
-            </a:pPr>
-            <a:r>
-              <a:rPr sz="2200" u="sng">
-                <a:solidFill>
-                  <a:srgbClr val="2F5B8A"/>
-                </a:solidFill>
-                <a:latin typeface="Arial"/>
-                <a:hlinkClick r:id="rId4"/>
-              </a:rPr>
-              <a:t>wef_future_jobs_2025.json</a:t>
+              <a:t>The DOSM figures, row by row</a:t>
             </a:r>
           </a:p>
         </p:txBody>
@@ -3382,8 +3365,8 @@
         </p:nvSpPr>
         <p:spPr>
           <a:xfrm>
-            <a:off x="685800" y="2148840"/>
-            <a:ext cx="10789920" cy="3291840"/>
+            <a:off x="685800" y="2240280"/>
+            <a:ext cx="10789920" cy="2926080"/>
           </a:xfrm>
           <a:prstGeom prst="rect">
             <a:avLst/>
@@ -3398,52 +3381,35 @@
           <a:p>
             <a:pPr>
               <a:spcAft>
-                <a:spcPts val="1600"/>
+                <a:spcPts val="1800"/>
               </a:spcAft>
             </a:pPr>
             <a:r>
-              <a:rPr sz="2200" u="sng">
+              <a:rPr sz="2400" u="sng">
                 <a:solidFill>
                   <a:srgbClr val="2F5B8A"/>
                 </a:solidFill>
                 <a:latin typeface="Arial"/>
                 <a:hlinkClick r:id="rId2"/>
               </a:rPr>
-              <a:t>src/utils.py - scoring</a:t>
+              <a:t>How the score is built</a:t>
             </a:r>
           </a:p>
           <a:p>
             <a:pPr>
               <a:spcAft>
-                <a:spcPts val="1600"/>
+                <a:spcPts val="1800"/>
               </a:spcAft>
             </a:pPr>
             <a:r>
-              <a:rPr sz="2200" u="sng">
+              <a:rPr sz="2400" u="sng">
                 <a:solidFill>
                   <a:srgbClr val="2F5B8A"/>
                 </a:solidFill>
                 <a:latin typeface="Arial"/>
                 <a:hlinkClick r:id="rId3"/>
               </a:rPr>
-              <a:t>src/cv.py - parsing</a:t>
-            </a:r>
-          </a:p>
-          <a:p>
-            <a:pPr>
-              <a:spcAft>
-                <a:spcPts val="1600"/>
-              </a:spcAft>
-            </a:pPr>
-            <a:r>
-              <a:rPr sz="2200" u="sng">
-                <a:solidFill>
-                  <a:srgbClr val="2F5B8A"/>
-                </a:solidFill>
-                <a:latin typeface="Arial"/>
-                <a:hlinkClick r:id="rId4"/>
-              </a:rPr>
-              <a:t>src/trends.py</a:t>
+              <a:t>AI tools used in development</a:t>
             </a:r>
           </a:p>
         </p:txBody>
@@ -3585,8 +3551,8 @@
         </p:nvSpPr>
         <p:spPr>
           <a:xfrm>
-            <a:off x="685800" y="2148840"/>
-            <a:ext cx="10789920" cy="3291840"/>
+            <a:off x="685800" y="2240280"/>
+            <a:ext cx="10789920" cy="2926080"/>
           </a:xfrm>
           <a:prstGeom prst="rect">
             <a:avLst/>
@@ -3601,35 +3567,35 @@
           <a:p>
             <a:pPr>
               <a:spcAft>
-                <a:spcPts val="1600"/>
+                <a:spcPts val="1800"/>
               </a:spcAft>
             </a:pPr>
             <a:r>
-              <a:rPr sz="2200" u="sng">
+              <a:rPr sz="2400" u="sng">
                 <a:solidFill>
                   <a:srgbClr val="2F5B8A"/>
                 </a:solidFill>
                 <a:latin typeface="Arial"/>
                 <a:hlinkClick r:id="rId2"/>
               </a:rPr>
-              <a:t>tests folder (54 tests)</a:t>
+              <a:t>Validation and test evidence</a:t>
             </a:r>
           </a:p>
           <a:p>
             <a:pPr>
               <a:spcAft>
-                <a:spcPts val="1600"/>
+                <a:spcPts val="1800"/>
               </a:spcAft>
             </a:pPr>
             <a:r>
-              <a:rPr sz="2200" u="sng">
+              <a:rPr sz="2400" u="sng">
                 <a:solidFill>
                   <a:srgbClr val="2F5B8A"/>
                 </a:solidFill>
                 <a:latin typeface="Arial"/>
                 <a:hlinkClick r:id="rId3"/>
               </a:rPr>
-              <a:t>Technical Declaration 4.3</a:t>
+              <a:t>Technical Declaration, signed</a:t>
             </a:r>
           </a:p>
         </p:txBody>
@@ -3771,8 +3737,8 @@
         </p:nvSpPr>
         <p:spPr>
           <a:xfrm>
-            <a:off x="685800" y="2148840"/>
-            <a:ext cx="10789920" cy="3291840"/>
+            <a:off x="685800" y="2240280"/>
+            <a:ext cx="10789920" cy="2926080"/>
           </a:xfrm>
           <a:prstGeom prst="rect">
             <a:avLst/>
@@ -3787,35 +3753,35 @@
           <a:p>
             <a:pPr>
               <a:spcAft>
-                <a:spcPts val="1600"/>
+                <a:spcPts val="1800"/>
               </a:spcAft>
             </a:pPr>
             <a:r>
-              <a:rPr sz="2200" u="sng">
+              <a:rPr sz="2400" u="sng">
                 <a:solidFill>
                   <a:srgbClr val="2F5B8A"/>
                 </a:solidFill>
                 <a:latin typeface="Arial"/>
                 <a:hlinkClick r:id="rId2"/>
               </a:rPr>
-              <a:t>REPLIT PROOF OF USE.pdf</a:t>
+              <a:t>Replit proof of use</a:t>
             </a:r>
           </a:p>
           <a:p>
             <a:pPr>
               <a:spcAft>
-                <a:spcPts val="1600"/>
+                <a:spcPts val="1800"/>
               </a:spcAft>
             </a:pPr>
             <a:r>
-              <a:rPr sz="2200" u="sng">
+              <a:rPr sz="2400" u="sng">
                 <a:solidFill>
                   <a:srgbClr val="2F5B8A"/>
                 </a:solidFill>
                 <a:latin typeface="Arial"/>
                 <a:hlinkClick r:id="rId3"/>
               </a:rPr>
-              <a:t>Technical Declaration</a:t>
+              <a:t>Technical Declaration, section 3</a:t>
             </a:r>
           </a:p>
         </p:txBody>
@@ -3957,8 +3923,8 @@
         </p:nvSpPr>
         <p:spPr>
           <a:xfrm>
-            <a:off x="685800" y="2148840"/>
-            <a:ext cx="10789920" cy="3291840"/>
+            <a:off x="685800" y="2240280"/>
+            <a:ext cx="10789920" cy="2926080"/>
           </a:xfrm>
           <a:prstGeom prst="rect">
             <a:avLst/>
@@ -3973,35 +3939,35 @@
           <a:p>
             <a:pPr>
               <a:spcAft>
-                <a:spcPts val="1600"/>
+                <a:spcPts val="1800"/>
               </a:spcAft>
             </a:pPr>
             <a:r>
-              <a:rPr sz="2200" u="sng">
+              <a:rPr sz="2400" u="sng">
                 <a:solidFill>
                   <a:srgbClr val="2F5B8A"/>
                 </a:solidFill>
                 <a:latin typeface="Arial"/>
                 <a:hlinkClick r:id="rId2"/>
               </a:rPr>
-              <a:t>data/skills_sdg.json - 54 skills</a:t>
+              <a:t>SDG mapping and what it means</a:t>
             </a:r>
           </a:p>
           <a:p>
             <a:pPr>
               <a:spcAft>
-                <a:spcPts val="1600"/>
+                <a:spcPts val="1800"/>
               </a:spcAft>
             </a:pPr>
             <a:r>
-              <a:rPr sz="2200" u="sng">
+              <a:rPr sz="2400" u="sng">
                 <a:solidFill>
                   <a:srgbClr val="2F5B8A"/>
                 </a:solidFill>
                 <a:latin typeface="Arial"/>
                 <a:hlinkClick r:id="rId3"/>
               </a:rPr>
-              <a:t>README - SDG row</a:t>
+              <a:t>The 54-skill crosswalk</a:t>
             </a:r>
           </a:p>
         </p:txBody>
@@ -4143,8 +4109,8 @@
         </p:nvSpPr>
         <p:spPr>
           <a:xfrm>
-            <a:off x="685800" y="2148840"/>
-            <a:ext cx="10789920" cy="3291840"/>
+            <a:off x="685800" y="2240280"/>
+            <a:ext cx="10789920" cy="2926080"/>
           </a:xfrm>
           <a:prstGeom prst="rect">
             <a:avLst/>
@@ -4159,35 +4125,35 @@
           <a:p>
             <a:pPr>
               <a:spcAft>
-                <a:spcPts val="1600"/>
+                <a:spcPts val="1800"/>
               </a:spcAft>
             </a:pPr>
             <a:r>
-              <a:rPr sz="2200" u="sng">
+              <a:rPr sz="2400" u="sng">
                 <a:solidFill>
                   <a:srgbClr val="2F5B8A"/>
                 </a:solidFill>
                 <a:latin typeface="Arial"/>
                 <a:hlinkClick r:id="rId2"/>
               </a:rPr>
-              <a:t>data/courses.json - 60 links</a:t>
+              <a:t>What was tested, what was not</a:t>
             </a:r>
           </a:p>
           <a:p>
             <a:pPr>
               <a:spcAft>
-                <a:spcPts val="1600"/>
+                <a:spcPts val="1800"/>
               </a:spcAft>
             </a:pPr>
             <a:r>
-              <a:rPr sz="2200" u="sng">
+              <a:rPr sz="2400" u="sng">
                 <a:solidFill>
                   <a:srgbClr val="2F5B8A"/>
                 </a:solidFill>
                 <a:latin typeface="Arial"/>
                 <a:hlinkClick r:id="rId3"/>
               </a:rPr>
-              <a:t>data/sample_cv.txt - synthetic</a:t>
+              <a:t>The course catalogue, all 54 skills</a:t>
             </a:r>
           </a:p>
         </p:txBody>
@@ -4329,8 +4295,8 @@
         </p:nvSpPr>
         <p:spPr>
           <a:xfrm>
-            <a:off x="685800" y="2148840"/>
-            <a:ext cx="10789920" cy="3291840"/>
+            <a:off x="685800" y="2240280"/>
+            <a:ext cx="10789920" cy="2926080"/>
           </a:xfrm>
           <a:prstGeom prst="rect">
             <a:avLst/>
@@ -4345,35 +4311,35 @@
           <a:p>
             <a:pPr>
               <a:spcAft>
-                <a:spcPts val="1600"/>
+                <a:spcPts val="1800"/>
               </a:spcAft>
             </a:pPr>
             <a:r>
-              <a:rPr sz="2200" u="sng">
+              <a:rPr sz="2400" u="sng">
                 <a:solidFill>
                   <a:srgbClr val="2F5B8A"/>
                 </a:solidFill>
                 <a:latin typeface="Arial"/>
                 <a:hlinkClick r:id="rId2"/>
               </a:rPr>
-              <a:t>README - known limitations</a:t>
+              <a:t>Known limits</a:t>
             </a:r>
           </a:p>
           <a:p>
             <a:pPr>
               <a:spcAft>
-                <a:spcPts val="1600"/>
+                <a:spcPts val="1800"/>
               </a:spcAft>
             </a:pPr>
             <a:r>
-              <a:rPr sz="2200" u="sng">
+              <a:rPr sz="2400" u="sng">
                 <a:solidFill>
                   <a:srgbClr val="2F5B8A"/>
                 </a:solidFill>
                 <a:latin typeface="Arial"/>
                 <a:hlinkClick r:id="rId3"/>
               </a:rPr>
-              <a:t>Slide deck - roadmap</a:t>
+              <a:t>Roadmap in the deck</a:t>
             </a:r>
           </a:p>
         </p:txBody>

</xml_diff>

<commit_message>
docs(team): one destination per link, plus a dedicated SDG page
</commit_message>
<xml_diff>
--- a/team/CUE_DECK_4min10_to_6min.pptx
+++ b/team/CUE_DECK_4min10_to_6min.pptx
@@ -3209,23 +3209,6 @@
               <a:t>Data sources explained</a:t>
             </a:r>
           </a:p>
-          <a:p>
-            <a:pPr>
-              <a:spcAft>
-                <a:spcPts val="1800"/>
-              </a:spcAft>
-            </a:pPr>
-            <a:r>
-              <a:rPr sz="2400" u="sng">
-                <a:solidFill>
-                  <a:srgbClr val="2F5B8A"/>
-                </a:solidFill>
-                <a:latin typeface="Arial"/>
-                <a:hlinkClick r:id="rId3"/>
-              </a:rPr>
-              <a:t>The DOSM figures, row by row</a:t>
-            </a:r>
-          </a:p>
         </p:txBody>
       </p:sp>
       <p:sp>
@@ -3395,23 +3378,6 @@
               <a:t>How the score is built</a:t>
             </a:r>
           </a:p>
-          <a:p>
-            <a:pPr>
-              <a:spcAft>
-                <a:spcPts val="1800"/>
-              </a:spcAft>
-            </a:pPr>
-            <a:r>
-              <a:rPr sz="2400" u="sng">
-                <a:solidFill>
-                  <a:srgbClr val="2F5B8A"/>
-                </a:solidFill>
-                <a:latin typeface="Arial"/>
-                <a:hlinkClick r:id="rId3"/>
-              </a:rPr>
-              <a:t>AI tools used in development</a:t>
-            </a:r>
-          </a:p>
         </p:txBody>
       </p:sp>
       <p:sp>
@@ -3781,7 +3747,7 @@
                 <a:latin typeface="Arial"/>
                 <a:hlinkClick r:id="rId3"/>
               </a:rPr>
-              <a:t>Technical Declaration, section 3</a:t>
+              <a:t>Technical Declaration, signed</a:t>
             </a:r>
           </a:p>
         </p:txBody>
@@ -3950,7 +3916,7 @@
                 <a:latin typeface="Arial"/>
                 <a:hlinkClick r:id="rId2"/>
               </a:rPr>
-              <a:t>SDG mapping and what it means</a:t>
+              <a:t>SDG mapping and why 4.4</a:t>
             </a:r>
           </a:p>
           <a:p>

</xml_diff>

<commit_message>
docs(team): one readable destination per slide, add the course catalogue page
</commit_message>
<xml_diff>
--- a/team/CUE_DECK_4min10_to_6min.pptx
+++ b/team/CUE_DECK_4min10_to_6min.pptx
@@ -3544,23 +3544,6 @@
                 <a:latin typeface="Arial"/>
                 <a:hlinkClick r:id="rId2"/>
               </a:rPr>
-              <a:t>Validation and test evidence</a:t>
-            </a:r>
-          </a:p>
-          <a:p>
-            <a:pPr>
-              <a:spcAft>
-                <a:spcPts val="1800"/>
-              </a:spcAft>
-            </a:pPr>
-            <a:r>
-              <a:rPr sz="2400" u="sng">
-                <a:solidFill>
-                  <a:srgbClr val="2F5B8A"/>
-                </a:solidFill>
-                <a:latin typeface="Arial"/>
-                <a:hlinkClick r:id="rId3"/>
-              </a:rPr>
               <a:t>Technical Declaration, signed</a:t>
             </a:r>
           </a:p>
@@ -3733,23 +3716,6 @@
               <a:t>Replit proof of use</a:t>
             </a:r>
           </a:p>
-          <a:p>
-            <a:pPr>
-              <a:spcAft>
-                <a:spcPts val="1800"/>
-              </a:spcAft>
-            </a:pPr>
-            <a:r>
-              <a:rPr sz="2400" u="sng">
-                <a:solidFill>
-                  <a:srgbClr val="2F5B8A"/>
-                </a:solidFill>
-                <a:latin typeface="Arial"/>
-                <a:hlinkClick r:id="rId3"/>
-              </a:rPr>
-              <a:t>Technical Declaration, signed</a:t>
-            </a:r>
-          </a:p>
         </p:txBody>
       </p:sp>
       <p:sp>
@@ -3919,23 +3885,6 @@
               <a:t>SDG mapping and why 4.4</a:t>
             </a:r>
           </a:p>
-          <a:p>
-            <a:pPr>
-              <a:spcAft>
-                <a:spcPts val="1800"/>
-              </a:spcAft>
-            </a:pPr>
-            <a:r>
-              <a:rPr sz="2400" u="sng">
-                <a:solidFill>
-                  <a:srgbClr val="2F5B8A"/>
-                </a:solidFill>
-                <a:latin typeface="Arial"/>
-                <a:hlinkClick r:id="rId3"/>
-              </a:rPr>
-              <a:t>The 54-skill crosswalk</a:t>
-            </a:r>
-          </a:p>
         </p:txBody>
       </p:sp>
       <p:sp>
@@ -4102,24 +4051,7 @@
                 <a:latin typeface="Arial"/>
                 <a:hlinkClick r:id="rId2"/>
               </a:rPr>
-              <a:t>What was tested, what was not</a:t>
-            </a:r>
-          </a:p>
-          <a:p>
-            <a:pPr>
-              <a:spcAft>
-                <a:spcPts val="1800"/>
-              </a:spcAft>
-            </a:pPr>
-            <a:r>
-              <a:rPr sz="2400" u="sng">
-                <a:solidFill>
-                  <a:srgbClr val="2F5B8A"/>
-                </a:solidFill>
-                <a:latin typeface="Arial"/>
-                <a:hlinkClick r:id="rId3"/>
-              </a:rPr>
-              <a:t>The course catalogue, all 54 skills</a:t>
+              <a:t>The course catalogue</a:t>
             </a:r>
           </a:p>
         </p:txBody>
@@ -4288,24 +4220,7 @@
                 <a:latin typeface="Arial"/>
                 <a:hlinkClick r:id="rId2"/>
               </a:rPr>
-              <a:t>Known limits</a:t>
-            </a:r>
-          </a:p>
-          <a:p>
-            <a:pPr>
-              <a:spcAft>
-                <a:spcPts val="1800"/>
-              </a:spcAft>
-            </a:pPr>
-            <a:r>
-              <a:rPr sz="2400" u="sng">
-                <a:solidFill>
-                  <a:srgbClr val="2F5B8A"/>
-                </a:solidFill>
-                <a:latin typeface="Arial"/>
-                <a:hlinkClick r:id="rId3"/>
-              </a:rPr>
-              <a:t>Roadmap in the deck</a:t>
+              <a:t>What was tested, what was not</a:t>
             </a:r>
           </a:p>
         </p:txBody>

</xml_diff>